<commit_message>
Finalize the pitch template after the advisor's deck review
Show the power-price result on the pick-change slide, qualify the
three-county tie as at today's prices, add a cockpit screenshot to the
engine slide, add a structural checker, fix footer and overflow issues
found in the renders, and write the morning summary and PR text in the
build log.
</commit_message>
<xml_diff>
--- a/docs/deck/pitch_template.pptx
+++ b/docs/deck/pitch_template.pptx
@@ -1616,9 +1616,9 @@
           </c:dLbls>
           <c:cat>
             <c:strRef>
-              <c:f>Sheet1!$A$2:$A$4</c:f>
+              <c:f>Sheet1!$A$2:$A$5</c:f>
               <c:strCache>
-                <c:ptCount val="3"/>
+                <c:ptCount val="4"/>
                 <c:pt idx="0">
                   <c:v>Seven pillars</c:v>
                 </c:pt>
@@ -1628,15 +1628,18 @@
                 <c:pt idx="2">
                   <c:v>Cost as a pillar</c:v>
                 </c:pt>
+                <c:pt idx="3">
+                  <c:v>What if WA pays $80/MWh</c:v>
+                </c:pt>
               </c:strCache>
             </c:strRef>
           </c:cat>
           <c:val>
             <c:numRef>
-              <c:f>Sheet1!$B$2:$B$4</c:f>
+              <c:f>Sheet1!$B$2:$B$5</c:f>
               <c:numCache>
                 <c:formatCode>General</c:formatCode>
-                <c:ptCount val="3"/>
+                <c:ptCount val="4"/>
                 <c:pt idx="0">
                   <c:v>1</c:v>
                 </c:pt>
@@ -1768,6 +1771,33 @@
               <c:showPercent val="0"/>
               <c:showBubbleSize val="0"/>
             </c:dLbl>
+            <c:dLbl>
+              <c:idx val="3"/>
+              <c:tx>
+                <c:rich>
+                  <a:bodyPr/>
+                  <a:lstStyle/>
+                  <a:p>
+                    <a:r>
+                      <a:rPr sz="1700" b="1" i="0">
+                        <a:solidFill>
+                          <a:srgbClr val="0B3C6F"/>
+                        </a:solidFill>
+                        <a:latin typeface="Arial"/>
+                      </a:rPr>
+                      <a:t>#79</a:t>
+                    </a:r>
+                  </a:p>
+                </c:rich>
+              </c:tx>
+              <c:dLblPos val="r"/>
+              <c:showLegendKey val="0"/>
+              <c:showVal val="1"/>
+              <c:showCatName val="0"/>
+              <c:showSerName val="0"/>
+              <c:showPercent val="0"/>
+              <c:showBubbleSize val="0"/>
+            </c:dLbl>
             <c:showLegendKey val="0"/>
             <c:showVal val="0"/>
             <c:showCatName val="0"/>
@@ -1778,9 +1808,9 @@
           </c:dLbls>
           <c:cat>
             <c:strRef>
-              <c:f>Sheet1!$A$2:$A$4</c:f>
+              <c:f>Sheet1!$A$2:$A$5</c:f>
               <c:strCache>
-                <c:ptCount val="3"/>
+                <c:ptCount val="4"/>
                 <c:pt idx="0">
                   <c:v>Seven pillars</c:v>
                 </c:pt>
@@ -1790,15 +1820,18 @@
                 <c:pt idx="2">
                   <c:v>Cost as a pillar</c:v>
                 </c:pt>
+                <c:pt idx="3">
+                  <c:v>What if WA pays $80/MWh</c:v>
+                </c:pt>
               </c:strCache>
             </c:strRef>
           </c:cat>
           <c:val>
             <c:numRef>
-              <c:f>Sheet1!$C$2:$C$4</c:f>
+              <c:f>Sheet1!$C$2:$C$5</c:f>
               <c:numCache>
                 <c:formatCode>General</c:formatCode>
-                <c:ptCount val="3"/>
+                <c:ptCount val="4"/>
                 <c:pt idx="0">
                   <c:v>7</c:v>
                 </c:pt>
@@ -1807,6 +1840,9 @@
                 </c:pt>
                 <c:pt idx="2">
                   <c:v>1</c:v>
+                </c:pt>
+                <c:pt idx="3">
+                  <c:v>25</c:v>
                 </c:pt>
               </c:numCache>
             </c:numRef>
@@ -2257,7 +2293,7 @@
             <a:lstStyle/>
             <a:p>
               <a:pPr>
-                <a:defRPr sz="1700" b="1">
+                <a:defRPr sz="1800" b="1">
                   <a:solidFill>
                     <a:srgbClr val="111518"/>
                   </a:solidFill>
@@ -2274,7 +2310,7 @@
           <c:showBubbleSize val="0"/>
           <c:showLeaderLines val="1"/>
         </c:dLbls>
-        <c:gapWidth val="35"/>
+        <c:gapWidth val="45"/>
         <c:axId val="-2068027336"/>
         <c:axId val="-2113994440"/>
       </c:barChart>
@@ -2300,7 +2336,7 @@
           <a:lstStyle/>
           <a:p>
             <a:pPr>
-              <a:defRPr sz="1500">
+              <a:defRPr sz="1600">
                 <a:solidFill>
                   <a:srgbClr val="111518"/>
                 </a:solidFill>
@@ -2337,7 +2373,7 @@
     <a:lstStyle/>
     <a:p>
       <a:pPr>
-        <a:defRPr sz="1500">
+        <a:defRPr sz="1600">
           <a:solidFill>
             <a:srgbClr val="46505A"/>
           </a:solidFill>
@@ -2382,7 +2418,7 @@
     <c:autoTitleDeleted val="0"/>
     <c:plotArea>
       <c:barChart>
-        <c:barDir val="bar"/>
+        <c:barDir val="col"/>
         <c:grouping val="clustered"/>
         <c:varyColors val="0"/>
         <c:ser>
@@ -2424,7 +2460,7 @@
                   <c:v>Dry cooling</c:v>
                 </c:pt>
                 <c:pt idx="1">
-                  <c:v>Evaporative cooling</c:v>
+                  <c:v>Evaporative</c:v>
                 </c:pt>
               </c:strCache>
             </c:strRef>
@@ -2469,17 +2505,17 @@
           <c:showBubbleSize val="0"/>
           <c:showLeaderLines val="1"/>
         </c:dLbls>
-        <c:gapWidth val="45"/>
+        <c:gapWidth val="70"/>
         <c:axId val="-2068027336"/>
         <c:axId val="-2113994440"/>
       </c:barChart>
       <c:catAx>
         <c:axId val="-2068027336"/>
         <c:scaling>
-          <c:orientation val="maxMin"/>
+          <c:orientation val="minMax"/>
         </c:scaling>
         <c:delete val="0"/>
-        <c:axPos val="l"/>
+        <c:axPos val="b"/>
         <c:majorTickMark val="none"/>
         <c:minorTickMark val="none"/>
         <c:tickLblPos val="nextTo"/>
@@ -2495,7 +2531,7 @@
           <a:lstStyle/>
           <a:p>
             <a:pPr>
-              <a:defRPr sz="1700">
+              <a:defRPr sz="1600">
                 <a:solidFill>
                   <a:srgbClr val="111518"/>
                 </a:solidFill>
@@ -2513,11 +2549,11 @@
       <c:valAx>
         <c:axId val="-2113994440"/>
         <c:scaling>
-          <c:max val="2000.0"/>
+          <c:max val="2100.0"/>
           <c:min val="0.0"/>
         </c:scaling>
         <c:delete/>
-        <c:axPos val="b"/>
+        <c:axPos val="l"/>
         <c:majorTickMark val="out"/>
         <c:minorTickMark val="none"/>
         <c:tickLblPos val="nextTo"/>
@@ -2532,7 +2568,7 @@
     <a:lstStyle/>
     <a:p>
       <a:pPr>
-        <a:defRPr sz="1700">
+        <a:defRPr sz="1600">
           <a:solidFill>
             <a:srgbClr val="46505A"/>
           </a:solidFill>
@@ -4226,12 +4262,12 @@
           </a:p>
           <a:p>
             <a:r>
-              <a:t>more than any other county. In 25-year dollars it ties Clark, Washington and Franklin, New</a:t>
-            </a:r>
-          </a:p>
-          <a:p>
-            <a:r>
-              <a:t>York; we feature Grant because its power timeline and tax status are sourced. The condition:</a:t>
+              <a:t>more than any other county. At today's prices its 25-year cost ties Clark, Washington and</a:t>
+            </a:r>
+          </a:p>
+          <a:p>
+            <a:r>
+              <a:t>Franklin, New York; we feature Grant because its power timeline and tax status are sourced. The condition:</a:t>
             </a:r>
           </a:p>
           <a:p>
@@ -4514,7 +4550,7 @@
           </a:p>
           <a:p>
             <a:r>
-              <a:t>thousand. State law then requires the utility's power to be fully clean by 2045.</a:t>
+              <a:t>thousand. Then Washington law requires fully clean retail power by 2045.</a:t>
             </a:r>
           </a:p>
           <a:p/>
@@ -4551,6 +4587,21 @@
           <a:p>
             <a:r>
               <a:t>  alternative compliance) and 100% renewable or non-emitting by 2045 (RCW 19.405.040, .050).</a:t>
+            </a:r>
+          </a:p>
+          <a:p>
+            <a:r>
+              <a:t>- Isn't 2045 an edge over Loudoun? No. Virginia's Clean Economy Act (2020) also sets a 2045</a:t>
+            </a:r>
+          </a:p>
+          <a:p>
+            <a:r>
+              <a:t>  carbon-free target for Dominion, which serves Loudoun (not verified for this deck). Our edge</a:t>
+            </a:r>
+          </a:p>
+          <a:p>
+            <a:r>
+              <a:t>  is the supply we fund, not the statute.</a:t>
             </a:r>
           </a:p>
           <a:p/>
@@ -4692,38 +4743,53 @@
           </a:p>
           <a:p>
             <a:r>
-              <a:t>We didn't start at Grant. With seven pillars, Berkshire County, Massachusetts ranked first</a:t>
-            </a:r>
-          </a:p>
-          <a:p>
-            <a:r>
-              <a:t>and Grant seventh. Massachusetts closed the tax exemption Berkshire relied on, and it fell</a:t>
-            </a:r>
-          </a:p>
-          <a:p>
-            <a:r>
-              <a:t>to fifth. Then we made power cost its own pillar. Grant</a:t>
-            </a:r>
-          </a:p>
-          <a:p>
-            <a:r>
-              <a:t>rose to first, and Berkshire fell to 1,047th. The last correction cut</a:t>
-            </a:r>
-          </a:p>
-          <a:p>
-            <a:r>
-              <a:t>against us. A new 300 megawatt load doesn't get today's average price, so Grant's bill is 196</a:t>
-            </a:r>
-          </a:p>
-          <a:p>
-            <a:r>
-              <a:t>to 323 million dollars a year, not 162. And we dropped a permitting model that failed out of sample.</a:t>
+              <a:t>With seven pillars, Berkshire County, Massachusetts ranked first and Grant seventh.</a:t>
+            </a:r>
+          </a:p>
+          <a:p>
+            <a:r>
+              <a:t>Massachusetts closed the tax exemption Berkshire relied on, and it fell to fifth. Then we</a:t>
+            </a:r>
+          </a:p>
+          <a:p>
+            <a:r>
+              <a:t>made power cost its own pillar, and Grant rose to first. The last check cut against us. A new</a:t>
+            </a:r>
+          </a:p>
+          <a:p>
+            <a:r>
+              <a:t>300 megawatt load doesn't get today's average price. Reprice only Washington at BPA's</a:t>
+            </a:r>
+          </a:p>
+          <a:p>
+            <a:r>
+              <a:t>new-load rate, and Grant falls to 79th. No other state's new-load rate is sourced,</a:t>
+            </a:r>
+          </a:p>
+          <a:p>
+            <a:r>
+              <a:t>so that's lopsided, but it's real. We also dropped a permitting model that failed out of sample.</a:t>
             </a:r>
           </a:p>
           <a:p/>
           <a:p>
             <a:r>
-              <a:t>IF ASKED: why doesn't Grant get cheap hydro? BPA's rule for a new large single load: "…the customer must serve that load, and any increases to it, with either power from Bonneville at the NR rate or a dedicated nonfederal resource."</a:t>
+              <a:t>IF ASKED:</a:t>
+            </a:r>
+          </a:p>
+          <a:p>
+            <a:r>
+              <a:t>- The bill: at BPA's $80 to $132/MWh, Grant's energy costs $196M to $323M a year, not $162M.</a:t>
+            </a:r>
+          </a:p>
+          <a:p>
+            <a:r>
+              <a:t>  At $132/MWh, with only Washington repriced, Grant falls to 1,146th.</a:t>
+            </a:r>
+          </a:p>
+          <a:p>
+            <a:r>
+              <a:t>- Why doesn't Grant get cheap hydro? BPA's rule for a new large single load: "…the customer must serve that load, and any increases to it, with either power from Bonneville at the NR rate or a dedicated nonfederal resource."</a:t>
             </a:r>
           </a:p>
           <a:p>
@@ -4760,6 +4826,11 @@
           <a:p>
             <a:r>
               <a:t>- Permitting model AUC without facility counts: 0.48 to 0.585 (bar 0.60) [[CHECK]]. Source: research/permitting_model.md; data/processed/permitting_validation.json</a:t>
+            </a:r>
+          </a:p>
+          <a:p>
+            <a:r>
+              <a:t>- Grant rank with only WA at BPA's $80 / $132 per MWh: 79 / 1,146 [[CHECK]]. Source: docs/deck_build_log.md, field step 1, price sensitivity (scratchpad rerun of the balanced preset)</a:t>
             </a:r>
           </a:p>
         </p:txBody>
@@ -4834,32 +4905,32 @@
           </a:p>
           <a:p>
             <a:r>
-              <a:t>The obvious question: did we pick weights that make Grant win? So we stopped choosing. We</a:t>
-            </a:r>
-          </a:p>
-          <a:p>
-            <a:r>
-              <a:t>drew 5,000 random weightings of the eight pillars and counted how often each county makes</a:t>
-            </a:r>
-          </a:p>
-          <a:p>
-            <a:r>
-              <a:t>the top 10. Grant does in 50.5% of them, more than any</a:t>
-            </a:r>
-          </a:p>
-          <a:p>
-            <a:r>
-              <a:t>other county. No county wins most weightings; the top three each come first in 11 to 13</a:t>
-            </a:r>
-          </a:p>
-          <a:p>
-            <a:r>
-              <a:t>percent. Near our own weights, Grant stays in the top 10 in 99.9%.</a:t>
-            </a:r>
-          </a:p>
-          <a:p>
-            <a:r>
-              <a:t>We didn't tune the weights to get our answer. We tested whether our answer depends on them.</a:t>
+              <a:t>Did we pick weights that make Grant win? We stopped choosing. We drew 5,000 random</a:t>
+            </a:r>
+          </a:p>
+          <a:p>
+            <a:r>
+              <a:t>weightings of the eight pillars and counted how often each county makes the top 10. Grant</a:t>
+            </a:r>
+          </a:p>
+          <a:p>
+            <a:r>
+              <a:t>does in 50.5% of them, more than any other county. No county</a:t>
+            </a:r>
+          </a:p>
+          <a:p>
+            <a:r>
+              <a:t>wins most weightings; the top three each come first in 11 to 13 percent. We didn't tune the</a:t>
+            </a:r>
+          </a:p>
+          <a:p>
+            <a:r>
+              <a:t>weights to get our answer. We tested whether our answer depends on them. It's robust to</a:t>
+            </a:r>
+          </a:p>
+          <a:p>
+            <a:r>
+              <a:t>weights. It isn't robust to price, which brings us to the risk.</a:t>
             </a:r>
           </a:p>
           <a:p/>
@@ -5000,27 +5071,27 @@
           </a:p>
           <a:p>
             <a:r>
-              <a:t>279, and about 800 megawatts are queued ahead of us. So we</a:t>
-            </a:r>
-          </a:p>
-          <a:p>
-            <a:r>
-              <a:t>fund new supply and phase in behind the 2027 and 2029 transmission lines. Timing is the win</a:t>
-            </a:r>
-          </a:p>
-          <a:p>
-            <a:r>
-              <a:t>condition: in 25-year dollars Grant ties Clark and Franklin, and each month of delay costs</a:t>
-            </a:r>
-          </a:p>
-          <a:p>
-            <a:r>
-              <a:t>about 25 million dollars. Heat is a medium risk. Protected land and tribal sites are low,</a:t>
-            </a:r>
-          </a:p>
-          <a:p>
-            <a:r>
-              <a:t>checked by hand, with early consultation.</a:t>
+              <a:t>279, and about 800 megawatts are queued ahead of us. So we fund new</a:t>
+            </a:r>
+          </a:p>
+          <a:p>
+            <a:r>
+              <a:t>supply and phase in behind the 2027 and 2029 transmission lines. That's the win condition:</a:t>
+            </a:r>
+          </a:p>
+          <a:p>
+            <a:r>
+              <a:t>full power by about late 2029, near today's price. Later or pricier, Clark or Franklin costs</a:t>
+            </a:r>
+          </a:p>
+          <a:p>
+            <a:r>
+              <a:t>less. Heat is a medium risk. We consult tribes early, and no protected land sits within</a:t>
+            </a:r>
+          </a:p>
+          <a:p>
+            <a:r>
+              <a:t>5 kilometers of Quincy.</a:t>
             </a:r>
           </a:p>
           <a:p/>
@@ -5031,6 +5102,56 @@
           </a:p>
           <a:p>
             <a:r>
+              <a:t>- Timing math: each month of delay is priced at $25M, an assumption (docs/weighting.md). Grant</a:t>
+            </a:r>
+          </a:p>
+          <a:p>
+            <a:r>
+              <a:t>  breaks even with Clark at 10.2 months and Franklin at 12.1 months past a 2-year baseline from</a:t>
+            </a:r>
+          </a:p>
+          <a:p>
+            <a:r>
+              <a:t>  October 2026; its evidence-based estimate is 12 months (8 to 18.5).</a:t>
+            </a:r>
+          </a:p>
+          <a:p>
+            <a:r>
+              <a:t>- The utility's own words (verified): "…service cannot always be provided as quickly as customers or developers may prefer." Grant County PUD, Data Center FAQs, Aug. 28, 2026.</a:t>
+            </a:r>
+          </a:p>
+          <a:p>
+            <a:r>
+              <a:t>- Tribal and protected land: the sensitive-land branch rates both rows Low residual (PAD-US 4.1:</a:t>
+            </a:r>
+          </a:p>
+          <a:p>
+            <a:r>
+              <a:t>  nearest protected parcels 5.8 km W and 8.6 km S; no tribal land in the county; Quincy appears</a:t>
+            </a:r>
+          </a:p>
+          <a:p>
+            <a:r>
+              <a:t>  to sit in the Yakama Nation's 1855 ceded area). Section 106 consultation is triggered by a federal</a:t>
+            </a:r>
+          </a:p>
+          <a:p>
+            <a:r>
+              <a:t>  connection (Army Corps permit, BPA interconnection, federal funding, FERC project lands); state</a:t>
+            </a:r>
+          </a:p>
+          <a:p>
+            <a:r>
+              <a:t>  funding triggers Executive Order 21-02 review. We show consultation as an early action, not a</a:t>
+            </a:r>
+          </a:p>
+          <a:p>
+            <a:r>
+              <a:t>  low rating, because of the fisheries point below.</a:t>
+            </a:r>
+          </a:p>
+          <a:p>
+            <a:r>
               <a:t>- Price: with Washington at BPA's new-load rate and other states at their averages, Grant</a:t>
             </a:r>
           </a:p>
@@ -5117,7 +5238,7 @@
           </a:p>
           <a:p>
             <a:r>
-              <a:t>- Protected land and tribal rows: residual Low [[CHECK]]. Source: research/risk.md on origin/fix/sensitive-land (d2ed911), field Protected and sensitive land; Tribal consultation</a:t>
+              <a:t>- Protected land within 5 km of Quincy: none (nearest 5.8 km) [[CHECK]]. Source: research/risk.md on origin/fix/sensitive-land (12a8127), field Protected and sensitive land</a:t>
             </a:r>
           </a:p>
           <a:p/>
@@ -5133,7 +5254,7 @@
           </a:p>
           <a:p>
             <a:r>
-              <a:t>- PAD-US 4.1 and tribal land checks: research/risk.md and research/sensitive_land.md on branch fix/sensitive-land, commit d2ed911</a:t>
+              <a:t>- PAD-US 4.1 and tribal land checks: research/risk.md and research/sensitive_land.md on branch fix/sensitive-land, commit 12a8127</a:t>
             </a:r>
           </a:p>
           <a:p>
@@ -8479,7 +8600,7 @@
           <a:p>
             <a:pPr algn="l"/>
             <a:r>
-              <a:rPr sz="1300" b="1" i="0">
+              <a:rPr sz="1400" b="1" i="0">
                 <a:solidFill>
                   <a:srgbClr val="0B3C6F"/>
                 </a:solidFill>
@@ -8903,7 +9024,7 @@
           <a:p>
             <a:pPr algn="l"/>
             <a:r>
-              <a:rPr sz="1300" b="1" i="0">
+              <a:rPr sz="1400" b="1" i="0">
                 <a:solidFill>
                   <a:srgbClr val="0B3C6F"/>
                 </a:solidFill>
@@ -9092,8 +9213,8 @@
         </p:nvSpPr>
         <p:spPr>
           <a:xfrm>
-            <a:off x="548640" y="5303520"/>
-            <a:ext cx="11094415" cy="1005840"/>
+            <a:off x="548640" y="5257800"/>
+            <a:ext cx="11094415" cy="896112"/>
           </a:xfrm>
           <a:prstGeom prst="rect">
             <a:avLst/>
@@ -9236,7 +9357,7 @@
           <a:p>
             <a:pPr algn="l"/>
             <a:r>
-              <a:rPr sz="1300" b="1" i="0">
+              <a:rPr sz="1400" b="1" i="0">
                 <a:solidFill>
                   <a:srgbClr val="0B3C6F"/>
                 </a:solidFill>
@@ -9277,7 +9398,7 @@
                 </a:solidFill>
                 <a:latin typeface="Arial"/>
               </a:rPr>
-              <a:t>In 25-year dollars, three counties tie within 1.1%. Each has a win condition.</a:t>
+              <a:t>At today's prices, three counties tie within 1.1% over 25 years.</a:t>
             </a:r>
           </a:p>
         </p:txBody>
@@ -9439,7 +9560,7 @@
                           </a:solidFill>
                           <a:latin typeface="Arial"/>
                         </a:rPr>
-                        <a:t>25-year cost</a:t>
+                        <a:t>25-year cost, today's prices</a:t>
                       </a:r>
                     </a:p>
                   </a:txBody>
@@ -9689,7 +9810,7 @@
         <p:spPr>
           <a:xfrm>
             <a:off x="548640" y="4892040"/>
-            <a:ext cx="11094415" cy="1463040"/>
+            <a:ext cx="11094415" cy="1188720"/>
           </a:xfrm>
           <a:prstGeom prst="rect">
             <a:avLst/>
@@ -9748,7 +9869,7 @@
                 </a:solidFill>
                 <a:latin typeface="Arial"/>
               </a:rPr>
-              <a:t>Shortlist ranks with tax: Clark 73, Grant 78, Franklin 80.</a:t>
+              <a:t>Ranks among 162 shortlisted: Clark 73, Grant 78, Franklin 80.</a:t>
             </a:r>
           </a:p>
         </p:txBody>
@@ -9832,7 +9953,7 @@
           <a:p>
             <a:pPr algn="l"/>
             <a:r>
-              <a:rPr sz="1300" b="1" i="0">
+              <a:rPr sz="1400" b="1" i="0">
                 <a:solidFill>
                   <a:srgbClr val="0B3C6F"/>
                 </a:solidFill>
@@ -9986,8 +10107,8 @@
           <p:nvPr/>
         </p:nvGraphicFramePr>
         <p:xfrm>
-          <a:off x="548640" y="2011680"/>
-          <a:ext cx="11094415" cy="4297680"/>
+          <a:off x="548640" y="1965960"/>
+          <a:ext cx="11094415" cy="4206240"/>
         </p:xfrm>
         <a:graphic>
           <a:graphicData uri="http://schemas.openxmlformats.org/drawingml/2006/chart">
@@ -10074,7 +10195,7 @@
           <a:p>
             <a:pPr algn="l"/>
             <a:r>
-              <a:rPr sz="1300" b="1" i="0">
+              <a:rPr sz="1400" b="1" i="0">
                 <a:solidFill>
                   <a:srgbClr val="0B3C6F"/>
                 </a:solidFill>
@@ -10228,8 +10349,8 @@
           <p:nvPr/>
         </p:nvGraphicFramePr>
         <p:xfrm>
-          <a:off x="548640" y="2011680"/>
-          <a:ext cx="11094415" cy="4297680"/>
+          <a:off x="548640" y="1965960"/>
+          <a:ext cx="11094415" cy="3931920"/>
         </p:xfrm>
         <a:graphic>
           <a:graphicData uri="http://schemas.openxmlformats.org/drawingml/2006/table">
@@ -10241,14 +10362,14 @@
                 <a:gridCol w="2926080"/>
                 <a:gridCol w="8168335"/>
               </a:tblGrid>
-              <a:tr h="477520">
+              <a:tr h="436880">
                 <a:tc>
                   <a:txBody>
                     <a:bodyPr wrap="square"/>
                     <a:lstStyle/>
                     <a:p>
                       <a:r>
-                        <a:rPr sz="1600" b="1" i="0">
+                        <a:rPr sz="1500" b="1" i="0">
                           <a:solidFill>
                             <a:srgbClr val="FFFFFF"/>
                           </a:solidFill>
@@ -10270,7 +10391,7 @@
                     <a:lstStyle/>
                     <a:p>
                       <a:r>
-                        <a:rPr sz="1600" b="1" i="0">
+                        <a:rPr sz="1500" b="1" i="0">
                           <a:solidFill>
                             <a:srgbClr val="FFFFFF"/>
                           </a:solidFill>
@@ -10287,14 +10408,14 @@
                   </a:tcPr>
                 </a:tc>
               </a:tr>
-              <a:tr h="477520">
+              <a:tr h="436880">
                 <a:tc>
                   <a:txBody>
                     <a:bodyPr wrap="square"/>
                     <a:lstStyle/>
                     <a:p>
                       <a:r>
-                        <a:rPr sz="1600" b="1" i="0">
+                        <a:rPr sz="1500" b="1" i="0">
                           <a:solidFill>
                             <a:srgbClr val="111518"/>
                           </a:solidFill>
@@ -10316,7 +10437,7 @@
                     <a:lstStyle/>
                     <a:p>
                       <a:r>
-                        <a:rPr sz="1600" b="0" i="0">
+                        <a:rPr sz="1500" b="0" i="0">
                           <a:solidFill>
                             <a:srgbClr val="111518"/>
                           </a:solidFill>
@@ -10333,14 +10454,14 @@
                   </a:tcPr>
                 </a:tc>
               </a:tr>
-              <a:tr h="477520">
+              <a:tr h="436880">
                 <a:tc>
                   <a:txBody>
                     <a:bodyPr wrap="square"/>
                     <a:lstStyle/>
                     <a:p>
                       <a:r>
-                        <a:rPr sz="1600" b="1" i="0">
+                        <a:rPr sz="1500" b="1" i="0">
                           <a:solidFill>
                             <a:srgbClr val="111518"/>
                           </a:solidFill>
@@ -10362,7 +10483,7 @@
                     <a:lstStyle/>
                     <a:p>
                       <a:r>
-                        <a:rPr sz="1600" b="0" i="0">
+                        <a:rPr sz="1500" b="0" i="0">
                           <a:solidFill>
                             <a:srgbClr val="111518"/>
                           </a:solidFill>
@@ -10379,14 +10500,14 @@
                   </a:tcPr>
                 </a:tc>
               </a:tr>
-              <a:tr h="477520">
+              <a:tr h="436880">
                 <a:tc>
                   <a:txBody>
                     <a:bodyPr wrap="square"/>
                     <a:lstStyle/>
                     <a:p>
                       <a:r>
-                        <a:rPr sz="1600" b="1" i="0">
+                        <a:rPr sz="1500" b="1" i="0">
                           <a:solidFill>
                             <a:srgbClr val="111518"/>
                           </a:solidFill>
@@ -10408,7 +10529,7 @@
                     <a:lstStyle/>
                     <a:p>
                       <a:r>
-                        <a:rPr sz="1600" b="0" i="0">
+                        <a:rPr sz="1500" b="0" i="0">
                           <a:solidFill>
                             <a:srgbClr val="111518"/>
                           </a:solidFill>
@@ -10425,14 +10546,14 @@
                   </a:tcPr>
                 </a:tc>
               </a:tr>
-              <a:tr h="477520">
+              <a:tr h="436880">
                 <a:tc>
                   <a:txBody>
                     <a:bodyPr wrap="square"/>
                     <a:lstStyle/>
                     <a:p>
                       <a:r>
-                        <a:rPr sz="1600" b="1" i="0">
+                        <a:rPr sz="1500" b="1" i="0">
                           <a:solidFill>
                             <a:srgbClr val="111518"/>
                           </a:solidFill>
@@ -10454,7 +10575,7 @@
                     <a:lstStyle/>
                     <a:p>
                       <a:r>
-                        <a:rPr sz="1600" b="0" i="0">
+                        <a:rPr sz="1500" b="0" i="0">
                           <a:solidFill>
                             <a:srgbClr val="111518"/>
                           </a:solidFill>
@@ -10471,14 +10592,14 @@
                   </a:tcPr>
                 </a:tc>
               </a:tr>
-              <a:tr h="477520">
+              <a:tr h="436880">
                 <a:tc>
                   <a:txBody>
                     <a:bodyPr wrap="square"/>
                     <a:lstStyle/>
                     <a:p>
                       <a:r>
-                        <a:rPr sz="1600" b="1" i="0">
+                        <a:rPr sz="1500" b="1" i="0">
                           <a:solidFill>
                             <a:srgbClr val="111518"/>
                           </a:solidFill>
@@ -10500,7 +10621,7 @@
                     <a:lstStyle/>
                     <a:p>
                       <a:r>
-                        <a:rPr sz="1600" b="0" i="0">
+                        <a:rPr sz="1500" b="0" i="0">
                           <a:solidFill>
                             <a:srgbClr val="111518"/>
                           </a:solidFill>
@@ -10517,14 +10638,14 @@
                   </a:tcPr>
                 </a:tc>
               </a:tr>
-              <a:tr h="477520">
+              <a:tr h="436880">
                 <a:tc>
                   <a:txBody>
                     <a:bodyPr wrap="square"/>
                     <a:lstStyle/>
                     <a:p>
                       <a:r>
-                        <a:rPr sz="1600" b="1" i="0">
+                        <a:rPr sz="1500" b="1" i="0">
                           <a:solidFill>
                             <a:srgbClr val="111518"/>
                           </a:solidFill>
@@ -10546,7 +10667,7 @@
                     <a:lstStyle/>
                     <a:p>
                       <a:r>
-                        <a:rPr sz="1600" b="0" i="0">
+                        <a:rPr sz="1500" b="0" i="0">
                           <a:solidFill>
                             <a:srgbClr val="111518"/>
                           </a:solidFill>
@@ -10563,14 +10684,14 @@
                   </a:tcPr>
                 </a:tc>
               </a:tr>
-              <a:tr h="477520">
+              <a:tr h="436880">
                 <a:tc>
                   <a:txBody>
                     <a:bodyPr wrap="square"/>
                     <a:lstStyle/>
                     <a:p>
                       <a:r>
-                        <a:rPr sz="1600" b="1" i="0">
+                        <a:rPr sz="1500" b="1" i="0">
                           <a:solidFill>
                             <a:srgbClr val="111518"/>
                           </a:solidFill>
@@ -10592,7 +10713,7 @@
                     <a:lstStyle/>
                     <a:p>
                       <a:r>
-                        <a:rPr sz="1600" b="0" i="0">
+                        <a:rPr sz="1500" b="0" i="0">
                           <a:solidFill>
                             <a:srgbClr val="111518"/>
                           </a:solidFill>
@@ -10609,14 +10730,14 @@
                   </a:tcPr>
                 </a:tc>
               </a:tr>
-              <a:tr h="477520">
+              <a:tr h="436880">
                 <a:tc>
                   <a:txBody>
                     <a:bodyPr wrap="square"/>
                     <a:lstStyle/>
                     <a:p>
                       <a:r>
-                        <a:rPr sz="1600" b="1" i="0">
+                        <a:rPr sz="1500" b="1" i="0">
                           <a:solidFill>
                             <a:srgbClr val="111518"/>
                           </a:solidFill>
@@ -10638,7 +10759,7 @@
                     <a:lstStyle/>
                     <a:p>
                       <a:r>
-                        <a:rPr sz="1600" b="0" i="0">
+                        <a:rPr sz="1500" b="0" i="0">
                           <a:solidFill>
                             <a:srgbClr val="111518"/>
                           </a:solidFill>
@@ -10738,7 +10859,7 @@
           <a:p>
             <a:pPr algn="l"/>
             <a:r>
-              <a:rPr sz="1300" b="1" i="0">
+              <a:rPr sz="1400" b="1" i="0">
                 <a:solidFill>
                   <a:srgbClr val="0B3C6F"/>
                 </a:solidFill>
@@ -11408,7 +11529,7 @@
           <a:p>
             <a:pPr algn="l"/>
             <a:r>
-              <a:rPr sz="1300" b="1" i="0">
+              <a:rPr sz="1400" b="1" i="0">
                 <a:solidFill>
                   <a:srgbClr val="0B3C6F"/>
                 </a:solidFill>
@@ -11513,7 +11634,7 @@
                 </a:solidFill>
                 <a:latin typeface="Arial"/>
               </a:rPr>
-              <a:t>Sources: docs/global.md; results/global_balanced.csv; docs/figures/global_table.png; docs/industrial_reuse.md; docs/demo_script.md (Boone County, IL; BLS QCEW private manufacturing jobs).</a:t>
+              <a:t>Sources: docs/global.md; results/global_balanced.csv; docs/figures/facts.json (global); docs/industrial_reuse.md; docs/demo_script.md (Boone County, IL; BLS QCEW private manufacturing jobs).</a:t>
             </a:r>
           </a:p>
         </p:txBody>
@@ -12378,7 +12499,7 @@
           <a:p>
             <a:pPr algn="l"/>
             <a:r>
-              <a:rPr sz="1300" b="1" i="0">
+              <a:rPr sz="1400" b="1" i="0">
                 <a:solidFill>
                   <a:srgbClr val="0B3C6F"/>
                 </a:solidFill>
@@ -12539,8 +12660,8 @@
         </p:blipFill>
         <p:spPr>
           <a:xfrm>
-            <a:off x="688416" y="1965960"/>
-            <a:ext cx="5572607" cy="4389120"/>
+            <a:off x="804512" y="1965960"/>
+            <a:ext cx="5340415" cy="4206240"/>
           </a:xfrm>
           <a:prstGeom prst="rect">
             <a:avLst/>
@@ -12549,7 +12670,112 @@
       </p:pic>
       <p:sp>
         <p:nvSpPr>
-          <p:cNvPr id="9" name="Condition"/>
+          <p:cNvPr id="9" name="Map title"/>
+          <p:cNvSpPr/>
+          <p:nvPr/>
+        </p:nvSpPr>
+        <p:spPr>
+          <a:xfrm>
+            <a:off x="804512" y="1965960"/>
+            <a:ext cx="5340415" cy="269264"/>
+          </a:xfrm>
+          <a:prstGeom prst="rect">
+            <a:avLst/>
+          </a:prstGeom>
+          <a:solidFill>
+            <a:srgbClr val="FCFCFB"/>
+          </a:solidFill>
+          <a:ln>
+            <a:noFill/>
+          </a:ln>
+        </p:spPr>
+        <p:txBody>
+          <a:bodyPr rtlCol="0" anchor="ctr" wrap="square" lIns="73152" rIns="73152" tIns="36576" bIns="36576"/>
+          <a:lstStyle/>
+          <a:p>
+            <a:pPr algn="l"/>
+            <a:r>
+              <a:rPr sz="1600" b="1" i="0">
+                <a:solidFill>
+                  <a:srgbClr val="111518"/>
+                </a:solidFill>
+                <a:latin typeface="Arial"/>
+              </a:rPr>
+              <a:t>Counties that pass the gates; Grant, WA circled</a:t>
+            </a:r>
+          </a:p>
+        </p:txBody>
+      </p:sp>
+      <p:sp>
+        <p:nvSpPr>
+          <p:cNvPr id="10" name="Grant ring"/>
+          <p:cNvSpPr/>
+          <p:nvPr/>
+        </p:nvSpPr>
+        <p:spPr>
+          <a:xfrm>
+            <a:off x="1418596" y="2449492"/>
+            <a:ext cx="566928" cy="566928"/>
+          </a:xfrm>
+          <a:prstGeom prst="ellipse">
+            <a:avLst/>
+          </a:prstGeom>
+          <a:noFill/>
+          <a:ln w="38100">
+            <a:solidFill>
+              <a:srgbClr val="D9532B"/>
+            </a:solidFill>
+          </a:ln>
+        </p:spPr>
+        <p:txBody>
+          <a:bodyPr rtlCol="0" anchor="ctr"/>
+          <a:lstStyle/>
+          <a:p>
+            <a:pPr algn="ctr"/>
+          </a:p>
+        </p:txBody>
+      </p:sp>
+      <p:sp>
+        <p:nvSpPr>
+          <p:cNvPr id="11" name="Map legend"/>
+          <p:cNvSpPr/>
+          <p:nvPr/>
+        </p:nvSpPr>
+        <p:spPr>
+          <a:xfrm>
+            <a:off x="877947" y="5401123"/>
+            <a:ext cx="3427004" cy="252945"/>
+          </a:xfrm>
+          <a:prstGeom prst="rect">
+            <a:avLst/>
+          </a:prstGeom>
+          <a:solidFill>
+            <a:srgbClr val="FCFCFB"/>
+          </a:solidFill>
+          <a:ln>
+            <a:noFill/>
+          </a:ln>
+        </p:spPr>
+        <p:txBody>
+          <a:bodyPr rtlCol="0" anchor="ctr" wrap="square" lIns="36576" rIns="36576" tIns="36576" bIns="36576"/>
+          <a:lstStyle/>
+          <a:p>
+            <a:pPr algn="l"/>
+            <a:r>
+              <a:rPr sz="1400" b="0" i="0">
+                <a:solidFill>
+                  <a:srgbClr val="46505A"/>
+                </a:solidFill>
+                <a:latin typeface="Arial"/>
+              </a:rPr>
+              <a:t>Grey: excluded by a hard gate</a:t>
+            </a:r>
+          </a:p>
+        </p:txBody>
+      </p:sp>
+      <p:sp>
+        <p:nvSpPr>
+          <p:cNvPr id="12" name="Condition"/>
           <p:cNvSpPr/>
           <p:nvPr/>
         </p:nvSpPr>
@@ -12574,7 +12800,7 @@
           <a:p>
             <a:pPr algn="l"/>
             <a:r>
-              <a:rPr sz="1300" b="1" i="0">
+              <a:rPr sz="1400" b="1" i="0">
                 <a:solidFill>
                   <a:srgbClr val="DCE3EA"/>
                 </a:solidFill>
@@ -12599,14 +12825,14 @@
       </p:sp>
       <p:sp>
         <p:nvSpPr>
-          <p:cNvPr id="10" name="Bullets"/>
+          <p:cNvPr id="13" name="Bullets"/>
           <p:cNvSpPr txBox="1"/>
           <p:nvPr/>
         </p:nvSpPr>
         <p:spPr>
           <a:xfrm>
             <a:off x="6720840" y="3703320"/>
-            <a:ext cx="4922215" cy="2651760"/>
+            <a:ext cx="4922215" cy="2377440"/>
           </a:xfrm>
           <a:prstGeom prst="rect">
             <a:avLst/>
@@ -12665,7 +12891,7 @@
                 </a:solidFill>
                 <a:latin typeface="Arial"/>
               </a:rPr>
-              <a:t>Top 10 in 51% of all weightings, more than any county.</a:t>
+              <a:t>Top 10 in 50.5% of all weightings, more than any county.</a:t>
             </a:r>
           </a:p>
           <a:p>
@@ -12690,7 +12916,7 @@
                 </a:solidFill>
                 <a:latin typeface="Arial"/>
               </a:rPr>
-              <a:t>Ties Clark WA and Franklin NY within 1.1% over 25 years.</a:t>
+              <a:t>Ties Clark WA, Franklin NY within 1.1% at today's prices.</a:t>
             </a:r>
           </a:p>
         </p:txBody>
@@ -12774,7 +13000,7 @@
           <a:p>
             <a:pPr algn="l"/>
             <a:r>
-              <a:rPr sz="1300" b="1" i="0">
+              <a:rPr sz="1400" b="1" i="0">
                 <a:solidFill>
                   <a:srgbClr val="0B3C6F"/>
                 </a:solidFill>
@@ -13191,13 +13417,13 @@
           <a:p>
             <a:pPr algn="ctr"/>
             <a:r>
-              <a:rPr sz="2400" b="1" i="0">
+              <a:rPr sz="2600" b="1" i="0">
                 <a:solidFill>
                   <a:srgbClr val="FFFFFF"/>
                 </a:solidFill>
                 <a:latin typeface="Arial"/>
               </a:rPr>
-              <a:t>$ and t</a:t>
+              <a:t>Cost</a:t>
             </a:r>
           </a:p>
           <a:p>
@@ -13209,7 +13435,7 @@
                 </a:solidFill>
                 <a:latin typeface="Arial"/>
               </a:rPr>
-              <a:t>25-year cost and carbon price the leaders</a:t>
+              <a:t>25-year dollars and tonnes price the leaders</a:t>
             </a:r>
           </a:p>
         </p:txBody>
@@ -13272,7 +13498,7 @@
           <a:p>
             <a:pPr algn="ctr"/>
             <a:r>
-              <a:rPr sz="2400" b="1" i="0">
+              <a:rPr sz="2600" b="1" i="0">
                 <a:solidFill>
                   <a:srgbClr val="FFFFFF"/>
                 </a:solidFill>
@@ -13637,7 +13863,7 @@
                 </a:solidFill>
                 <a:latin typeface="Arial"/>
               </a:rPr>
-              <a:t>8%</a:t>
+              <a:t>9%</a:t>
             </a:r>
           </a:p>
         </p:txBody>
@@ -13776,7 +14002,7 @@
                 </a:solidFill>
                 <a:latin typeface="Arial"/>
               </a:rPr>
-              <a:t>Not machine learning: stated weights, tested for robustness on slide 6.</a:t>
+              <a:t>Not machine learning: stated weights, rounded half up as in the app, tested on slide 6.</a:t>
             </a:r>
           </a:p>
         </p:txBody>
@@ -13860,7 +14086,7 @@
           <a:p>
             <a:pPr algn="l"/>
             <a:r>
-              <a:rPr sz="1300" b="1" i="0">
+              <a:rPr sz="1400" b="1" i="0">
                 <a:solidFill>
                   <a:srgbClr val="0B3C6F"/>
                 </a:solidFill>
@@ -13901,7 +14127,7 @@
                 </a:solidFill>
                 <a:latin typeface="Arial"/>
               </a:rPr>
-              <a:t>Dry cooling cuts water 87%. State law forces power clean by 2045.</a:t>
+              <a:t>Dry cooling cuts water 87%. Carbon depends on the supply we fund.</a:t>
             </a:r>
           </a:p>
         </p:txBody>
@@ -14049,8 +14275,8 @@
         </p:nvSpPr>
         <p:spPr>
           <a:xfrm>
-            <a:off x="548640" y="4983480"/>
-            <a:ext cx="5318607" cy="1143000"/>
+            <a:off x="548640" y="4956048"/>
+            <a:ext cx="5318607" cy="1261872"/>
           </a:xfrm>
           <a:prstGeom prst="rect">
             <a:avLst/>
@@ -14078,8 +14304,8 @@
         </p:nvSpPr>
         <p:spPr>
           <a:xfrm>
-            <a:off x="548640" y="4983480"/>
-            <a:ext cx="73152" cy="1143000"/>
+            <a:off x="548640" y="4956048"/>
+            <a:ext cx="73152" cy="1261872"/>
           </a:xfrm>
           <a:prstGeom prst="rect">
             <a:avLst/>
@@ -14107,8 +14333,8 @@
         </p:nvSpPr>
         <p:spPr>
           <a:xfrm>
-            <a:off x="822960" y="5093208"/>
-            <a:ext cx="4861407" cy="960120"/>
+            <a:off x="822960" y="5065776"/>
+            <a:ext cx="4861407" cy="1078992"/>
           </a:xfrm>
           <a:prstGeom prst="rect">
             <a:avLst/>
@@ -14193,7 +14419,7 @@
                 </a:solidFill>
                 <a:latin typeface="Arial"/>
               </a:rPr>
-              <a:t>Shown before funded supply. State law: 100% clean by 2045.</a:t>
+              <a:t>Shown before the clean supply we fund comes online.</a:t>
             </a:r>
           </a:p>
         </p:txBody>
@@ -14277,7 +14503,7 @@
           <a:p>
             <a:pPr algn="l"/>
             <a:r>
-              <a:rPr sz="1300" b="1" i="0">
+              <a:rPr sz="1400" b="1" i="0">
                 <a:solidFill>
                   <a:srgbClr val="0B3C6F"/>
                 </a:solidFill>
@@ -14318,7 +14544,7 @@
                 </a:solidFill>
                 <a:latin typeface="Arial"/>
               </a:rPr>
-              <a:t>Corrections moved our pick. The last one cut against Grant.</a:t>
+              <a:t>Corrections moved our pick. The price check cuts against Grant.</a:t>
             </a:r>
           </a:p>
         </p:txBody>
@@ -14568,7 +14794,7 @@
                 </a:solidFill>
                 <a:latin typeface="Arial"/>
               </a:rPr>
-              <a:t>New-load power prices raise Grant's bill to $196–323M.</a:t>
+              <a:t>Repricing only Washington at BPA's $80/MWh: Grant falls to 79th.</a:t>
             </a:r>
           </a:p>
         </p:txBody>
@@ -14600,7 +14826,7 @@
           <a:p>
             <a:pPr algn="l"/>
             <a:r>
-              <a:rPr sz="1300" b="1" i="0">
+              <a:rPr sz="1400" b="1" i="0">
                 <a:solidFill>
                   <a:srgbClr val="D9532B"/>
                 </a:solidFill>
@@ -14702,7 +14928,7 @@
           <a:p>
             <a:pPr algn="l"/>
             <a:r>
-              <a:rPr sz="1300" b="1" i="0">
+              <a:rPr sz="1400" b="1" i="0">
                 <a:solidFill>
                   <a:srgbClr val="0B3C6F"/>
                 </a:solidFill>
@@ -14856,8 +15082,8 @@
           <p:nvPr/>
         </p:nvGraphicFramePr>
         <p:xfrm>
-          <a:off x="548640" y="2011680"/>
-          <a:ext cx="6035040" cy="3657600"/>
+          <a:off x="548640" y="1965960"/>
+          <a:ext cx="6035040" cy="3520440"/>
         </p:xfrm>
         <a:graphic>
           <a:graphicData uri="http://schemas.openxmlformats.org/drawingml/2006/chart">
@@ -14971,7 +15197,7 @@
         </p:nvSpPr>
         <p:spPr>
           <a:xfrm>
-            <a:off x="548640" y="5806440"/>
+            <a:off x="548640" y="5623560"/>
             <a:ext cx="11094415" cy="548640"/>
           </a:xfrm>
           <a:prstGeom prst="rect">
@@ -15080,7 +15306,7 @@
           <a:p>
             <a:pPr algn="l"/>
             <a:r>
-              <a:rPr sz="1300" b="1" i="0">
+              <a:rPr sz="1400" b="1" i="0">
                 <a:solidFill>
                   <a:srgbClr val="0B3C6F"/>
                 </a:solidFill>
@@ -15121,7 +15347,7 @@
                 </a:solidFill>
                 <a:latin typeface="Arial"/>
               </a:rPr>
-              <a:t>Grant's case rests on one thing: full power by about 2029.</a:t>
+              <a:t>Grant's case rests on power: full load by 2029, near today's price.</a:t>
             </a:r>
           </a:p>
         </p:txBody>
@@ -15185,7 +15411,7 @@
                 </a:solidFill>
                 <a:latin typeface="Arial"/>
               </a:rPr>
-              <a:t>Sources: Grant PUD data center FAQ (2026-08-28); research/risk.md; docs/weighting.md; protected land and tribal rows from research/risk.md on branch fix/sensitive-land (d2ed911, not yet on main; PAD-US 4.1).</a:t>
+              <a:t>Sources: Grant PUD data center FAQ (2026-08-28); research/risk.md; docs/weighting.md; protected land and tribal rows from research/risk.md on branch fix/sensitive-land (12a8127, not yet on main; PAD-US 4.1).</a:t>
             </a:r>
           </a:p>
         </p:txBody>
@@ -15235,7 +15461,7 @@
         </p:nvGraphicFramePr>
         <p:xfrm>
           <a:off x="548640" y="1965960"/>
-          <a:ext cx="5120640" cy="2240280"/>
+          <a:ext cx="5120640" cy="3200400"/>
         </p:xfrm>
         <a:graphic>
           <a:graphicData uri="http://schemas.openxmlformats.org/drawingml/2006/chart">
@@ -15245,123 +15471,14 @@
       </p:graphicFrame>
       <p:sp>
         <p:nvSpPr>
-          <p:cNvPr id="9" name="Quote"/>
+          <p:cNvPr id="9" name="Risk HIGH"/>
           <p:cNvSpPr/>
           <p:nvPr/>
         </p:nvSpPr>
         <p:spPr>
           <a:xfrm>
-            <a:off x="548640" y="4297680"/>
-            <a:ext cx="5120640" cy="914400"/>
-          </a:xfrm>
-          <a:prstGeom prst="rect">
-            <a:avLst/>
-          </a:prstGeom>
-          <a:solidFill>
-            <a:srgbClr val="F3F5F4"/>
-          </a:solidFill>
-          <a:ln>
-            <a:noFill/>
-          </a:ln>
-        </p:spPr>
-        <p:txBody>
-          <a:bodyPr rtlCol="0" anchor="ctr"/>
-          <a:lstStyle/>
-          <a:p>
-            <a:pPr algn="ctr"/>
-          </a:p>
-        </p:txBody>
-      </p:sp>
-      <p:sp>
-        <p:nvSpPr>
-          <p:cNvPr id="10" name="Quote bar"/>
-          <p:cNvSpPr/>
-          <p:nvPr/>
-        </p:nvSpPr>
-        <p:spPr>
-          <a:xfrm>
-            <a:off x="548640" y="4297680"/>
-            <a:ext cx="73152" cy="914400"/>
-          </a:xfrm>
-          <a:prstGeom prst="rect">
-            <a:avLst/>
-          </a:prstGeom>
-          <a:solidFill>
-            <a:srgbClr val="0B3C6F"/>
-          </a:solidFill>
-          <a:ln>
-            <a:noFill/>
-          </a:ln>
-        </p:spPr>
-        <p:txBody>
-          <a:bodyPr rtlCol="0" anchor="ctr"/>
-          <a:lstStyle/>
-          <a:p>
-            <a:pPr algn="ctr"/>
-          </a:p>
-        </p:txBody>
-      </p:sp>
-      <p:sp>
-        <p:nvSpPr>
-          <p:cNvPr id="11" name="Quote text"/>
-          <p:cNvSpPr txBox="1"/>
-          <p:nvPr/>
-        </p:nvSpPr>
-        <p:spPr>
-          <a:xfrm>
-            <a:off x="822960" y="4407408"/>
-            <a:ext cx="4663440" cy="731520"/>
-          </a:xfrm>
-          <a:prstGeom prst="rect">
-            <a:avLst/>
-          </a:prstGeom>
-          <a:noFill/>
-        </p:spPr>
-        <p:txBody>
-          <a:bodyPr wrap="square" anchor="ctr" lIns="36576" rIns="36576" tIns="18288" bIns="18288">
-            <a:spAutoFit/>
-          </a:bodyPr>
-          <a:lstStyle/>
-          <a:p>
-            <a:pPr algn="l"/>
-            <a:r>
-              <a:rPr sz="1600" b="0" i="0">
-                <a:solidFill>
-                  <a:srgbClr val="111518"/>
-                </a:solidFill>
-                <a:latin typeface="Arial"/>
-              </a:rPr>
-              <a:t>“…service cannot always be provided as quickly as customers or developers may prefer.”</a:t>
-            </a:r>
-          </a:p>
-          <a:p>
-            <a:pPr algn="l">
-              <a:spcBef>
-                <a:spcPts val="600"/>
-              </a:spcBef>
-            </a:pPr>
-            <a:r>
-              <a:rPr sz="1400" b="1" i="0">
-                <a:solidFill>
-                  <a:srgbClr val="46505A"/>
-                </a:solidFill>
-                <a:latin typeface="Arial"/>
-              </a:rPr>
-              <a:t>Grant County PUD, Aug. 2026</a:t>
-            </a:r>
-          </a:p>
-        </p:txBody>
-      </p:sp>
-      <p:sp>
-        <p:nvSpPr>
-          <p:cNvPr id="12" name="Risk HIGH"/>
-          <p:cNvSpPr/>
-          <p:nvPr/>
-        </p:nvSpPr>
-        <p:spPr>
-          <a:xfrm>
             <a:off x="5989320" y="2194560"/>
-            <a:ext cx="1097280" cy="457200"/>
+            <a:ext cx="1280160" cy="457200"/>
           </a:xfrm>
           <a:prstGeom prst="roundRect">
             <a:avLst>
@@ -15394,14 +15511,14 @@
       </p:sp>
       <p:sp>
         <p:nvSpPr>
-          <p:cNvPr id="13" name="TextBox 12"/>
+          <p:cNvPr id="10" name="TextBox 9"/>
           <p:cNvSpPr txBox="1"/>
           <p:nvPr/>
         </p:nvSpPr>
         <p:spPr>
           <a:xfrm>
-            <a:off x="7269480" y="2011680"/>
-            <a:ext cx="4373575" cy="868680"/>
+            <a:off x="7452360" y="2011680"/>
+            <a:ext cx="4190695" cy="868680"/>
           </a:xfrm>
           <a:prstGeom prst="rect">
             <a:avLst/>
@@ -15422,21 +15539,21 @@
                 </a:solidFill>
                 <a:latin typeface="Arial"/>
               </a:rPr>
-              <a:t>Power: no spare hydro; ~800 MW of requests queued ahead.</a:t>
-            </a:r>
-          </a:p>
-        </p:txBody>
-      </p:sp>
-      <p:sp>
-        <p:nvSpPr>
-          <p:cNvPr id="14" name="Risk MEDIUM"/>
+              <a:t>Power: no spare hydro; ~800 MW queued; new-load price unset.</a:t>
+            </a:r>
+          </a:p>
+        </p:txBody>
+      </p:sp>
+      <p:sp>
+        <p:nvSpPr>
+          <p:cNvPr id="11" name="Risk MEDIUM"/>
           <p:cNvSpPr/>
           <p:nvPr/>
         </p:nvSpPr>
         <p:spPr>
           <a:xfrm>
             <a:off x="5989320" y="3264408"/>
-            <a:ext cx="1097280" cy="457200"/>
+            <a:ext cx="1280160" cy="457200"/>
           </a:xfrm>
           <a:prstGeom prst="roundRect">
             <a:avLst>
@@ -15469,14 +15586,14 @@
       </p:sp>
       <p:sp>
         <p:nvSpPr>
-          <p:cNvPr id="15" name="TextBox 14"/>
+          <p:cNvPr id="12" name="TextBox 11"/>
           <p:cNvSpPr txBox="1"/>
           <p:nvPr/>
         </p:nvSpPr>
         <p:spPr>
           <a:xfrm>
-            <a:off x="7269480" y="3081528"/>
-            <a:ext cx="4373575" cy="868680"/>
+            <a:off x="7452360" y="3081528"/>
+            <a:ext cx="4190695" cy="868680"/>
           </a:xfrm>
           <a:prstGeom prst="rect">
             <a:avLst/>
@@ -15504,14 +15621,14 @@
       </p:sp>
       <p:sp>
         <p:nvSpPr>
-          <p:cNvPr id="16" name="Risk LOW"/>
+          <p:cNvPr id="13" name="Risk ACT EARLY"/>
           <p:cNvSpPr/>
           <p:nvPr/>
         </p:nvSpPr>
         <p:spPr>
           <a:xfrm>
             <a:off x="5989320" y="4334256"/>
-            <a:ext cx="1097280" cy="457200"/>
+            <a:ext cx="1280160" cy="457200"/>
           </a:xfrm>
           <a:prstGeom prst="roundRect">
             <a:avLst>
@@ -15519,7 +15636,7 @@
             </a:avLst>
           </a:prstGeom>
           <a:solidFill>
-            <a:srgbClr val="23804F"/>
+            <a:srgbClr val="0B3C6F"/>
           </a:solidFill>
           <a:ln>
             <a:noFill/>
@@ -15537,21 +15654,21 @@
                 </a:solidFill>
                 <a:latin typeface="Arial"/>
               </a:rPr>
-              <a:t>LOW</a:t>
-            </a:r>
-          </a:p>
-        </p:txBody>
-      </p:sp>
-      <p:sp>
-        <p:nvSpPr>
-          <p:cNvPr id="17" name="TextBox 16"/>
+              <a:t>ACT EARLY</a:t>
+            </a:r>
+          </a:p>
+        </p:txBody>
+      </p:sp>
+      <p:sp>
+        <p:nvSpPr>
+          <p:cNvPr id="14" name="TextBox 13"/>
           <p:cNvSpPr txBox="1"/>
           <p:nvPr/>
         </p:nvSpPr>
         <p:spPr>
           <a:xfrm>
-            <a:off x="7269480" y="4151376"/>
-            <a:ext cx="4373575" cy="868680"/>
+            <a:off x="7452360" y="4151376"/>
+            <a:ext cx="4190695" cy="868680"/>
           </a:xfrm>
           <a:prstGeom prst="rect">
             <a:avLst/>
@@ -15572,14 +15689,14 @@
                 </a:solidFill>
                 <a:latin typeface="Arial"/>
               </a:rPr>
-              <a:t>Protected land, tribal sites: checked by hand; consult early.</a:t>
-            </a:r>
-          </a:p>
-        </p:txBody>
-      </p:sp>
-      <p:sp>
-        <p:nvSpPr>
-          <p:cNvPr id="18" name="Win condition"/>
+              <a:t>Consult tribes early; no protected land within 5 km.</a:t>
+            </a:r>
+          </a:p>
+        </p:txBody>
+      </p:sp>
+      <p:sp>
+        <p:nvSpPr>
+          <p:cNvPr id="15" name="Win condition"/>
           <p:cNvSpPr/>
           <p:nvPr/>
         </p:nvSpPr>
@@ -15619,7 +15736,7 @@
                 </a:solidFill>
                 <a:latin typeface="Arial"/>
               </a:rPr>
-              <a:t>In 25-year dollars Grant ties Clark WA and Franklin NY. Each month of power delay costs about $25M.</a:t>
+              <a:t>Full 300 MW by about late 2029, near today's power price. Later or pricier, the three-way tie breaks against Grant.</a:t>
             </a:r>
           </a:p>
         </p:txBody>
@@ -15703,7 +15820,7 @@
           <a:p>
             <a:pPr algn="l"/>
             <a:r>
-              <a:rPr sz="1300" b="1" i="0">
+              <a:rPr sz="1400" b="1" i="0">
                 <a:solidFill>
                   <a:srgbClr val="0B3C6F"/>
                 </a:solidFill>
@@ -16617,8 +16734,8 @@
         </p:nvSpPr>
         <p:spPr>
           <a:xfrm>
-            <a:off x="548640" y="5212080"/>
-            <a:ext cx="11094415" cy="914400"/>
+            <a:off x="548640" y="5166360"/>
+            <a:ext cx="11094415" cy="1051560"/>
           </a:xfrm>
           <a:prstGeom prst="rect">
             <a:avLst/>
@@ -16646,8 +16763,8 @@
         </p:nvSpPr>
         <p:spPr>
           <a:xfrm>
-            <a:off x="548640" y="5212080"/>
-            <a:ext cx="73152" cy="914400"/>
+            <a:off x="548640" y="5166360"/>
+            <a:ext cx="73152" cy="1051560"/>
           </a:xfrm>
           <a:prstGeom prst="rect">
             <a:avLst/>
@@ -16675,8 +16792,8 @@
         </p:nvSpPr>
         <p:spPr>
           <a:xfrm>
-            <a:off x="822960" y="5321808"/>
-            <a:ext cx="10637215" cy="731520"/>
+            <a:off x="822960" y="5276088"/>
+            <a:ext cx="10637215" cy="868680"/>
           </a:xfrm>
           <a:prstGeom prst="rect">
             <a:avLst/>
@@ -16797,7 +16914,7 @@
           <a:p>
             <a:pPr algn="l"/>
             <a:r>
-              <a:rPr sz="1300" b="1" i="0">
+              <a:rPr sz="1400" b="1" i="0">
                 <a:solidFill>
                   <a:srgbClr val="0B3C6F"/>
                 </a:solidFill>
@@ -16902,7 +17019,7 @@
                 </a:solidFill>
                 <a:latin typeface="Arial"/>
               </a:rPr>
-              <a:t>Sources: engine/conditions/balanced.yaml with cooling: evaporative (rerun in docs/deck_build_log.md step 1); docs/demo_script.md; WRI Aqueduct 4.0 water stress.</a:t>
+              <a:t>Sources: engine/conditions/balanced.yaml with cooling: evaporative (docs/deck_build_log.md step 1); WRI Aqueduct 4.0. Screenshot (cropped): team cockpit (app/cockpit), ?preset=balanced&amp;cool=evaporative&amp;c=53025, main 23bb71c.</a:t>
             </a:r>
           </a:p>
         </p:txBody>
@@ -16942,34 +17059,63 @@
           </a:p>
         </p:txBody>
       </p:sp>
+      <p:pic>
+        <p:nvPicPr>
+          <p:cNvPr id="8" name="Picture 7" descr="cockpit_cooling_switch.png"/>
+          <p:cNvPicPr>
+            <a:picLocks noChangeAspect="1"/>
+          </p:cNvPicPr>
+          <p:nvPr/>
+        </p:nvPicPr>
+        <p:blipFill>
+          <a:blip r:embed="rId3"/>
+          <a:stretch>
+            <a:fillRect/>
+          </a:stretch>
+        </p:blipFill>
+        <p:spPr>
+          <a:xfrm>
+            <a:off x="548640" y="1965960"/>
+            <a:ext cx="3525818" cy="3154680"/>
+          </a:xfrm>
+          <a:prstGeom prst="rect">
+            <a:avLst/>
+          </a:prstGeom>
+          <a:ln w="12700">
+            <a:solidFill>
+              <a:srgbClr val="D3D8D6"/>
+            </a:solidFill>
+          </a:ln>
+        </p:spPr>
+      </p:pic>
       <p:graphicFrame>
         <p:nvGraphicFramePr>
-          <p:cNvPr id="8" name="Chart 7"/>
+          <p:cNvPr id="9" name="Chart 8"/>
           <p:cNvGraphicFramePr>
             <a:graphicFrameLocks noGrp="1"/>
           </p:cNvGraphicFramePr>
           <p:nvPr/>
         </p:nvGraphicFramePr>
         <p:xfrm>
-          <a:off x="548640" y="2011680"/>
-          <a:ext cx="5120640" cy="3017520"/>
+          <a:off x="4348778" y="1965960"/>
+          <a:ext cx="3383280" cy="3154680"/>
         </p:xfrm>
         <a:graphic>
           <a:graphicData uri="http://schemas.openxmlformats.org/drawingml/2006/chart">
-            <c:chart xmlns:c="http://schemas.openxmlformats.org/drawingml/2006/chart" r:id="rId3"/>
+            <c:chart xmlns:c="http://schemas.openxmlformats.org/drawingml/2006/chart" r:id="rId4"/>
           </a:graphicData>
         </a:graphic>
       </p:graphicFrame>
       <p:sp>
         <p:nvSpPr>
-          <p:cNvPr id="9" name="Bullets"/>
+          <p:cNvPr id="10" name="Bullets"/>
           <p:cNvSpPr txBox="1"/>
           <p:nvPr/>
         </p:nvSpPr>
         <p:spPr>
           <a:xfrm>
-            <a:off x="5989320" y="2103120"/>
-            <a:ext cx="5653735" cy="2651760"/>
+            <a:off x="8006378" y="2103120"/>
+            <a:ext cx="3636677" cy="2926080"/>
           </a:xfrm>
           <a:prstGeom prst="rect">
             <a:avLst/>
@@ -16987,7 +17133,7 @@
                 <a:spcPct val="105000"/>
               </a:lnSpc>
               <a:spcAft>
-                <a:spcPts val="1400"/>
+                <a:spcPts val="1200"/>
               </a:spcAft>
               <a:buClr>
                 <a:srgbClr val="0B3C6F"/>
@@ -16997,7 +17143,7 @@
               <a:buChar char="■"/>
             </a:pPr>
             <a:r>
-              <a:rPr sz="2000" b="0" i="0">
+              <a:rPr sz="1900" b="0" i="0">
                 <a:solidFill>
                   <a:srgbClr val="111518"/>
                 </a:solidFill>
@@ -17012,7 +17158,7 @@
                 <a:spcPct val="105000"/>
               </a:lnSpc>
               <a:spcAft>
-                <a:spcPts val="1400"/>
+                <a:spcPts val="1200"/>
               </a:spcAft>
               <a:buClr>
                 <a:srgbClr val="0B3C6F"/>
@@ -17022,13 +17168,13 @@
               <a:buChar char="■"/>
             </a:pPr>
             <a:r>
-              <a:rPr sz="2000" b="0" i="0">
+              <a:rPr sz="1900" b="0" i="0">
                 <a:solidFill>
                   <a:srgbClr val="111518"/>
                 </a:solidFill>
                 <a:latin typeface="Arial"/>
               </a:rPr>
-              <a:t>Grant (water stress 3.6 of 5) drops out.</a:t>
+              <a:t>Grant (3.6 of 5) drops out; the app says why.</a:t>
             </a:r>
           </a:p>
           <a:p>
@@ -17037,7 +17183,7 @@
                 <a:spcPct val="105000"/>
               </a:lnSpc>
               <a:spcAft>
-                <a:spcPts val="1400"/>
+                <a:spcPts val="1200"/>
               </a:spcAft>
               <a:buClr>
                 <a:srgbClr val="0B3C6F"/>
@@ -17047,27 +17193,27 @@
               <a:buChar char="■"/>
             </a:pPr>
             <a:r>
-              <a:rPr sz="2000" b="0" i="0">
+              <a:rPr sz="1900" b="0" i="0">
                 <a:solidFill>
                   <a:srgbClr val="111518"/>
                 </a:solidFill>
                 <a:latin typeface="Arial"/>
               </a:rPr>
-              <a:t>One conditions file in; ranked, explained shortlist out.</a:t>
-            </a:r>
-          </a:p>
-        </p:txBody>
-      </p:sp>
-      <p:sp>
-        <p:nvSpPr>
-          <p:cNvPr id="10" name="Hand-off"/>
+              <a:t>Wayne, TN leads instead.</a:t>
+            </a:r>
+          </a:p>
+        </p:txBody>
+      </p:sp>
+      <p:sp>
+        <p:nvSpPr>
+          <p:cNvPr id="11" name="Hand-off"/>
           <p:cNvSpPr/>
           <p:nvPr/>
         </p:nvSpPr>
         <p:spPr>
           <a:xfrm>
             <a:off x="548640" y="5257800"/>
-            <a:ext cx="11094415" cy="1051560"/>
+            <a:ext cx="11094415" cy="896112"/>
           </a:xfrm>
           <a:prstGeom prst="rect">
             <a:avLst/>

</xml_diff>

<commit_message>
Finish round 2 of the deck after the advisor's review
Merge the risk and plan slides, add Whitman to the dollar comparison,
correct the grid carbon range, describe farmland as crops and pasture,
and record the round in the build log.
</commit_message>
<xml_diff>
--- a/docs/deck/pitch_template.pptx
+++ b/docs/deck/pitch_template.pptx
@@ -19,7 +19,6 @@
     <p:sldId id="267" r:id="rId19"/>
     <p:sldId id="268" r:id="rId20"/>
     <p:sldId id="269" r:id="rId21"/>
-    <p:sldId id="270" r:id="rId22"/>
   </p:sldIdLst>
   <p:sldSz cx="12191695" cy="6858000" type="screen4x3"/>
   <p:notesSz cx="6858000" cy="9144000"/>
@@ -1754,7 +1753,7 @@
             <a:lstStyle/>
             <a:p>
               <a:pPr>
-                <a:defRPr sz="1800" b="1">
+                <a:defRPr sz="1700" b="1">
                   <a:solidFill>
                     <a:srgbClr val="111518"/>
                   </a:solidFill>
@@ -1771,7 +1770,7 @@
           <c:showBubbleSize val="0"/>
           <c:showLeaderLines val="1"/>
         </c:dLbls>
-        <c:gapWidth val="45"/>
+        <c:gapWidth val="35"/>
         <c:axId val="-2068027336"/>
         <c:axId val="-2113994440"/>
       </c:barChart>
@@ -1797,7 +1796,7 @@
           <a:lstStyle/>
           <a:p>
             <a:pPr>
-              <a:defRPr sz="1600">
+              <a:defRPr sz="1500">
                 <a:solidFill>
                   <a:srgbClr val="111518"/>
                 </a:solidFill>
@@ -1815,7 +1814,7 @@
       <c:valAx>
         <c:axId val="-2113994440"/>
         <c:scaling>
-          <c:max val="1300.0"/>
+          <c:max val="1350.0"/>
           <c:min val="0.0"/>
         </c:scaling>
         <c:delete/>
@@ -1834,7 +1833,7 @@
     <a:lstStyle/>
     <a:p>
       <a:pPr>
-        <a:defRPr sz="1600">
+        <a:defRPr sz="1500">
           <a:solidFill>
             <a:srgbClr val="46505A"/>
           </a:solidFill>
@@ -3085,27 +3084,7 @@
           <a:lstStyle/>
           <a:p>
             <a:r>
-              <a:t>AI is driving a boom in data center construction. Lawrence Berkeley National Lab found that data</a:t>
-            </a:r>
-          </a:p>
-          <a:p>
-            <a:r>
-              <a:t>centers used 4.4 percent of US electricity in 2023, and it expects 6.7 to 12 percent by 2028.</a:t>
-            </a:r>
-          </a:p>
-          <a:p>
-            <a:r>
-              <a:t>Communities are pushing back on where these go. This summer New York paused state permits for</a:t>
-            </a:r>
-          </a:p>
-          <a:p>
-            <a:r>
-              <a:t>large data centers over energy and water. A campus built today runs for 20 to 30 years, so the</a:t>
-            </a:r>
-          </a:p>
-          <a:p>
-            <a:r>
-              <a:t>county you choose sets its carbon, its water, and its power bill for decades.</a:t>
+              <a:t>AI is driving a boom in data center construction. Lawrence Berkeley National Lab found that data centers used 4.4 percent of US electricity in 2023, and it expects 6.7 to 12 percent by 2028. Communities are pushing back on where these go. This summer New York paused state permits for large data centers over energy and water. A campus built today runs for 20 to 30 years, so the county you choose sets its carbon, its water, and its power bill for decades.</a:t>
             </a:r>
           </a:p>
           <a:p/>
@@ -3126,7 +3105,7 @@
           </a:p>
           <a:p>
             <a:r>
-              <a:t>- Grid carbon varies about fourfold across candidate counties, 242 to 911 lb/MWh [[CHECK]] (research/impact.md, dry cooling table)</a:t>
+              <a:t>- Grid carbon across all counties, 242 to 1,397 lb/MWh, nearly sixfold [[CHECK]] (data/processed/county_features.parquet, grid_co2_lb_mwh (eGRID2023 subregions))</a:t>
             </a:r>
           </a:p>
           <a:p/>
@@ -3212,63 +3191,44 @@
           <a:lstStyle/>
           <a:p>
             <a:r>
-              <a:t>With seven factors, Berkshire County, Massachusetts ranked first and Grant seventh. Massachusetts closed the tax break Berkshire relied on, and it fell to</a:t>
-            </a:r>
-          </a:p>
-          <a:p>
-            <a:r>
-              <a:t>27th. When we added the cost of power as its own factor, Grant rose to first and Berkshire fell</a:t>
-            </a:r>
-          </a:p>
-          <a:p>
-            <a:r>
-              <a:t>to 1,164th. Then the price check cut against us. A new load this size won't get today's</a:t>
-            </a:r>
-          </a:p>
-          <a:p>
-            <a:r>
-              <a:t>average price, and if only Washington pays BPA's new-load rate, Grant falls to 77th.</a:t>
-            </a:r>
-          </a:p>
-          <a:p>
-            <a:r>
-              <a:t>We also tested a machine-learning model of permitting outcomes and dropped it, because out of</a:t>
-            </a:r>
-          </a:p>
-          <a:p>
-            <a:r>
-              <a:t>sample it did no better than chance.</a:t>
+              <a:t>Scores out of 100 can hide physical differences. At regional grid rates, Franklin County, New York emits 2.7 times less CO2 than Grant, yet their carbon scores are 80.4 and 70.4, the 99th and 94th percentiles. So for the leaders we also price everything in dollars and tons over 25 years. In that model energy and carbon carry 67 to 88 percent of the cost differences between counties, depending on the carbon price. Our balanced weights give them about 30 percent.</a:t>
             </a:r>
           </a:p>
           <a:p/>
           <a:p>
             <a:r>
+              <a:t>If someone asks, with BPA-like supply Grant drops to about 236 thousand tons, below Franklin.</a:t>
+            </a:r>
+          </a:p>
+          <a:p/>
+          <a:p>
+            <a:r>
               <a:t>Where the numbers come from. [[CHECK]] marks a number that could change tonight.</a:t>
             </a:r>
           </a:p>
           <a:p>
             <a:r>
-              <a:t>- Berkshire ranks by step, 1 / 27 / 1164 [[CHECK]] (docs/figures/facts.json, pick_story.ranks['Berkshire, MA'])</a:t>
-            </a:r>
-          </a:p>
-          <a:p>
-            <a:r>
-              <a:t>- Grant ranks by step, 7 / 7 / 1 [[CHECK]] (docs/figures/facts.json, pick_story.ranks['Grant, WA'])</a:t>
-            </a:r>
-          </a:p>
-          <a:p>
-            <a:r>
-              <a:t>- Grant rank with only WA at BPA's $80 per MWh, 77 [[CHECK]] (docs/deck_build_log.md, step 4 price rerun)</a:t>
-            </a:r>
-          </a:p>
-          <a:p>
-            <a:r>
-              <a:t>- Grant energy cost at BPA's new-load rate, $196M to $323M a year [[CHECK]] (docs/figures/facts.json, grant_ranges.energy_cost_musd)</a:t>
-            </a:r>
-          </a:p>
-          <a:p>
-            <a:r>
-              <a:t>- Permitting model AUC without facility counts, 0.48 to 0.585, below a 0.60 bar [[CHECK]] (research/permitting_model.md)</a:t>
+              <a:t>- Carbon score, Grant, 70.4 (93.6th percentile) [[CHECK]] (docs/deck_build_log.md, step 4)</a:t>
+            </a:r>
+          </a:p>
+          <a:p>
+            <a:r>
+              <a:t>- Carbon score, Franklin, 80.4 (98.7th percentile) [[CHECK]] (docs/deck_build_log.md, step 4)</a:t>
+            </a:r>
+          </a:p>
+          <a:p>
+            <a:r>
+              <a:t>- CO2, Grant at the regional average, 700,390 t a year [[CHECK]] (docs/figures/facts.json, grant_ranges.co2_tonnes.nwpp_table)</a:t>
+            </a:r>
+          </a:p>
+          <a:p>
+            <a:r>
+              <a:t>- CO2, Franklin, 262,168 t a year [[CHECK]] (research/impact.md, dry cooling table)</a:t>
+            </a:r>
+          </a:p>
+          <a:p>
+            <a:r>
+              <a:t>- Energy and carbon share of cost differences, 67%, 78%, 88% at $0, $190, $300 per ton, published source (docs/weighting.md, Variance shares)</a:t>
             </a:r>
           </a:p>
         </p:txBody>
@@ -3338,38 +3298,13 @@
           <a:lstStyle/>
           <a:p>
             <a:r>
-              <a:t>Scores out of 100 can hide physical differences. At regional grid rates, Franklin County, New York</a:t>
-            </a:r>
-          </a:p>
-          <a:p>
-            <a:r>
-              <a:t>emits 2.7 times less CO2 than Grant, yet their carbon scores are 80.4 and 70.4, the</a:t>
-            </a:r>
-          </a:p>
-          <a:p>
-            <a:r>
-              <a:t>99th and 94th percentiles. So for the leaders we also price everything in dollars and</a:t>
-            </a:r>
-          </a:p>
-          <a:p>
-            <a:r>
-              <a:t>tonnes over 25 years. In that model energy and carbon carry 67 to 88 percent of the cost differences</a:t>
-            </a:r>
-          </a:p>
-          <a:p>
-            <a:r>
-              <a:t>between counties, depending on the carbon price. Our balanced weights give them about 30 percent.</a:t>
+              <a:t>In the 25-year dollar model, four leading counties land within 3 percent of each other at today's prices, so the model can't really separate them. Whitman is the cheapest, but its time to power uses a national-median assumption, not research. Clark wins over Grant if its parcel avoids the transit district's higher sales tax and it gets power in about two and a quarter years. Grant holds up if its power arrives within about a year of a two-year baseline. Franklin needs New York's data center tax exemption, which probably doesn't cover an AI training campus.</a:t>
             </a:r>
           </a:p>
           <a:p/>
           <a:p>
             <a:r>
-              <a:t>If someone asks, with BPA-like supply Grant drops to about 236 thousand</a:t>
-            </a:r>
-          </a:p>
-          <a:p>
-            <a:r>
-              <a:t>tons, below Franklin.</a:t>
+              <a:t>If someone asks about cheaper states, with sales tax the states that exempt all equipment price cheaper, but those flags in our state table aren't verified.</a:t>
             </a:r>
           </a:p>
           <a:p/>
@@ -3380,27 +3315,37 @@
           </a:p>
           <a:p>
             <a:r>
-              <a:t>- Carbon score, Grant, 70.4 (93.6th percentile) [[CHECK]] (docs/deck_build_log.md, step 4)</a:t>
-            </a:r>
-          </a:p>
-          <a:p>
-            <a:r>
-              <a:t>- Carbon score, Franklin, 80.4 (98.7th percentile) [[CHECK]] (docs/deck_build_log.md, step 4)</a:t>
-            </a:r>
-          </a:p>
-          <a:p>
-            <a:r>
-              <a:t>- CO2, Grant at the regional average, 700,390 t a year [[CHECK]] (docs/figures/facts.json, grant_ranges.co2_tonnes.nwpp_table)</a:t>
-            </a:r>
-          </a:p>
-          <a:p>
-            <a:r>
-              <a:t>- CO2, Franklin, 262,168 t a year [[CHECK]] (research/impact.md, dry cooling table)</a:t>
-            </a:r>
-          </a:p>
-          <a:p>
-            <a:r>
-              <a:t>- Energy and carbon share of cost differences, 67%, 78%, 88% at $0, $190, $300 per ton, published source (docs/weighting.md, Variance shares)</a:t>
+              <a:t>- 25-year cost, Whitman, WA, $4.330B [[CHECK]] (docs/weighting.md and scratch/weighting/out/monetized_costs.csv, total_190)</a:t>
+            </a:r>
+          </a:p>
+          <a:p>
+            <a:r>
+              <a:t>- 25-year cost, Clark, WA, $4.405B [[CHECK]] (docs/weighting.md and scratch/weighting/out/monetized_costs.csv, total_190)</a:t>
+            </a:r>
+          </a:p>
+          <a:p>
+            <a:r>
+              <a:t>- 25-year cost, Grant, WA, $4.452B [[CHECK]] (docs/weighting.md and scratch/weighting/out/monetized_costs.csv, total_190)</a:t>
+            </a:r>
+          </a:p>
+          <a:p>
+            <a:r>
+              <a:t>- 25-year cost, Franklin, NY, $4.454B [[CHECK]] (docs/weighting.md and scratch/weighting/out/monetized_costs.csv, total_190)</a:t>
+            </a:r>
+          </a:p>
+          <a:p>
+            <a:r>
+              <a:t>- Whitman time to power, national median queue age, 2.89 years (imputed) [[CHECK]] (scratch/weighting/out/monetized_costs.csv, queue_age_used, queue_imputed)</a:t>
+            </a:r>
+          </a:p>
+          <a:p>
+            <a:r>
+              <a:t>- Grant break-even with Clark and Franklin, 10.2 and 12.1 months [[CHECK]] (docs/weighting.md, Grant's row)</a:t>
+            </a:r>
+          </a:p>
+          <a:p>
+            <a:r>
+              <a:t>- Malone distance to the Adirondack Blue Line, 6.1 km [[CHECK]] (research/sensitive_land.md, Franklin County)</a:t>
             </a:r>
           </a:p>
         </p:txBody>
@@ -3470,79 +3415,28 @@
           <a:lstStyle/>
           <a:p>
             <a:r>
-              <a:t>In the 25-year dollar model, Clark, Grant, and Franklin land within 1.1 percent of each other at</a:t>
-            </a:r>
-          </a:p>
-          <a:p>
-            <a:r>
-              <a:t>today's prices, so the model can't separate them. Grant wins if its power arrives within about a year</a:t>
-            </a:r>
-          </a:p>
-          <a:p>
-            <a:r>
-              <a:t>of a two-year baseline. Clark wins if its parcel avoids the transit district's higher sales tax and it</a:t>
-            </a:r>
-          </a:p>
-          <a:p>
-            <a:r>
-              <a:t>gets power in about two and a quarter years. Franklin wins if New York's data center tax exemption</a:t>
-            </a:r>
-          </a:p>
-          <a:p>
-            <a:r>
-              <a:t>applies, which probably doesn't cover an AI training campus. None of the three has a land conflict</a:t>
-            </a:r>
-          </a:p>
-          <a:p>
-            <a:r>
-              <a:t>at its reference site.</a:t>
+              <a:t>All 3,109 counties are scored from public sources joined into one county table. This round added USGS protected areas, NLCD land cover, and Census tribal boundaries. Four inputs are proxies, and we say so. Home fiber stands in for backbone fiber, plants within 100 kilometers stand in for power a new load can actually get, a state average price stands in for what a new load pays, and a heat-demand score stands in for heat reuse. 39 of 45 planned columns have data, so coverage across the top 10 is 84 to 87 percent.</a:t>
             </a:r>
           </a:p>
           <a:p/>
           <a:p>
             <a:r>
-              <a:t>If someone asks about cheaper states, with sales tax the states that exempt all equipment price</a:t>
-            </a:r>
-          </a:p>
-          <a:p>
-            <a:r>
-              <a:t>cheaper, but those flags in our state table aren't verified.</a:t>
-            </a:r>
-          </a:p>
-          <a:p/>
-          <a:p>
-            <a:r>
               <a:t>Where the numbers come from. [[CHECK]] marks a number that could change tonight.</a:t>
             </a:r>
           </a:p>
           <a:p>
             <a:r>
-              <a:t>- 25-year cost, Clark, WA, $4.405B [[CHECK]] (docs/weighting.md, Recommendation table)</a:t>
-            </a:r>
-          </a:p>
-          <a:p>
-            <a:r>
-              <a:t>- 25-year cost, Grant, WA, $4.452B [[CHECK]] (docs/weighting.md, Recommendation table)</a:t>
-            </a:r>
-          </a:p>
-          <a:p>
-            <a:r>
-              <a:t>- 25-year cost, Franklin, NY, $4.454B [[CHECK]] (docs/weighting.md, Recommendation table)</a:t>
-            </a:r>
-          </a:p>
-          <a:p>
-            <a:r>
-              <a:t>- Grant break-even with Clark and Franklin, 10.2 and 12.1 months [[CHECK]] (docs/weighting.md, Grant's row)</a:t>
-            </a:r>
-          </a:p>
-          <a:p>
-            <a:r>
-              <a:t>- Franklin share inside the Adirondack Park, 68% [[CHECK]] (research/sensitive_land.md, Franklin County)</a:t>
-            </a:r>
-          </a:p>
-          <a:p>
-            <a:r>
-              <a:t>- Malone distance to the Blue Line, 6.1 km [[CHECK]] (research/sensitive_land.md, Franklin County)</a:t>
+              <a:t>- Counties, 3,109 [[CHECK]] (docs/figures/facts.json, balanced.counties)</a:t>
+            </a:r>
+          </a:p>
+          <a:p>
+            <a:r>
+              <a:t>- Columns with data, of those planned, 39 of 45 [[CHECK]] (docs/figures/facts.json, limitations.scored_columns_present and scored_columns_mapped)</a:t>
+            </a:r>
+          </a:p>
+          <a:p>
+            <a:r>
+              <a:t>- Coverage across the top 10, 0.84 to 0.87 [[CHECK]] (docs/figures/facts.json, limitations.coverage_top10)</a:t>
             </a:r>
           </a:p>
         </p:txBody>
@@ -3612,37 +3506,7 @@
           <a:lstStyle/>
           <a:p>
             <a:r>
-              <a:t>All 3,109 counties are scored from public sources joined into one county table. This round</a:t>
-            </a:r>
-          </a:p>
-          <a:p>
-            <a:r>
-              <a:t>added USGS protected areas, NLCD land cover, and Census tribal boundaries. Four inputs are proxies,</a:t>
-            </a:r>
-          </a:p>
-          <a:p>
-            <a:r>
-              <a:t>and we say so. Home fiber stands in for backbone fiber, plants within 100 kilometers stand in for</a:t>
-            </a:r>
-          </a:p>
-          <a:p>
-            <a:r>
-              <a:t>power a new load can actually get, a state average price stands in for what a new load pays, and a</a:t>
-            </a:r>
-          </a:p>
-          <a:p>
-            <a:r>
-              <a:t>heat-demand score stands in for heat reuse. 39 of</a:t>
-            </a:r>
-          </a:p>
-          <a:p>
-            <a:r>
-              <a:t>45 planned columns have data, so coverage across the top 10 is</a:t>
-            </a:r>
-          </a:p>
-          <a:p>
-            <a:r>
-              <a:t>84 to 87 percent.</a:t>
+              <a:t>Three limits matter most. First, protected land, tribal land, and land cover are county shares. They're a screen, not a siting check. A 150-acre campus can avoid protected land inside a county, so parcel checks belong in feasibility. Second, scoring against the nation stretches small gaps. Whitman is 0.2 percent protected and Grant 12.8 percent, and that ends up about 89 percentile points apart. Third, Grant leads Whitman by 0.01 points, which is a tie. The engine also sees installed generation and average prices, which a new 300 megawatt load won't get.</a:t>
             </a:r>
           </a:p>
           <a:p/>
@@ -3653,17 +3517,22 @@
           </a:p>
           <a:p>
             <a:r>
-              <a:t>- Counties, 3,109 [[CHECK]] (docs/figures/facts.json, balanced.counties)</a:t>
-            </a:r>
-          </a:p>
-          <a:p>
-            <a:r>
-              <a:t>- Columns with data, of those planned, 39 of 45 [[CHECK]] (docs/figures/facts.json, limitations.scored_columns_present and scored_columns_mapped)</a:t>
-            </a:r>
-          </a:p>
-          <a:p>
-            <a:r>
-              <a:t>- Coverage across the top 10, 0.84 to 0.87 [[CHECK]] (docs/figures/facts.json, limitations.coverage_top10)</a:t>
+              <a:t>- Grant lead over Whitman, 0.01 points [[CHECK]] (results/balanced.csv, composite)</a:t>
+            </a:r>
+          </a:p>
+          <a:p>
+            <a:r>
+              <a:t>- Protected share, Whitman and Grant, 0.2% and 12.8%, about 89 percentile points apart [[CHECK]] (research/sensitive_land.md, County shares in the engine)</a:t>
+            </a:r>
+          </a:p>
+          <a:p>
+            <a:r>
+              <a:t>- Plant capacity within 100 km of Grant, 16,193 MW [[CHECK]] (docs/figures/facts.json, limitations.featured_plant_capacity_mw_100km)</a:t>
+            </a:r>
+          </a:p>
+          <a:p>
+            <a:r>
+              <a:t>- Loudoun VA, fails the queue age limit (max_queue_median_age_years) [[CHECK]] (docs/figures/facts.json, limitations.loudoun_va)</a:t>
             </a:r>
           </a:p>
         </p:txBody>
@@ -3733,153 +3602,7 @@
           <a:lstStyle/>
           <a:p>
             <a:r>
-              <a:t>Three limits matter most. First, protected land, tribal land, and land cover are county shares. They're</a:t>
-            </a:r>
-          </a:p>
-          <a:p>
-            <a:r>
-              <a:t>a screen, not a siting check. A 150-acre campus can avoid protected land inside a county, so parcel</a:t>
-            </a:r>
-          </a:p>
-          <a:p>
-            <a:r>
-              <a:t>checks belong in feasibility. Second, scoring against the nation stretches small gaps. Whitman is 0.2</a:t>
-            </a:r>
-          </a:p>
-          <a:p>
-            <a:r>
-              <a:t>percent protected and Grant 12.8 percent, and that ends up about 89 percentile points apart. Third,</a:t>
-            </a:r>
-          </a:p>
-          <a:p>
-            <a:r>
-              <a:t>Grant leads Whitman by 0.01 points, which is a tie. The engine also sees installed</a:t>
-            </a:r>
-          </a:p>
-          <a:p>
-            <a:r>
-              <a:t>generation and average prices, which a new 300 megawatt load won't get.</a:t>
-            </a:r>
-          </a:p>
-          <a:p/>
-          <a:p>
-            <a:r>
-              <a:t>Where the numbers come from. [[CHECK]] marks a number that could change tonight.</a:t>
-            </a:r>
-          </a:p>
-          <a:p>
-            <a:r>
-              <a:t>- Grant lead over Whitman, 0.01 points [[CHECK]] (results/balanced.csv, composite)</a:t>
-            </a:r>
-          </a:p>
-          <a:p>
-            <a:r>
-              <a:t>- Protected share, Whitman and Grant, 0.2% and 12.8%, about 89 percentile points apart [[CHECK]] (research/sensitive_land.md, County shares in the engine)</a:t>
-            </a:r>
-          </a:p>
-          <a:p>
-            <a:r>
-              <a:t>- Plant capacity within 100 km of Grant, 16,193 MW [[CHECK]] (docs/figures/facts.json, limitations.featured_plant_capacity_mw_100km)</a:t>
-            </a:r>
-          </a:p>
-          <a:p>
-            <a:r>
-              <a:t>- Loudoun VA, fails the queue age limit (max_queue_median_age_years) [[CHECK]] (docs/figures/facts.json, limitations.loudoun_va)</a:t>
-            </a:r>
-          </a:p>
-        </p:txBody>
-      </p:sp>
-      <p:sp>
-        <p:nvSpPr>
-          <p:cNvPr id="4" name="Slide Number Placeholder 3"/>
-          <p:cNvSpPr>
-            <a:spLocks noGrp="1"/>
-          </p:cNvSpPr>
-          <p:nvPr>
-            <p:ph type="sldNum" idx="5" sz="quarter"/>
-          </p:nvPr>
-        </p:nvSpPr>
-        <p:spPr/>
-      </p:sp>
-    </p:spTree>
-  </p:cSld>
-  <p:clrMapOvr>
-    <a:masterClrMapping/>
-  </p:clrMapOvr>
-</p:notes>
-</file>
-
-<file path=ppt/notesSlides/notesSlide15.xml><?xml version="1.0" encoding="utf-8"?>
-<p:notes xmlns:a="http://schemas.openxmlformats.org/drawingml/2006/main" xmlns:p="http://schemas.openxmlformats.org/presentationml/2006/main" xmlns:r="http://schemas.openxmlformats.org/officeDocument/2006/relationships">
-  <p:cSld>
-    <p:spTree>
-      <p:nvGrpSpPr>
-        <p:cNvPr id="1" name=""/>
-        <p:cNvGrpSpPr/>
-        <p:nvPr/>
-      </p:nvGrpSpPr>
-      <p:grpSpPr>
-        <a:xfrm>
-          <a:off x="0" y="0"/>
-          <a:ext cx="0" cy="0"/>
-          <a:chOff x="0" y="0"/>
-          <a:chExt cx="0" cy="0"/>
-        </a:xfrm>
-      </p:grpSpPr>
-      <p:sp>
-        <p:nvSpPr>
-          <p:cNvPr id="2" name="Slide Image Placeholder 1"/>
-          <p:cNvSpPr>
-            <a:spLocks noGrp="1"/>
-          </p:cNvSpPr>
-          <p:nvPr>
-            <p:ph type="sldImg" idx="2"/>
-          </p:nvPr>
-        </p:nvSpPr>
-        <p:spPr/>
-      </p:sp>
-      <p:sp>
-        <p:nvSpPr>
-          <p:cNvPr id="3" name="Notes Placeholder 2"/>
-          <p:cNvSpPr>
-            <a:spLocks noGrp="1"/>
-          </p:cNvSpPr>
-          <p:nvPr>
-            <p:ph type="body" idx="3" sz="quarter"/>
-          </p:nvPr>
-        </p:nvSpPr>
-        <p:spPr/>
-        <p:txBody>
-          <a:bodyPr/>
-          <a:lstStyle/>
-          <a:p>
-            <a:r>
-              <a:t>Two extensions. The same engine ranked 196 countries after about 40 lines of change, and</a:t>
-            </a:r>
-          </a:p>
-          <a:p>
-            <a:r>
-              <a:t>83 pass the limits, led by Sweden, Switzerland, and Norway. That shows the method carries to</a:t>
-            </a:r>
-          </a:p>
-          <a:p>
-            <a:r>
-              <a:t>another region. It isn't a country recommendation, because there's no open global power price. The</a:t>
-            </a:r>
-          </a:p>
-          <a:p>
-            <a:r>
-              <a:t>second extension adds unscored context after the ranking. Boone County, Illinois lost almost three</a:t>
-            </a:r>
-          </a:p>
-          <a:p>
-            <a:r>
-              <a:t>quarters of its manufacturing jobs after the Belvidere plant went idle. Economic need isn't evidence</a:t>
-            </a:r>
-          </a:p>
-          <a:p>
-            <a:r>
-              <a:t>of community support, so local engagement is still required.</a:t>
+              <a:t>Two extensions. The same engine ranked 196 countries after about 40 lines of change, and 83 pass the limits, led by Sweden, Switzerland, and Norway. That shows the method carries to another region. It isn't a country recommendation, because there's no open global power price. The second extension adds unscored context after the ranking. Boone County, Illinois lost almost three quarters of its manufacturing jobs after the Belvidere plant went idle. Economic need isn't evidence of community support, so local engagement is still required.</a:t>
             </a:r>
           </a:p>
           <a:p/>
@@ -3970,48 +3693,13 @@
           <a:lstStyle/>
           <a:p>
             <a:r>
-              <a:t>So we built a tool for that choice. You describe the project, meaning its size, how it's cooled,</a:t>
-            </a:r>
-          </a:p>
-          <a:p>
-            <a:r>
-              <a:t>the limits you won't cross, and how much each factor matters to you. The tool screens all 3,109</a:t>
-            </a:r>
-          </a:p>
-          <a:p>
-            <a:r>
-              <a:t>counties in the lower 48. Hard limits like flood risk, wildfire, fiber, and the wait for a grid</a:t>
-            </a:r>
-          </a:p>
-          <a:p>
-            <a:r>
-              <a:t>connection rule out about half. Eight factors then score the rest against the nation, and a</a:t>
-            </a:r>
-          </a:p>
-          <a:p>
-            <a:r>
-              <a:t>county that's weak on any one of them drops below the others. You get a ranked shortlist, and</a:t>
-            </a:r>
-          </a:p>
-          <a:p>
-            <a:r>
-              <a:t>every rank comes with its reasons.</a:t>
+              <a:t>So we built a tool for that choice. You describe the project, meaning its size, how it's cooled, the limits you won't cross, and how much each factor matters to you. The tool screens all 3,109 counties in the lower 48. Hard limits like flood risk, wildfire, fiber, and the wait for a grid connection rule out about half. Eight factors then score the rest against the nation, and a county that's weak on any one of them drops below the others. You get a ranked shortlist, and every rank comes with its reasons.</a:t>
             </a:r>
           </a:p>
           <a:p/>
           <a:p>
             <a:r>
-              <a:t>If someone asks whether this is machine learning, it isn't. The weights are stated and anyone</a:t>
-            </a:r>
-          </a:p>
-          <a:p>
-            <a:r>
-              <a:t>can change them. The only model we built was for permitting, and we dropped it because it failed</a:t>
-            </a:r>
-          </a:p>
-          <a:p>
-            <a:r>
-              <a:t>out of sample.</a:t>
+              <a:t>If someone asks whether this is machine learning, it isn't. The weights are stated and anyone can change them. The only model we built was for permitting, and we dropped it because it failed out of sample.</a:t>
             </a:r>
           </a:p>
           <a:p/>
@@ -4107,79 +3795,19 @@
           <a:lstStyle/>
           <a:p>
             <a:r>
-              <a:t>The challenge asks about proximity to sensitive areas and ecosystems, so we added it. The tool now</a:t>
-            </a:r>
-          </a:p>
-          <a:p>
-            <a:r>
-              <a:t>reads how much of each county is protected for wildlife, how much is farmed, how much is built up,</a:t>
-            </a:r>
-          </a:p>
-          <a:p>
-            <a:r>
-              <a:t>and how much is forest or wetland, and each one now counts in the score. Grant shows the trade.</a:t>
-            </a:r>
-          </a:p>
-          <a:p>
-            <a:r>
-              <a:t>It's 43 percent cropland and 13 percent protected, so its land score fell from 75 to 53. It has</a:t>
-            </a:r>
-          </a:p>
-          <a:p>
-            <a:r>
-              <a:t>almost no forest or wetland, so permitting rose from 53 to 63.</a:t>
+              <a:t>The challenge asks about proximity to sensitive areas and ecosystems, so we added it. The tool now reads how much of each county is protected for wildlife, how much is farmed, how much is built up, and how much is forest or wetland, and each one now counts in the score. Grant shows the trade. It's 43 percent farmland, counting crops and pasture, and 13 percent protected, so its land score fell from 75 to 53. It has almost no forest or wetland, so permitting rose from 53 to 63.</a:t>
             </a:r>
           </a:p>
           <a:p/>
           <a:p>
             <a:r>
-              <a:t>If someone asks about farmland, large campuses often land on it because developers want flat,</a:t>
-            </a:r>
-          </a:p>
-          <a:p>
-            <a:r>
-              <a:t>big parcels near roads and transmission. That's a habit, not a need. Soil quality does nothing</a:t>
-            </a:r>
-          </a:p>
-          <a:p>
-            <a:r>
-              <a:t>for a data center, and old power plant sites or industrial parks can work as well. The tool</a:t>
-            </a:r>
-          </a:p>
-          <a:p>
-            <a:r>
-              <a:t>measures land cover, not prime soil. Building on farmland usually harms habitat less than wild</a:t>
-            </a:r>
-          </a:p>
-          <a:p>
-            <a:r>
-              <a:t>land does, but it uses up farmland, so we leave the balance to the user. In our opposition</a:t>
-            </a:r>
-          </a:p>
-          <a:p>
-            <a:r>
-              <a:t>dataset farmland comes up in 7 of 100 cases with stated reasons, mostly inferred from text. The</a:t>
-            </a:r>
-          </a:p>
-          <a:p>
-            <a:r>
-              <a:t>top reasons are zoning process, water, and grid strain.</a:t>
+              <a:t>If someone asks about farmland, large campuses often land on it because developers want flat, big parcels near roads and transmission. That's a habit, not a need. Soil quality does nothing for a data center, and old power plant sites or industrial parks can work as well. The tool measures land cover, not prime soil. Building on farmland usually harms habitat less than wild land does, but it uses up farmland, so we leave the balance to the user. In our opposition dataset farmland comes up in 7 of 100 cases with stated reasons, mostly inferred from text. The top reasons are zoning process, water, and grid strain.</a:t>
             </a:r>
           </a:p>
           <a:p/>
           <a:p>
             <a:r>
-              <a:t>If someone asks whether one input drives Grant's rank, scored alone protected land would drop</a:t>
-            </a:r>
-          </a:p>
-          <a:p>
-            <a:r>
-              <a:t>Grant to 4th and cropland alone to 2nd. Together, as designed, they offset. The protected and</a:t>
-            </a:r>
-          </a:p>
-          <a:p>
-            <a:r>
-              <a:t>tribal land limits are off in every preset.</a:t>
+              <a:t>If someone asks whether one input drives Grant's rank, scored alone protected land would drop Grant to 4th and cropland alone to 2nd. Together, as designed, they offset. The protected and tribal land limits are off in every preset.</a:t>
             </a:r>
           </a:p>
           <a:p/>
@@ -4200,7 +3828,7 @@
           </a:p>
           <a:p>
             <a:r>
-              <a:t>- Grant cropland share, 42.9% [[CHECK]] (research/sensitive_land.md, County shares table)</a:t>
+              <a:t>- Grant farmland share (crops and pasture, NLCD 81 and 82), 42.9% [[CHECK]] (research/sensitive_land.md, County shares table)</a:t>
             </a:r>
           </a:p>
           <a:p>
@@ -4285,38 +3913,13 @@
           <a:lstStyle/>
           <a:p>
             <a:r>
-              <a:t>With balanced weights, Grant and Whitman counties in eastern Washington come out level, 63.70 to 63.69. Under equal weights Whitman</a:t>
-            </a:r>
-          </a:p>
-          <a:p>
-            <a:r>
-              <a:t>comes first and Grant second. We use Grant as our worked example because it already hosts the</a:t>
-            </a:r>
-          </a:p>
-          <a:p>
-            <a:r>
-              <a:t>Quincy data center cluster, and its power timeline and tax status are documented. It comes with a</a:t>
-            </a:r>
-          </a:p>
-          <a:p>
-            <a:r>
-              <a:t>condition. The campus has to be sited next to hydro, powered by new clean supply the project</a:t>
-            </a:r>
-          </a:p>
-          <a:p>
-            <a:r>
-              <a:t>funds, because none of the utility's existing hydro is spare.</a:t>
+              <a:t>With balanced weights, Grant and Whitman counties in eastern Washington come out level, 63.70 to 63.69. Under equal weights Whitman comes first and Grant second. We use Grant as our worked example because it already hosts the Quincy data center cluster, and its power timeline and tax status are documented. It comes with a condition. The campus has to be sited next to hydro, powered by new clean supply the project funds, because none of the utility's existing hydro is spare.</a:t>
             </a:r>
           </a:p>
           <a:p/>
           <a:p>
             <a:r>
-              <a:t>If someone asks why not Whitman, it's a fair alternative with almost no protected land and no</a:t>
-            </a:r>
-          </a:p>
-          <a:p>
-            <a:r>
-              <a:t>water stress. We don't have the same site research for it yet.</a:t>
+              <a:t>If someone asks why not Whitman, it's a fair alternative with almost no protected land and no water stress. In the 25-year dollar model it's a little cheaper than Grant, .33 billion against .45 billion, but its power timeline is a national-median assumption, and we haven't done the same site research for it yet.</a:t>
             </a:r>
           </a:p>
           <a:p/>
@@ -4423,53 +4026,13 @@
           <a:lstStyle/>
           <a:p>
             <a:r>
-              <a:t>The obvious question is whether we picked weights that make our example win. So we stopped</a:t>
-            </a:r>
-          </a:p>
-          <a:p>
-            <a:r>
-              <a:t>choosing. We drew 5,000 random weightings and counted how often each county makes the top 10.</a:t>
-            </a:r>
-          </a:p>
-          <a:p>
-            <a:r>
-              <a:t>Whitman does most often, at 43.9 percent, and Grant sits in a close group</a:t>
-            </a:r>
-          </a:p>
-          <a:p>
-            <a:r>
-              <a:t>around 36 percent. Near our own weights Grant stays in the top 10 almost every time. When we priced</a:t>
-            </a:r>
-          </a:p>
-          <a:p>
-            <a:r>
-              <a:t>every county in dollars, energy and carbon drove most of the differences. We didn't tune the weights to get an answer. We tested</a:t>
-            </a:r>
-          </a:p>
-          <a:p>
-            <a:r>
-              <a:t>how much the answer depends on them.</a:t>
+              <a:t>Did we pick weights that make our example win? Instead of defending one set of weights, we drew 5,000 random weightings and counted how often each county makes the top 10. Whitman does most often, at 43.9 percent, and Grant sits in a close group around 36 percent. Near our own weights, Grant and Whitman both stay in the top 10 almost every time. So the tool shows you the spread and lets you pick the weights. We didn't tune the weights to get an answer. We tested how much the answer depends on them.</a:t>
             </a:r>
           </a:p>
           <a:p/>
           <a:p>
             <a:r>
-              <a:t>If someone asks why these weights, we compared five methods. A 25-year dollar model, random</a:t>
-            </a:r>
-          </a:p>
-          <a:p>
-            <a:r>
-              <a:t>weightings, two data-driven methods, and where industry has already built. Energy and carbon carry</a:t>
-            </a:r>
-          </a:p>
-          <a:p>
-            <a:r>
-              <a:t>67 to 88 percent of the dollar differences, depending on the carbon price. Our balanced weights give</a:t>
-            </a:r>
-          </a:p>
-          <a:p>
-            <a:r>
-              <a:t>them about 30 percent.</a:t>
+              <a:t>If someone asks why these weights, we compared five methods. A 25-year dollar model, random weightings, two data-driven methods, and where industry has already built. Energy and carbon carry 67 to 88 percent of the dollar differences, depending on the carbon price. Our balanced weights give them about 30 percent.</a:t>
             </a:r>
           </a:p>
           <a:p/>
@@ -4506,6 +4069,16 @@
           <a:p>
             <a:r>
               <a:t>- Grant in the top 10 near balanced weights, 99.95% [[CHECK]] (docs/figures/facts.json, featured.robustness (2,000 small perturbations))</a:t>
+            </a:r>
+          </a:p>
+          <a:p>
+            <a:r>
+              <a:t>- Whitman in the top 10 near balanced weights, 99.4% [[CHECK]] (docs/figures/facts.json, top10[1].robustness)</a:t>
+            </a:r>
+          </a:p>
+          <a:p>
+            <a:r>
+              <a:t>- Rank under equal weights, Grant 2nd, Whitman 1st [[CHECK]] (docs/figures/facts.json, weights.equal_weights_featured_rank)</a:t>
             </a:r>
           </a:p>
           <a:p>
@@ -4585,58 +4158,13 @@
           <a:lstStyle/>
           <a:p>
             <a:r>
-              <a:t>Against Loudoun County, Virginia, where much of the industry builds today, the example holds up</a:t>
-            </a:r>
-          </a:p>
-          <a:p>
-            <a:r>
-              <a:t>well on water. An evaporatively cooled campus in Grant would use about</a:t>
-            </a:r>
-          </a:p>
-          <a:p>
-            <a:r>
-              <a:t>210 million gallons of water a year. Dry cooling brings that to about</a:t>
-            </a:r>
-          </a:p>
-          <a:p>
-            <a:r>
-              <a:t>28 million, an 87 percent cut, for about 2 percent more</a:t>
-            </a:r>
-          </a:p>
-          <a:p>
-            <a:r>
-              <a:t>energy. Carbon depends on the power that serves the campus. Before its own clean supply comes</a:t>
-            </a:r>
-          </a:p>
-          <a:p>
-            <a:r>
-              <a:t>online, it's 236 to 700 thousand tons a year, against Loudoun's</a:t>
-            </a:r>
-          </a:p>
-          <a:p>
-            <a:r>
-              <a:t>675 thousand. Washington law then requires fully clean retail power by 2045.</a:t>
+              <a:t>Against Loudoun County, Virginia, where much of the industry builds today, the example holds up well on water. An evaporatively cooled campus in Grant would use about 210 million gallons of water a year. Dry cooling brings that to about 28 million, an 87 percent cut, for about 2 percent more energy. Carbon depends on the power that serves the campus. Before its own clean supply comes online, it's 236 to 700 thousand tons a year, against Loudoun's 675 thousand. Washington law then requires fully clean retail power by 2045.</a:t>
             </a:r>
           </a:p>
           <a:p/>
           <a:p>
             <a:r>
-              <a:t>If someone asks why not zero carbon, the utility's hydro rate of zero describes its existing</a:t>
-            </a:r>
-          </a:p>
-          <a:p>
-            <a:r>
-              <a:t>customers. None of that hydro is spare for a new load, so we don't claim it. If someone asks</a:t>
-            </a:r>
-          </a:p>
-          <a:p>
-            <a:r>
-              <a:t>whether 2045 is an edge over Virginia, it isn't. Virginia's Clean Economy Act also sets 2045 for</a:t>
-            </a:r>
-          </a:p>
-          <a:p>
-            <a:r>
-              <a:t>Dominion (not verified for this deck). The difference is the new supply the project funds.</a:t>
+              <a:t>If someone asks why not zero carbon, the utility's hydro rate of zero describes its existing customers. None of that hydro is spare for a new load, so we don't claim it. If someone asks whether 2045 is an edge over Virginia, probably not. Virginia's Clean Economy Act also sets 2045 for Dominion, though we haven't checked Virginia's law ourselves. The difference is the new supply the project funds.</a:t>
             </a:r>
           </a:p>
           <a:p/>
@@ -4773,100 +4301,42 @@
           <a:lstStyle/>
           <a:p>
             <a:r>
-              <a:t>For our example, one risk stands out, and it's power. Grant PUD's share of its dams averages about</a:t>
-            </a:r>
-          </a:p>
-          <a:p>
-            <a:r>
-              <a:t>633 average megawatts, already below its 757 megawatt load. The</a:t>
-            </a:r>
-          </a:p>
-          <a:p>
-            <a:r>
-              <a:t>campus would add 279, and about 800 megawatts of requests are ahead of it. So the</a:t>
-            </a:r>
-          </a:p>
-          <a:p>
-            <a:r>
-              <a:t>project funds new supply and phases in behind the 2027 and 2029 transmission lines. Heat is a medium</a:t>
-            </a:r>
-          </a:p>
-          <a:p>
-            <a:r>
-              <a:t>risk. Land is low, with no protected land within 5 kilometers of Quincy, and tribal consultation</a:t>
-            </a:r>
-          </a:p>
-          <a:p>
-            <a:r>
-              <a:t>starts early. The example holds only if full power arrives by about late 2029, near today's price.</a:t>
+              <a:t>For our example, power is the risk that matters. Grant PUD's share of its dams averages about 633 average megawatts, already below its 757 megawatt load. The campus would add 279, and about 800 megawatts of requests are ahead of it. So the build phases in, starting after Quincy's 2027 transmission upgrade and growing toward 300 megawatts after the 2029 line, only as new supply it pays for arrives. About a gigawatt of new solar matches its yearly use. Heat is a medium risk, and a hand check found no protected land within 5 kilometers.</a:t>
             </a:r>
           </a:p>
           <a:p/>
           <a:p>
             <a:r>
-              <a:t>If someone asks about price, a new load this size doesn't get today's average rate. If we reprice</a:t>
-            </a:r>
-          </a:p>
-          <a:p>
-            <a:r>
-              <a:t>only Washington at BPA's new-load rate of $80 a megawatt-hour, Grant falls to 77th, and</a:t>
-            </a:r>
-          </a:p>
-          <a:p>
-            <a:r>
-              <a:t>Whitman falls with it. No other state's new-load rate is sourced, so that comparison is lopsided.</a:t>
+              <a:t>If someone asks about price, a new load this size doesn't get today's average rate. If we reprice only Washington at BPA's new-load rate of $80 a megawatt-hour, Grant falls to 77th, and Whitman falls with it. No other state's new-load rate is sourced, so that comparison is lopsided.</a:t>
             </a:r>
           </a:p>
           <a:p/>
           <a:p>
             <a:r>
-              <a:t>If someone asks about timing, each month of delay is priced at $25 million in the dollar model, which</a:t>
-            </a:r>
-          </a:p>
-          <a:p>
-            <a:r>
-              <a:t>is an assumption. Grant breaks even with Clark at about 10 months past a two-year baseline and with</a:t>
-            </a:r>
-          </a:p>
-          <a:p>
-            <a:r>
-              <a:t>Franklin at about 12.</a:t>
+              <a:t>If someone asks about timing, each month of delay is priced at $25 million in the dollar model, which is an assumption. Grant breaks even with Clark at about 10 months past a two-year baseline and with Franklin at about 12.</a:t>
             </a:r>
           </a:p>
           <a:p/>
           <a:p>
             <a:r>
-              <a:t>If someone asks about tribal land, there's none in Grant County and the nearest is about 75 km away.</a:t>
-            </a:r>
-          </a:p>
-          <a:p>
-            <a:r>
-              <a:t>Quincy appears to sit in the Yakama Nation's 1855 ceded area, but that's our reading of the treaty</a:t>
-            </a:r>
-          </a:p>
-          <a:p>
-            <a:r>
-              <a:t>text, not an official map. A federal connection, like a federal permit or a BPA interconnection,</a:t>
-            </a:r>
-          </a:p>
-          <a:p>
-            <a:r>
-              <a:t>triggers Section 106 consultation, and state funding triggers Washington Executive Order 21-02 review.</a:t>
-            </a:r>
-          </a:p>
-          <a:p>
-            <a:r>
-              <a:t>Washington's data center workgroup also notes that new load on hydropower competes with tribal and</a:t>
-            </a:r>
-          </a:p>
-          <a:p>
-            <a:r>
-              <a:t>state fisheries efforts, which is one more reason we don't claim existing hydro.</a:t>
+              <a:t>If someone asks who pays, Grant PUD says large power users are responsible for the costs of new generation, transmission, and distribution needed to serve them.</a:t>
             </a:r>
           </a:p>
           <a:p/>
           <a:p>
             <a:r>
+              <a:t>If someone asks about cooling and heat, the plan uses liquid cooling with dry coolers, about 28 million gallons a year, sized for hotter 2050 summers, and pipes 45 to 65 degree return water to a food processor next door.</a:t>
+            </a:r>
+          </a:p>
+          <a:p/>
+          <a:p>
+            <a:r>
+              <a:t>If someone asks about tribal land, there's none in Grant County and the nearest is about 75 km away. Quincy appears to sit in the Yakama Nation's 1855 ceded area, but that's our reading of the treaty text, not an official map. A federal connection, like a federal permit or a BPA interconnection, triggers Section 106 consultation, and state funding triggers Washington Executive Order 21-02 review. Washington's data center workgroup also notes that new load on hydropower competes with tribal and state fisheries efforts, which is one more reason we don't claim existing hydro.</a:t>
+            </a:r>
+          </a:p>
+          <a:p/>
+          <a:p>
+            <a:r>
               <a:t>Where the numbers come from. [[CHECK]] marks a number that could change tonight.</a:t>
             </a:r>
           </a:p>
@@ -4892,6 +4362,16 @@
           </a:p>
           <a:p>
             <a:r>
+              <a:t>- Transmission milestones, 2027 Quincy upgrade, 2029 Wanapum to Quincy line, published source (research/implementation.md, The queue and the caps)</a:t>
+            </a:r>
+          </a:p>
+          <a:p>
+            <a:r>
+              <a:t>- New solar to match yearly use, about 1 GW (1,030 MW at 27% capacity factor) [[CHECK]] (research/implementation.md, Where new clean supply comes from)</a:t>
+            </a:r>
+          </a:p>
+          <a:p>
+            <a:r>
               <a:t>- Days above 95°F, 14.5 today, 35.9 by 2050 [[CHECK]] (docs/figures/facts.json, featured.horizon_2050_raw.days_above_95f_hist)</a:t>
             </a:r>
           </a:p>
@@ -4918,6 +4398,11 @@
           <a:p>
             <a:r>
               <a:t>- Grant break-even with Clark and Franklin, 10.2 and 12.1 months past a 2-year baseline [[CHECK]] (docs/weighting.md, Grant's row)</a:t>
+            </a:r>
+          </a:p>
+          <a:p>
+            <a:r>
+              <a:t>- Dry cooling water, 27.8 million gallons a year [[CHECK]] (docs/figures/facts.json, impact['Grant, WA'].water_million_gal_dry)</a:t>
             </a:r>
           </a:p>
           <a:p/>
@@ -5003,74 +4488,49 @@
           <a:lstStyle/>
           <a:p>
             <a:r>
-              <a:t>So the build starts small, behind the utility's queue. A first phase</a:t>
-            </a:r>
-          </a:p>
-          <a:p>
-            <a:r>
-              <a:t>comes online after Quincy's 2027 transmission upgrade, and the campus grows toward 300 megawatts</a:t>
-            </a:r>
-          </a:p>
-          <a:p>
-            <a:r>
-              <a:t>after the 2029 line, only as new supply it pays for comes online. About a gigawatt of new solar</a:t>
-            </a:r>
-          </a:p>
-          <a:p>
-            <a:r>
-              <a:t>matches its yearly use, though not every hour, so firm clean power like pumped storage follows in</a:t>
-            </a:r>
-          </a:p>
-          <a:p>
-            <a:r>
-              <a:t>the 2030s. Liquid cooling with dry coolers handles hotter 2050 summers, and the warm return water</a:t>
-            </a:r>
-          </a:p>
-          <a:p>
-            <a:r>
-              <a:t>heats a food processor next door.</a:t>
+              <a:t>That brings us back to the tool. Watch what one change does. Switch the cooling from dry to evaporative, and the tool adds a limit on water stress. The counties that pass drop from 1,565 to 826. Grant scores 3.6 out of 5 for water stress, so it drops out, and the app tells you exactly which limit it failed. Whitman, with almost no water stress, moves to first. Only the cooling choice changed, and the app explains the new order. Let us show you. [Hand over to the live demo.]</a:t>
             </a:r>
           </a:p>
           <a:p/>
           <a:p>
             <a:r>
+              <a:t>If someone asks about the other presets, speed to power puts Mayes, Oklahoma first, and sustainability first keeps Whitman first with Grant fourth.</a:t>
+            </a:r>
+          </a:p>
+          <a:p/>
+          <a:p>
+            <a:r>
               <a:t>Where the numbers come from. [[CHECK]] marks a number that could change tonight.</a:t>
             </a:r>
           </a:p>
           <a:p>
             <a:r>
-              <a:t>- Transmission milestones, 2027 Quincy upgrade, 2029 Wanapum to Quincy line, published source (research/implementation.md, The queue and the caps)</a:t>
-            </a:r>
-          </a:p>
-          <a:p>
-            <a:r>
-              <a:t>- New solar to match yearly use, about 1 GW (1,030 MW at 27% capacity factor) [[CHECK]] (research/implementation.md, Where new clean supply comes from)</a:t>
-            </a:r>
-          </a:p>
-          <a:p>
-            <a:r>
-              <a:t>- Goldendale pumped storage, 1.2 GW, 2031 to 2032, published source (research/implementation.md, Where new clean supply comes from)</a:t>
-            </a:r>
-          </a:p>
-          <a:p>
-            <a:r>
-              <a:t>- Dry cooling water, 27.8 million gallons a year [[CHECK]] (docs/figures/facts.json, impact['Grant, WA'].water_million_gal_dry)</a:t>
-            </a:r>
-          </a:p>
-          <a:p>
-            <a:r>
-              <a:t>- Liquid cooling return water, 45 to 65°C, published source (research/implementation.md, Cooling and water, Heat reuse)</a:t>
-            </a:r>
-          </a:p>
-          <a:p/>
-          <a:p>
-            <a:r>
-              <a:t>Outside sources</a:t>
-            </a:r>
-          </a:p>
-          <a:p>
-            <a:r>
-              <a:t>- Grant PUD Data Center FAQs, Q5, https://www.grantpud.org/blog/data-center-faqs</a:t>
+              <a:t>- Counties that pass, dry cooling, 1,565 [[CHECK]] (docs/figures/facts.json, balanced.passed)</a:t>
+            </a:r>
+          </a:p>
+          <a:p>
+            <a:r>
+              <a:t>- Counties that pass, evaporative cooling, 826 [[CHECK]] (docs/deck_build_log.md step 4 and docs/demo_script.md, evaporative cooling step)</a:t>
+            </a:r>
+          </a:p>
+          <a:p>
+            <a:r>
+              <a:t>- Counties with no weak factor, evaporative, 502 [[CHECK]] (docs/deck_build_log.md step 4 and docs/demo_script.md, evaporative cooling step)</a:t>
+            </a:r>
+          </a:p>
+          <a:p>
+            <a:r>
+              <a:t>- Grant water stress, 3.6 of 5 [[CHECK]] (docs/figures/facts.json, featured.horizon_2050_raw.water_stress_bws.today)</a:t>
+            </a:r>
+          </a:p>
+          <a:p>
+            <a:r>
+              <a:t>- First place under evaporative cooling, Whitman, WA [[CHECK]] (docs/deck_build_log.md step 4)</a:t>
+            </a:r>
+          </a:p>
+          <a:p>
+            <a:r>
+              <a:t>- Preset leaders, speed_to_power Mayes OK, sustainability_first Whitman WA with Grant 4th [[CHECK]] (docs/figures/facts.json and docs/deck.md, presets)</a:t>
             </a:r>
           </a:p>
         </p:txBody>
@@ -5140,74 +4600,38 @@
           <a:lstStyle/>
           <a:p>
             <a:r>
-              <a:t>That brings us back to the tool. Watch what one change does. Switch the cooling from dry to</a:t>
-            </a:r>
-          </a:p>
-          <a:p>
-            <a:r>
-              <a:t>evaporative, and the tool adds a limit on water stress. The counties that pass drop from</a:t>
-            </a:r>
-          </a:p>
-          <a:p>
-            <a:r>
-              <a:t>1,565 to 826. Grant scores 3.6 out of 5 for water stress, so it drops out,</a:t>
-            </a:r>
-          </a:p>
-          <a:p>
-            <a:r>
-              <a:t>and the app tells you exactly which limit it failed. Whitman, with almost no water stress, moves to</a:t>
-            </a:r>
-          </a:p>
-          <a:p>
-            <a:r>
-              <a:t>first. Same data, a new answer, with its reasons. Let us show you. [Hand over to the live demo.]</a:t>
+              <a:t>With seven factors, Berkshire County, Massachusetts ranked first and Grant seventh. Massachusetts closed the tax break Berkshire relied on, and it fell to 27th. When we added the cost of power as its own factor, Grant rose to first and Berkshire fell to 1,164th. Then the price check cut against us. A new load this size won't get today's average price, and if only Washington pays BPA's new-load rate, Grant falls to 77th. We also tested a machine-learning model of permitting outcomes and dropped it, because out of sample it did no better than chance.</a:t>
             </a:r>
           </a:p>
           <a:p/>
           <a:p>
             <a:r>
-              <a:t>If someone asks about the other presets, speed to power puts Mayes, Oklahoma first, and</a:t>
-            </a:r>
-          </a:p>
-          <a:p>
-            <a:r>
-              <a:t>sustainability first keeps Whitman first with Grant fourth.</a:t>
-            </a:r>
-          </a:p>
-          <a:p/>
-          <a:p>
-            <a:r>
               <a:t>Where the numbers come from. [[CHECK]] marks a number that could change tonight.</a:t>
             </a:r>
           </a:p>
           <a:p>
             <a:r>
-              <a:t>- Counties that pass, dry cooling, 1,565 [[CHECK]] (docs/figures/facts.json, balanced.passed)</a:t>
-            </a:r>
-          </a:p>
-          <a:p>
-            <a:r>
-              <a:t>- Counties that pass, evaporative cooling, 826 [[CHECK]] (docs/deck_build_log.md step 4 and docs/demo_script.md, evaporative cooling step)</a:t>
-            </a:r>
-          </a:p>
-          <a:p>
-            <a:r>
-              <a:t>- Counties with no weak factor, evaporative, 502 [[CHECK]] (docs/deck_build_log.md step 4 and docs/demo_script.md, evaporative cooling step)</a:t>
-            </a:r>
-          </a:p>
-          <a:p>
-            <a:r>
-              <a:t>- Grant water stress, 3.6 of 5 [[CHECK]] (docs/figures/facts.json, featured.horizon_2050_raw.water_stress_bws.today)</a:t>
-            </a:r>
-          </a:p>
-          <a:p>
-            <a:r>
-              <a:t>- First place under evaporative cooling, Whitman, WA [[CHECK]] (docs/deck_build_log.md step 4)</a:t>
-            </a:r>
-          </a:p>
-          <a:p>
-            <a:r>
-              <a:t>- Preset leaders, speed_to_power Mayes OK, sustainability_first Whitman WA with Grant 4th [[CHECK]] (docs/figures/facts.json and docs/deck.md, presets)</a:t>
+              <a:t>- Berkshire ranks by step, 1 / 27 / 1164 [[CHECK]] (docs/figures/facts.json, pick_story.ranks['Berkshire, MA'])</a:t>
+            </a:r>
+          </a:p>
+          <a:p>
+            <a:r>
+              <a:t>- Grant ranks by step, 7 / 7 / 1 [[CHECK]] (docs/figures/facts.json, pick_story.ranks['Grant, WA'])</a:t>
+            </a:r>
+          </a:p>
+          <a:p>
+            <a:r>
+              <a:t>- Grant rank with only WA at BPA's $80 per MWh, 77 [[CHECK]] (docs/deck_build_log.md, step 4 price rerun)</a:t>
+            </a:r>
+          </a:p>
+          <a:p>
+            <a:r>
+              <a:t>- Grant energy cost at BPA's new-load rate, $196M to $323M a year [[CHECK]] (docs/figures/facts.json, grant_ranges.energy_cost_musd)</a:t>
+            </a:r>
+          </a:p>
+          <a:p>
+            <a:r>
+              <a:t>- Permitting model AUC without facility counts, 0.48 to 0.585, below a 0.60 bar [[CHECK]] (research/permitting_model.md)</a:t>
             </a:r>
           </a:p>
         </p:txBody>
@@ -8344,7 +7768,7 @@
                 </a:solidFill>
                 <a:latin typeface="Arial"/>
               </a:rPr>
-              <a:t>Data from Lawrence Berkeley National Laboratory, 2024 United States Data Center Energy Usage Report, and New York Executive Order 62 (July 2026). Grid carbon range from research/impact.md. Links in docs/deck/sources.md.</a:t>
+              <a:t>Data from Lawrence Berkeley National Laboratory, 2024 United States Data Center Energy Usage Report, and New York Executive Order 62 (July 2026). Grid carbon range from eGRID2023 subregion rates. Links in docs/deck/sources.md.</a:t>
             </a:r>
           </a:p>
         </p:txBody>
@@ -8561,7 +7985,7 @@
                 </a:solidFill>
                 <a:latin typeface="Arial"/>
               </a:rPr>
-              <a:t>Grid carbon varies about fourfold between the counties we scored.</a:t>
+              <a:t>Grid carbon varies nearly sixfold between US counties.</a:t>
             </a:r>
           </a:p>
         </p:txBody>
@@ -8672,7 +8096,7 @@
                 </a:solidFill>
                 <a:latin typeface="Arial"/>
               </a:rPr>
-              <a:t>How our pick changed as we fixed the inputs</a:t>
+              <a:t>Why we also check the leaders in dollars and tons</a:t>
             </a:r>
           </a:p>
         </p:txBody>
@@ -8736,7 +8160,7 @@
                 </a:solidFill>
                 <a:latin typeface="Arial"/>
               </a:rPr>
-              <a:t>Ranks from docs/figures/facts.json (pick_story). Price rerun in docs/deck_build_log.md step 4. Permitting model results in research/permitting_model.md.</a:t>
+              <a:t>Pillar scores from the engine on main c239868 (docs/deck_build_log.md step 4). CO2 from research/impact.md at eGRID2023 regional rates. Cost shares from the 25-year dollar model in docs/weighting.md.</a:t>
             </a:r>
           </a:p>
         </p:txBody>
@@ -8771,7 +8195,7 @@
                 </a:solidFill>
                 <a:latin typeface="Arial"/>
               </a:rPr>
-              <a:t>A1</a:t>
+              <a:t>A2</a:t>
             </a:r>
           </a:p>
         </p:txBody>
@@ -8785,8 +8209,8 @@
           <p:nvPr/>
         </p:nvGraphicFramePr>
         <p:xfrm>
-          <a:off x="548640" y="2194559"/>
-          <a:ext cx="6309360" cy="3931920"/>
+          <a:off x="548640" y="1828799"/>
+          <a:ext cx="5318607" cy="2926080"/>
         </p:xfrm>
         <a:graphic>
           <a:graphicData uri="http://schemas.openxmlformats.org/drawingml/2006/chart">
@@ -8802,8 +8226,8 @@
         </p:nvSpPr>
         <p:spPr>
           <a:xfrm>
-            <a:off x="548640" y="1783079"/>
-            <a:ext cx="6309360" cy="365760"/>
+            <a:off x="548640" y="4892039"/>
+            <a:ext cx="5318607" cy="1097280"/>
           </a:xfrm>
           <a:prstGeom prst="rect">
             <a:avLst/>
@@ -8816,29 +8240,47 @@
           </a:bodyPr>
           <a:lstStyle/>
           <a:p>
-            <a:pPr algn="ctr"/>
-            <a:r>
-              <a:rPr sz="1800" b="1" i="0">
+            <a:pPr algn="l"/>
+            <a:r>
+              <a:rPr sz="1900" b="0" i="0">
                 <a:solidFill>
                   <a:srgbClr val="111518"/>
                 </a:solidFill>
                 <a:latin typeface="Arial"/>
               </a:rPr>
-              <a:t>Rank at each step, log scale</a:t>
-            </a:r>
-          </a:p>
-        </p:txBody>
-      </p:sp>
-      <p:sp>
-        <p:nvSpPr>
-          <p:cNvPr id="9" name="Bullets"/>
+              <a:t>Their carbon scores are 80 and 70, only 10 points apart.</a:t>
+            </a:r>
+          </a:p>
+        </p:txBody>
+      </p:sp>
+      <p:graphicFrame>
+        <p:nvGraphicFramePr>
+          <p:cNvPr id="9" name="Chart 8"/>
+          <p:cNvGraphicFramePr>
+            <a:graphicFrameLocks noGrp="1"/>
+          </p:cNvGraphicFramePr>
+          <p:nvPr/>
+        </p:nvGraphicFramePr>
+        <p:xfrm>
+          <a:off x="6324447" y="1828799"/>
+          <a:ext cx="5318607" cy="2926080"/>
+        </p:xfrm>
+        <a:graphic>
+          <a:graphicData uri="http://schemas.openxmlformats.org/drawingml/2006/chart">
+            <c:chart xmlns:c="http://schemas.openxmlformats.org/drawingml/2006/chart" r:id="rId4"/>
+          </a:graphicData>
+        </a:graphic>
+      </p:graphicFrame>
+      <p:sp>
+        <p:nvSpPr>
+          <p:cNvPr id="10" name="TextBox 9"/>
           <p:cNvSpPr txBox="1"/>
           <p:nvPr/>
         </p:nvSpPr>
         <p:spPr>
           <a:xfrm>
-            <a:off x="7132320" y="1965959"/>
-            <a:ext cx="4510735" cy="2926080"/>
+            <a:off x="6324447" y="4892039"/>
+            <a:ext cx="5318607" cy="1097280"/>
           </a:xfrm>
           <a:prstGeom prst="rect">
             <a:avLst/>
@@ -8846,25 +8288,12 @@
           <a:noFill/>
         </p:spPr>
         <p:txBody>
-          <a:bodyPr wrap="square" lIns="36576" rIns="36576">
+          <a:bodyPr wrap="square" anchor="t" lIns="36576" rIns="36576" tIns="18288" bIns="18288">
             <a:spAutoFit/>
           </a:bodyPr>
           <a:lstStyle/>
           <a:p>
-            <a:pPr marL="292608" indent="-292608">
-              <a:lnSpc>
-                <a:spcPct val="105000"/>
-              </a:lnSpc>
-              <a:spcAft>
-                <a:spcPts val="1200"/>
-              </a:spcAft>
-              <a:buClr>
-                <a:srgbClr val="0B3C6F"/>
-              </a:buClr>
-              <a:buSzPct val="100000"/>
-              <a:buFont typeface="Arial"/>
-              <a:buChar char="■"/>
-            </a:pPr>
+            <a:pPr algn="l"/>
             <a:r>
               <a:rPr sz="1900" b="0" i="0">
                 <a:solidFill>
@@ -8872,95 +8301,7 @@
                 </a:solidFill>
                 <a:latin typeface="Arial"/>
               </a:rPr>
-              <a:t>Massachusetts closed a tax break, and Berkshire fell to 27th.</a:t>
-            </a:r>
-          </a:p>
-          <a:p>
-            <a:pPr marL="292608" indent="-292608">
-              <a:lnSpc>
-                <a:spcPct val="105000"/>
-              </a:lnSpc>
-              <a:spcAft>
-                <a:spcPts val="1200"/>
-              </a:spcAft>
-              <a:buClr>
-                <a:srgbClr val="0B3C6F"/>
-              </a:buClr>
-              <a:buSzPct val="100000"/>
-              <a:buFont typeface="Arial"/>
-              <a:buChar char="■"/>
-            </a:pPr>
-            <a:r>
-              <a:rPr sz="1900" b="0" i="0">
-                <a:solidFill>
-                  <a:srgbClr val="111518"/>
-                </a:solidFill>
-                <a:latin typeface="Arial"/>
-              </a:rPr>
-              <a:t>Adding the cost of power moved Grant to first.</a:t>
-            </a:r>
-          </a:p>
-          <a:p>
-            <a:pPr marL="292608" indent="-292608">
-              <a:lnSpc>
-                <a:spcPct val="105000"/>
-              </a:lnSpc>
-              <a:spcAft>
-                <a:spcPts val="1200"/>
-              </a:spcAft>
-              <a:buClr>
-                <a:srgbClr val="0B3C6F"/>
-              </a:buClr>
-              <a:buSzPct val="100000"/>
-              <a:buFont typeface="Arial"/>
-              <a:buChar char="■"/>
-            </a:pPr>
-            <a:r>
-              <a:rPr sz="1900" b="0" i="0">
-                <a:solidFill>
-                  <a:srgbClr val="111518"/>
-                </a:solidFill>
-                <a:latin typeface="Arial"/>
-              </a:rPr>
-              <a:t>Repricing only Washington at BPA's rate drops Grant to 77th.</a:t>
-            </a:r>
-          </a:p>
-        </p:txBody>
-      </p:sp>
-      <p:sp>
-        <p:nvSpPr>
-          <p:cNvPr id="10" name="Dropped"/>
-          <p:cNvSpPr/>
-          <p:nvPr/>
-        </p:nvSpPr>
-        <p:spPr>
-          <a:xfrm>
-            <a:off x="7132320" y="4937759"/>
-            <a:ext cx="4510735" cy="1188720"/>
-          </a:xfrm>
-          <a:prstGeom prst="rect">
-            <a:avLst/>
-          </a:prstGeom>
-          <a:solidFill>
-            <a:srgbClr val="F3F5F4"/>
-          </a:solidFill>
-          <a:ln>
-            <a:noFill/>
-          </a:ln>
-        </p:spPr>
-        <p:txBody>
-          <a:bodyPr rtlCol="0" anchor="ctr" wrap="square" lIns="182880" rIns="182880" tIns="36576" bIns="36576"/>
-          <a:lstStyle/>
-          <a:p>
-            <a:pPr algn="l"/>
-            <a:r>
-              <a:rPr sz="1700" b="0" i="0">
-                <a:solidFill>
-                  <a:srgbClr val="111518"/>
-                </a:solidFill>
-                <a:latin typeface="Arial"/>
-              </a:rPr>
-              <a:t>We also tested a machine-learning model of permitting and dropped it. Out of sample it did no better than chance.</a:t>
+              <a:t>Energy and carbon drive most cost differences between counties.</a:t>
             </a:r>
           </a:p>
         </p:txBody>
@@ -9053,7 +8394,7 @@
                 </a:solidFill>
                 <a:latin typeface="Arial"/>
               </a:rPr>
-              <a:t>Why we also check the leaders in dollars and tons</a:t>
+              <a:t>In 25-year dollars, four leading counties land within 3% of each other</a:t>
             </a:r>
           </a:p>
         </p:txBody>
@@ -9117,7 +8458,7 @@
                 </a:solidFill>
                 <a:latin typeface="Arial"/>
               </a:rPr>
-              <a:t>Pillar scores from the engine on main c239868 (docs/deck_build_log.md step 4). CO2 from research/impact.md at eGRID2023 regional rates. Cost shares from the 25-year dollar model in docs/weighting.md.</a:t>
+              <a:t>25-year costs at $190 per ton CO2 with sales tax, at today's average prices (docs/weighting.md and scratch/weighting/out/monetized_costs.csv). Land checks from research/sensitive_land.md.</a:t>
             </a:r>
           </a:p>
         </p:txBody>
@@ -9152,304 +8493,6 @@
                 </a:solidFill>
                 <a:latin typeface="Arial"/>
               </a:rPr>
-              <a:t>A2</a:t>
-            </a:r>
-          </a:p>
-        </p:txBody>
-      </p:sp>
-      <p:graphicFrame>
-        <p:nvGraphicFramePr>
-          <p:cNvPr id="7" name="Chart 6"/>
-          <p:cNvGraphicFramePr>
-            <a:graphicFrameLocks noGrp="1"/>
-          </p:cNvGraphicFramePr>
-          <p:nvPr/>
-        </p:nvGraphicFramePr>
-        <p:xfrm>
-          <a:off x="548640" y="1828799"/>
-          <a:ext cx="5318607" cy="2926080"/>
-        </p:xfrm>
-        <a:graphic>
-          <a:graphicData uri="http://schemas.openxmlformats.org/drawingml/2006/chart">
-            <c:chart xmlns:c="http://schemas.openxmlformats.org/drawingml/2006/chart" r:id="rId3"/>
-          </a:graphicData>
-        </a:graphic>
-      </p:graphicFrame>
-      <p:sp>
-        <p:nvSpPr>
-          <p:cNvPr id="8" name="TextBox 7"/>
-          <p:cNvSpPr txBox="1"/>
-          <p:nvPr/>
-        </p:nvSpPr>
-        <p:spPr>
-          <a:xfrm>
-            <a:off x="548640" y="4892039"/>
-            <a:ext cx="5318607" cy="1097280"/>
-          </a:xfrm>
-          <a:prstGeom prst="rect">
-            <a:avLst/>
-          </a:prstGeom>
-          <a:noFill/>
-        </p:spPr>
-        <p:txBody>
-          <a:bodyPr wrap="square" anchor="t" lIns="36576" rIns="36576" tIns="18288" bIns="18288">
-            <a:spAutoFit/>
-          </a:bodyPr>
-          <a:lstStyle/>
-          <a:p>
-            <a:pPr algn="l"/>
-            <a:r>
-              <a:rPr sz="1900" b="0" i="0">
-                <a:solidFill>
-                  <a:srgbClr val="111518"/>
-                </a:solidFill>
-                <a:latin typeface="Arial"/>
-              </a:rPr>
-              <a:t>Their carbon scores are 80 and 70, only 10 points apart.</a:t>
-            </a:r>
-          </a:p>
-        </p:txBody>
-      </p:sp>
-      <p:graphicFrame>
-        <p:nvGraphicFramePr>
-          <p:cNvPr id="9" name="Chart 8"/>
-          <p:cNvGraphicFramePr>
-            <a:graphicFrameLocks noGrp="1"/>
-          </p:cNvGraphicFramePr>
-          <p:nvPr/>
-        </p:nvGraphicFramePr>
-        <p:xfrm>
-          <a:off x="6324447" y="1828799"/>
-          <a:ext cx="5318607" cy="2926080"/>
-        </p:xfrm>
-        <a:graphic>
-          <a:graphicData uri="http://schemas.openxmlformats.org/drawingml/2006/chart">
-            <c:chart xmlns:c="http://schemas.openxmlformats.org/drawingml/2006/chart" r:id="rId4"/>
-          </a:graphicData>
-        </a:graphic>
-      </p:graphicFrame>
-      <p:sp>
-        <p:nvSpPr>
-          <p:cNvPr id="10" name="TextBox 9"/>
-          <p:cNvSpPr txBox="1"/>
-          <p:nvPr/>
-        </p:nvSpPr>
-        <p:spPr>
-          <a:xfrm>
-            <a:off x="6324447" y="4892039"/>
-            <a:ext cx="5318607" cy="1097280"/>
-          </a:xfrm>
-          <a:prstGeom prst="rect">
-            <a:avLst/>
-          </a:prstGeom>
-          <a:noFill/>
-        </p:spPr>
-        <p:txBody>
-          <a:bodyPr wrap="square" anchor="t" lIns="36576" rIns="36576" tIns="18288" bIns="18288">
-            <a:spAutoFit/>
-          </a:bodyPr>
-          <a:lstStyle/>
-          <a:p>
-            <a:pPr algn="l"/>
-            <a:r>
-              <a:rPr sz="1900" b="0" i="0">
-                <a:solidFill>
-                  <a:srgbClr val="111518"/>
-                </a:solidFill>
-                <a:latin typeface="Arial"/>
-              </a:rPr>
-              <a:t>Dollars show what the scores flatten, so the two views check each other.</a:t>
-            </a:r>
-          </a:p>
-        </p:txBody>
-      </p:sp>
-    </p:spTree>
-  </p:cSld>
-  <p:clrMapOvr>
-    <a:masterClrMapping/>
-  </p:clrMapOvr>
-  <p:transition spd="med">
-    <p:fade/>
-  </p:transition>
-</p:sld>
-</file>
-
-<file path=ppt/slides/slide12.xml><?xml version="1.0" encoding="utf-8"?>
-<p:sld xmlns:a="http://schemas.openxmlformats.org/drawingml/2006/main" xmlns:p="http://schemas.openxmlformats.org/presentationml/2006/main" xmlns:r="http://schemas.openxmlformats.org/officeDocument/2006/relationships">
-  <p:cSld>
-    <p:bg>
-      <p:bgPr>
-        <a:solidFill>
-          <a:srgbClr val="FFFFFF"/>
-        </a:solidFill>
-        <a:effectLst/>
-      </p:bgPr>
-    </p:bg>
-    <p:spTree>
-      <p:nvGrpSpPr>
-        <p:cNvPr id="1" name=""/>
-        <p:cNvGrpSpPr/>
-        <p:nvPr/>
-      </p:nvGrpSpPr>
-      <p:grpSpPr/>
-      <p:sp>
-        <p:nvSpPr>
-          <p:cNvPr id="2" name="Accent"/>
-          <p:cNvSpPr/>
-          <p:nvPr/>
-        </p:nvSpPr>
-        <p:spPr>
-          <a:xfrm>
-            <a:off x="548640" y="384048"/>
-            <a:ext cx="457200" cy="64008"/>
-          </a:xfrm>
-          <a:prstGeom prst="rect">
-            <a:avLst/>
-          </a:prstGeom>
-          <a:solidFill>
-            <a:srgbClr val="0B3C6F"/>
-          </a:solidFill>
-          <a:ln>
-            <a:noFill/>
-          </a:ln>
-        </p:spPr>
-        <p:txBody>
-          <a:bodyPr rtlCol="0" anchor="ctr"/>
-          <a:lstStyle/>
-          <a:p>
-            <a:pPr algn="ctr"/>
-          </a:p>
-        </p:txBody>
-      </p:sp>
-      <p:sp>
-        <p:nvSpPr>
-          <p:cNvPr id="3" name="Headline"/>
-          <p:cNvSpPr txBox="1"/>
-          <p:nvPr/>
-        </p:nvSpPr>
-        <p:spPr>
-          <a:xfrm>
-            <a:off x="548640" y="548640"/>
-            <a:ext cx="11094415" cy="1143000"/>
-          </a:xfrm>
-          <a:prstGeom prst="rect">
-            <a:avLst/>
-          </a:prstGeom>
-          <a:noFill/>
-        </p:spPr>
-        <p:txBody>
-          <a:bodyPr wrap="square" anchor="t" lIns="36576" rIns="36576" tIns="18288" bIns="18288">
-            <a:spAutoFit/>
-          </a:bodyPr>
-          <a:lstStyle/>
-          <a:p>
-            <a:pPr algn="l"/>
-            <a:r>
-              <a:rPr sz="3000" b="1" i="0">
-                <a:solidFill>
-                  <a:srgbClr val="111518"/>
-                </a:solidFill>
-                <a:latin typeface="Arial"/>
-              </a:rPr>
-              <a:t>Clark WA and Franklin NY are the alternatives, each with a condition</a:t>
-            </a:r>
-          </a:p>
-        </p:txBody>
-      </p:sp>
-      <p:sp>
-        <p:nvSpPr>
-          <p:cNvPr id="4" name="Rule"/>
-          <p:cNvSpPr/>
-          <p:nvPr/>
-        </p:nvSpPr>
-        <p:spPr>
-          <a:xfrm>
-            <a:off x="548640" y="6272784"/>
-            <a:ext cx="11094415" cy="9525"/>
-          </a:xfrm>
-          <a:prstGeom prst="rect">
-            <a:avLst/>
-          </a:prstGeom>
-          <a:solidFill>
-            <a:srgbClr val="D3D8D6"/>
-          </a:solidFill>
-          <a:ln>
-            <a:noFill/>
-          </a:ln>
-        </p:spPr>
-        <p:txBody>
-          <a:bodyPr rtlCol="0" anchor="ctr"/>
-          <a:lstStyle/>
-          <a:p>
-            <a:pPr algn="ctr"/>
-          </a:p>
-        </p:txBody>
-      </p:sp>
-      <p:sp>
-        <p:nvSpPr>
-          <p:cNvPr id="5" name="Source line"/>
-          <p:cNvSpPr txBox="1"/>
-          <p:nvPr/>
-        </p:nvSpPr>
-        <p:spPr>
-          <a:xfrm>
-            <a:off x="548640" y="6327648"/>
-            <a:ext cx="10362895" cy="457200"/>
-          </a:xfrm>
-          <a:prstGeom prst="rect">
-            <a:avLst/>
-          </a:prstGeom>
-          <a:noFill/>
-        </p:spPr>
-        <p:txBody>
-          <a:bodyPr wrap="square" anchor="t" lIns="36576" rIns="36576" tIns="18288" bIns="18288">
-            <a:spAutoFit/>
-          </a:bodyPr>
-          <a:lstStyle/>
-          <a:p>
-            <a:pPr algn="l"/>
-            <a:r>
-              <a:rPr sz="1100" b="0" i="0">
-                <a:solidFill>
-                  <a:srgbClr val="5F6A74"/>
-                </a:solidFill>
-                <a:latin typeface="Arial"/>
-              </a:rPr>
-              <a:t>25-year costs at $190 per ton CO2 with sales tax, at today's average prices (docs/weighting.md). Land checks from research/sensitive_land.md.</a:t>
-            </a:r>
-          </a:p>
-        </p:txBody>
-      </p:sp>
-      <p:sp>
-        <p:nvSpPr>
-          <p:cNvPr id="6" name="Slide number"/>
-          <p:cNvSpPr txBox="1"/>
-          <p:nvPr/>
-        </p:nvSpPr>
-        <p:spPr>
-          <a:xfrm>
-            <a:off x="11002975" y="6327648"/>
-            <a:ext cx="640080" cy="274320"/>
-          </a:xfrm>
-          <a:prstGeom prst="rect">
-            <a:avLst/>
-          </a:prstGeom>
-          <a:noFill/>
-        </p:spPr>
-        <p:txBody>
-          <a:bodyPr wrap="square" anchor="t" lIns="36576" rIns="36576" tIns="18288" bIns="18288">
-            <a:spAutoFit/>
-          </a:bodyPr>
-          <a:lstStyle/>
-          <a:p>
-            <a:pPr algn="r"/>
-            <a:r>
-              <a:rPr sz="1100" b="0" i="0">
-                <a:solidFill>
-                  <a:srgbClr val="5F6A74"/>
-                </a:solidFill>
-                <a:latin typeface="Arial"/>
-              </a:rPr>
               <a:t>A3</a:t>
             </a:r>
           </a:p>
@@ -9465,7 +8508,7 @@
         </p:nvGraphicFramePr>
         <p:xfrm>
           <a:off x="548640" y="1828799"/>
-          <a:ext cx="11094415" cy="3017520"/>
+          <a:ext cx="11094415" cy="3291840"/>
         </p:xfrm>
         <a:graphic>
           <a:graphicData uri="http://schemas.openxmlformats.org/drawingml/2006/table">
@@ -9479,7 +8522,7 @@
                 <a:gridCol w="3840480"/>
                 <a:gridCol w="3687775"/>
               </a:tblGrid>
-              <a:tr h="754380">
+              <a:tr h="658368">
                 <a:tc>
                   <a:txBody>
                     <a:bodyPr wrap="square"/>
@@ -9536,7 +8579,7 @@
                           </a:solidFill>
                           <a:latin typeface="Arial"/>
                         </a:rPr>
-                        <a:t>Wins if</a:t>
+                        <a:t>Main condition</a:t>
                       </a:r>
                     </a:p>
                   </a:txBody>
@@ -9569,7 +8612,187 @@
                   </a:tcPr>
                 </a:tc>
               </a:tr>
-              <a:tr h="754380">
+              <a:tr h="658368">
+                <a:tc>
+                  <a:txBody>
+                    <a:bodyPr wrap="square"/>
+                    <a:lstStyle/>
+                    <a:p>
+                      <a:r>
+                        <a:rPr sz="1600" b="1" i="0">
+                          <a:solidFill>
+                            <a:srgbClr val="111518"/>
+                          </a:solidFill>
+                          <a:latin typeface="Arial"/>
+                        </a:rPr>
+                        <a:t>Whitman, WA</a:t>
+                      </a:r>
+                    </a:p>
+                  </a:txBody>
+                  <a:tcPr marL="91440" marR="91440" anchor="ctr">
+                    <a:solidFill>
+                      <a:srgbClr val="FFFFFF"/>
+                    </a:solidFill>
+                  </a:tcPr>
+                </a:tc>
+                <a:tc>
+                  <a:txBody>
+                    <a:bodyPr wrap="square"/>
+                    <a:lstStyle/>
+                    <a:p>
+                      <a:r>
+                        <a:rPr sz="1600" b="0" i="0">
+                          <a:solidFill>
+                            <a:srgbClr val="111518"/>
+                          </a:solidFill>
+                          <a:latin typeface="Arial"/>
+                        </a:rPr>
+                        <a:t>$4.330B</a:t>
+                      </a:r>
+                    </a:p>
+                  </a:txBody>
+                  <a:tcPr marL="91440" marR="91440" anchor="ctr">
+                    <a:solidFill>
+                      <a:srgbClr val="FFFFFF"/>
+                    </a:solidFill>
+                  </a:tcPr>
+                </a:tc>
+                <a:tc>
+                  <a:txBody>
+                    <a:bodyPr wrap="square"/>
+                    <a:lstStyle/>
+                    <a:p>
+                      <a:r>
+                        <a:rPr sz="1600" b="0" i="0">
+                          <a:solidFill>
+                            <a:srgbClr val="111518"/>
+                          </a:solidFill>
+                          <a:latin typeface="Arial"/>
+                        </a:rPr>
+                        <a:t>Power on an assumed timeline that we haven't researched</a:t>
+                      </a:r>
+                    </a:p>
+                  </a:txBody>
+                  <a:tcPr marL="91440" marR="91440" anchor="ctr">
+                    <a:solidFill>
+                      <a:srgbClr val="FFFFFF"/>
+                    </a:solidFill>
+                  </a:tcPr>
+                </a:tc>
+                <a:tc>
+                  <a:txBody>
+                    <a:bodyPr wrap="square"/>
+                    <a:lstStyle/>
+                    <a:p>
+                      <a:r>
+                        <a:rPr sz="1600" b="0" i="0">
+                          <a:solidFill>
+                            <a:srgbClr val="111518"/>
+                          </a:solidFill>
+                          <a:latin typeface="Arial"/>
+                        </a:rPr>
+                        <a:t>0.2% of the county is protected, not checked by hand</a:t>
+                      </a:r>
+                    </a:p>
+                  </a:txBody>
+                  <a:tcPr marL="91440" marR="91440" anchor="ctr">
+                    <a:solidFill>
+                      <a:srgbClr val="FFFFFF"/>
+                    </a:solidFill>
+                  </a:tcPr>
+                </a:tc>
+              </a:tr>
+              <a:tr h="658368">
+                <a:tc>
+                  <a:txBody>
+                    <a:bodyPr wrap="square"/>
+                    <a:lstStyle/>
+                    <a:p>
+                      <a:r>
+                        <a:rPr sz="1600" b="1" i="0">
+                          <a:solidFill>
+                            <a:srgbClr val="111518"/>
+                          </a:solidFill>
+                          <a:latin typeface="Arial"/>
+                        </a:rPr>
+                        <a:t>Clark, WA</a:t>
+                      </a:r>
+                    </a:p>
+                  </a:txBody>
+                  <a:tcPr marL="91440" marR="91440" anchor="ctr">
+                    <a:solidFill>
+                      <a:srgbClr val="F3F5F4"/>
+                    </a:solidFill>
+                  </a:tcPr>
+                </a:tc>
+                <a:tc>
+                  <a:txBody>
+                    <a:bodyPr wrap="square"/>
+                    <a:lstStyle/>
+                    <a:p>
+                      <a:r>
+                        <a:rPr sz="1600" b="0" i="0">
+                          <a:solidFill>
+                            <a:srgbClr val="111518"/>
+                          </a:solidFill>
+                          <a:latin typeface="Arial"/>
+                        </a:rPr>
+                        <a:t>$4.405B</a:t>
+                      </a:r>
+                    </a:p>
+                  </a:txBody>
+                  <a:tcPr marL="91440" marR="91440" anchor="ctr">
+                    <a:solidFill>
+                      <a:srgbClr val="F3F5F4"/>
+                    </a:solidFill>
+                  </a:tcPr>
+                </a:tc>
+                <a:tc>
+                  <a:txBody>
+                    <a:bodyPr wrap="square"/>
+                    <a:lstStyle/>
+                    <a:p>
+                      <a:r>
+                        <a:rPr sz="1600" b="0" i="0">
+                          <a:solidFill>
+                            <a:srgbClr val="111518"/>
+                          </a:solidFill>
+                          <a:latin typeface="Arial"/>
+                        </a:rPr>
+                        <a:t>Its parcel avoids the transit tax and power comes in 2.25 years</a:t>
+                      </a:r>
+                    </a:p>
+                  </a:txBody>
+                  <a:tcPr marL="91440" marR="91440" anchor="ctr">
+                    <a:solidFill>
+                      <a:srgbClr val="F3F5F4"/>
+                    </a:solidFill>
+                  </a:tcPr>
+                </a:tc>
+                <a:tc>
+                  <a:txBody>
+                    <a:bodyPr wrap="square"/>
+                    <a:lstStyle/>
+                    <a:p>
+                      <a:r>
+                        <a:rPr sz="1600" b="0" i="0">
+                          <a:solidFill>
+                            <a:srgbClr val="111518"/>
+                          </a:solidFill>
+                          <a:latin typeface="Arial"/>
+                        </a:rPr>
+                        <a:t>Avoid the Gorge Scenic Area and the Ridgefield lowlands</a:t>
+                      </a:r>
+                    </a:p>
+                  </a:txBody>
+                  <a:tcPr marL="91440" marR="91440" anchor="ctr">
+                    <a:solidFill>
+                      <a:srgbClr val="F3F5F4"/>
+                    </a:solidFill>
+                  </a:tcPr>
+                </a:tc>
+              </a:tr>
+              <a:tr h="658368">
                 <a:tc>
                   <a:txBody>
                     <a:bodyPr wrap="square"/>
@@ -9659,7 +8882,7 @@
                   </a:tcPr>
                 </a:tc>
               </a:tr>
-              <a:tr h="754380">
+              <a:tr h="658368">
                 <a:tc>
                   <a:txBody>
                     <a:bodyPr wrap="square"/>
@@ -9672,7 +8895,7 @@
                           </a:solidFill>
                           <a:latin typeface="Arial"/>
                         </a:rPr>
-                        <a:t>Clark, WA</a:t>
+                        <a:t>Franklin, NY</a:t>
                       </a:r>
                     </a:p>
                   </a:txBody>
@@ -9694,7 +8917,7 @@
                           </a:solidFill>
                           <a:latin typeface="Arial"/>
                         </a:rPr>
-                        <a:t>$4.405B</a:t>
+                        <a:t>$4.454B</a:t>
                       </a:r>
                     </a:p>
                   </a:txBody>
@@ -9716,7 +8939,7 @@
                           </a:solidFill>
                           <a:latin typeface="Arial"/>
                         </a:rPr>
-                        <a:t>Its parcel avoids the transit tax and power comes in 2.25 years</a:t>
+                        <a:t>New York's data center tax exemption applies</a:t>
                       </a:r>
                     </a:p>
                   </a:txBody>
@@ -9738,7 +8961,7 @@
                           </a:solidFill>
                           <a:latin typeface="Arial"/>
                         </a:rPr>
-                        <a:t>Avoid the Gorge Scenic Area and the Ridgefield lowlands</a:t>
+                        <a:t>Malone sits 6.1 km outside the Adirondack Park</a:t>
                       </a:r>
                     </a:p>
                   </a:txBody>
@@ -9749,96 +8972,6 @@
                   </a:tcPr>
                 </a:tc>
               </a:tr>
-              <a:tr h="754380">
-                <a:tc>
-                  <a:txBody>
-                    <a:bodyPr wrap="square"/>
-                    <a:lstStyle/>
-                    <a:p>
-                      <a:r>
-                        <a:rPr sz="1600" b="1" i="0">
-                          <a:solidFill>
-                            <a:srgbClr val="111518"/>
-                          </a:solidFill>
-                          <a:latin typeface="Arial"/>
-                        </a:rPr>
-                        <a:t>Franklin, NY</a:t>
-                      </a:r>
-                    </a:p>
-                  </a:txBody>
-                  <a:tcPr marL="91440" marR="91440" anchor="ctr">
-                    <a:solidFill>
-                      <a:srgbClr val="FFFFFF"/>
-                    </a:solidFill>
-                  </a:tcPr>
-                </a:tc>
-                <a:tc>
-                  <a:txBody>
-                    <a:bodyPr wrap="square"/>
-                    <a:lstStyle/>
-                    <a:p>
-                      <a:r>
-                        <a:rPr sz="1600" b="0" i="0">
-                          <a:solidFill>
-                            <a:srgbClr val="111518"/>
-                          </a:solidFill>
-                          <a:latin typeface="Arial"/>
-                        </a:rPr>
-                        <a:t>$4.454B</a:t>
-                      </a:r>
-                    </a:p>
-                  </a:txBody>
-                  <a:tcPr marL="91440" marR="91440" anchor="ctr">
-                    <a:solidFill>
-                      <a:srgbClr val="FFFFFF"/>
-                    </a:solidFill>
-                  </a:tcPr>
-                </a:tc>
-                <a:tc>
-                  <a:txBody>
-                    <a:bodyPr wrap="square"/>
-                    <a:lstStyle/>
-                    <a:p>
-                      <a:r>
-                        <a:rPr sz="1600" b="0" i="0">
-                          <a:solidFill>
-                            <a:srgbClr val="111518"/>
-                          </a:solidFill>
-                          <a:latin typeface="Arial"/>
-                        </a:rPr>
-                        <a:t>New York's data center tax exemption applies</a:t>
-                      </a:r>
-                    </a:p>
-                  </a:txBody>
-                  <a:tcPr marL="91440" marR="91440" anchor="ctr">
-                    <a:solidFill>
-                      <a:srgbClr val="FFFFFF"/>
-                    </a:solidFill>
-                  </a:tcPr>
-                </a:tc>
-                <a:tc>
-                  <a:txBody>
-                    <a:bodyPr wrap="square"/>
-                    <a:lstStyle/>
-                    <a:p>
-                      <a:r>
-                        <a:rPr sz="1600" b="0" i="0">
-                          <a:solidFill>
-                            <a:srgbClr val="111518"/>
-                          </a:solidFill>
-                          <a:latin typeface="Arial"/>
-                        </a:rPr>
-                        <a:t>Malone sits 6.1 km outside the Adirondack Park</a:t>
-                      </a:r>
-                    </a:p>
-                  </a:txBody>
-                  <a:tcPr marL="91440" marR="91440" anchor="ctr">
-                    <a:solidFill>
-                      <a:srgbClr val="FFFFFF"/>
-                    </a:solidFill>
-                  </a:tcPr>
-                </a:tc>
-              </a:tr>
             </a:tbl>
           </a:graphicData>
         </a:graphic>
@@ -9851,8 +8984,8 @@
         </p:nvSpPr>
         <p:spPr>
           <a:xfrm>
-            <a:off x="548640" y="5074919"/>
-            <a:ext cx="11094415" cy="914400"/>
+            <a:off x="548640" y="5303519"/>
+            <a:ext cx="11094415" cy="822960"/>
           </a:xfrm>
           <a:prstGeom prst="rect">
             <a:avLst/>
@@ -9902,7 +9035,7 @@
 </p:sld>
 </file>
 
-<file path=ppt/slides/slide13.xml><?xml version="1.0" encoding="utf-8"?>
+<file path=ppt/slides/slide12.xml><?xml version="1.0" encoding="utf-8"?>
 <p:sld xmlns:a="http://schemas.openxmlformats.org/drawingml/2006/main" xmlns:p="http://schemas.openxmlformats.org/presentationml/2006/main" xmlns:r="http://schemas.openxmlformats.org/officeDocument/2006/relationships">
   <p:cSld>
     <p:bg>
@@ -10580,7 +9713,7 @@
 </p:sld>
 </file>
 
-<file path=ppt/slides/slide14.xml><?xml version="1.0" encoding="utf-8"?>
+<file path=ppt/slides/slide13.xml><?xml version="1.0" encoding="utf-8"?>
 <p:sld xmlns:a="http://schemas.openxmlformats.org/drawingml/2006/main" xmlns:p="http://schemas.openxmlformats.org/presentationml/2006/main" xmlns:r="http://schemas.openxmlformats.org/officeDocument/2006/relationships">
   <p:cSld>
     <p:bg>
@@ -11218,7 +10351,7 @@
 </p:sld>
 </file>
 
-<file path=ppt/slides/slide15.xml><?xml version="1.0" encoding="utf-8"?>
+<file path=ppt/slides/slide14.xml><?xml version="1.0" encoding="utf-8"?>
 <p:sld xmlns:a="http://schemas.openxmlformats.org/drawingml/2006/main" xmlns:p="http://schemas.openxmlformats.org/presentationml/2006/main" xmlns:r="http://schemas.openxmlformats.org/officeDocument/2006/relationships">
   <p:cSld>
     <p:bg>
@@ -13578,7 +12711,7 @@
                 </a:solidFill>
                 <a:latin typeface="Arial"/>
               </a:rPr>
-              <a:t>Building on farmland spares wild habitat but uses up cropland. The tool lets you weigh both.</a:t>
+              <a:t>Building on farmland avoids wild habitat but takes land out of farming. You set the balance.</a:t>
             </a:r>
           </a:p>
         </p:txBody>
@@ -13832,7 +12965,7 @@
                 </a:solidFill>
                 <a:latin typeface="Arial"/>
               </a:rPr>
-              <a:t>Grant and Whitman circled</a:t>
+              <a:t>Grant and Whitman, circled, are tied for first</a:t>
             </a:r>
           </a:p>
         </p:txBody>
@@ -14192,7 +13325,7 @@
                 </a:solidFill>
                 <a:latin typeface="Arial"/>
               </a:rPr>
-              <a:t>Top 10 shares from 5,000 random weightings of the eight factors (docs/figures/facts.json, computed by docs/figures/make_figures.py). Cost shares from the 25-year dollar model in docs/weighting.md.</a:t>
+              <a:t>Top 10 shares from 5,000 random weightings of the eight factors, and robustness from 2,000 small changes to our weights (docs/figures/facts.json, computed by docs/figures/make_figures.py).</a:t>
             </a:r>
           </a:p>
         </p:txBody>
@@ -14242,7 +13375,7 @@
         </p:nvGraphicFramePr>
         <p:xfrm>
           <a:off x="548640" y="1828799"/>
-          <a:ext cx="6035040" cy="3429000"/>
+          <a:ext cx="6035040" cy="4023360"/>
         </p:xfrm>
         <a:graphic>
           <a:graphicData uri="http://schemas.openxmlformats.org/drawingml/2006/chart">
@@ -14318,7 +13451,7 @@
                 </a:solidFill>
                 <a:latin typeface="Arial"/>
               </a:rPr>
-              <a:t>Near our chosen weights, Grant stays in the top 10 (99.95%).</a:t>
+              <a:t>Near our weights, Grant and Whitman stay in the top 10.</a:t>
             </a:r>
           </a:p>
           <a:p>
@@ -14343,45 +13476,7 @@
                 </a:solidFill>
                 <a:latin typeface="Arial"/>
               </a:rPr>
-              <a:t>Energy and carbon drive most cost differences between counties.</a:t>
-            </a:r>
-          </a:p>
-        </p:txBody>
-      </p:sp>
-      <p:sp>
-        <p:nvSpPr>
-          <p:cNvPr id="9" name="Band"/>
-          <p:cNvSpPr/>
-          <p:nvPr/>
-        </p:nvSpPr>
-        <p:spPr>
-          <a:xfrm>
-            <a:off x="548640" y="5440679"/>
-            <a:ext cx="11094415" cy="566928"/>
-          </a:xfrm>
-          <a:prstGeom prst="rect">
-            <a:avLst/>
-          </a:prstGeom>
-          <a:solidFill>
-            <a:srgbClr val="F3F5F4"/>
-          </a:solidFill>
-          <a:ln>
-            <a:noFill/>
-          </a:ln>
-        </p:spPr>
-        <p:txBody>
-          <a:bodyPr rtlCol="0" anchor="ctr" wrap="square" lIns="274320" rIns="274320" tIns="36576" bIns="36576"/>
-          <a:lstStyle/>
-          <a:p>
-            <a:pPr algn="ctr"/>
-            <a:r>
-              <a:rPr sz="1800" b="1" i="0">
-                <a:solidFill>
-                  <a:srgbClr val="0B3C6F"/>
-                </a:solidFill>
-                <a:latin typeface="Arial"/>
-              </a:rPr>
-              <a:t>We didn't tune weights to get an answer. We tested how much it depends on them.</a:t>
+              <a:t>Under equal weights, Whitman ranks first and Grant second.</a:t>
             </a:r>
           </a:p>
         </p:txBody>
@@ -14474,7 +13569,7 @@
                 </a:solidFill>
                 <a:latin typeface="Arial"/>
               </a:rPr>
-              <a:t>A dry-cooled campus in Grant would use 87% less water</a:t>
+              <a:t>A dry-cooled campus in Grant would use 87% less water than an evaporative one</a:t>
             </a:r>
           </a:p>
         </p:txBody>
@@ -14859,7 +13954,7 @@
                 </a:solidFill>
                 <a:latin typeface="Arial"/>
               </a:rPr>
-              <a:t>Power is the biggest risk, so the project has to bring its own</a:t>
+              <a:t>For Grant, everything turns on full power by late 2029 at near today's price</a:t>
             </a:r>
           </a:p>
         </p:txBody>
@@ -14923,7 +14018,7 @@
                 </a:solidFill>
                 <a:latin typeface="Arial"/>
               </a:rPr>
-              <a:t>Grant PUD data center FAQ, August 2026. Risk ratings from research/risk.md. Land check from research/sensitive_land.md (PAD-US 4.1, Census TIGER 2024). Timing from docs/weighting.md.</a:t>
+              <a:t>Grant PUD data center FAQ, August 2026. Plan and ratings from research/implementation.md and research/risk.md. Land check from research/sensitive_land.md (PAD-US 4.1, Census TIGER 2024).</a:t>
             </a:r>
           </a:p>
         </p:txBody>
@@ -14973,7 +14068,7 @@
         </p:nvGraphicFramePr>
         <p:xfrm>
           <a:off x="548640" y="1828799"/>
-          <a:ext cx="5120640" cy="3200400"/>
+          <a:ext cx="4480560" cy="2606040"/>
         </p:xfrm>
         <a:graphic>
           <a:graphicData uri="http://schemas.openxmlformats.org/drawingml/2006/chart">
@@ -14983,54 +14078,14 @@
       </p:graphicFrame>
       <p:sp>
         <p:nvSpPr>
-          <p:cNvPr id="8" name="Risk High"/>
-          <p:cNvSpPr/>
+          <p:cNvPr id="8" name="Timeline title"/>
+          <p:cNvSpPr txBox="1"/>
           <p:nvPr/>
         </p:nvSpPr>
         <p:spPr>
           <a:xfrm>
-            <a:off x="5989320" y="2057399"/>
-            <a:ext cx="1097280" cy="457200"/>
-          </a:xfrm>
-          <a:prstGeom prst="roundRect">
-            <a:avLst>
-              <a:gd name="adj" fmla="val 12000"/>
-            </a:avLst>
-          </a:prstGeom>
-          <a:solidFill>
-            <a:srgbClr val="D9532B"/>
-          </a:solidFill>
-          <a:ln>
-            <a:noFill/>
-          </a:ln>
-        </p:spPr>
-        <p:txBody>
-          <a:bodyPr rtlCol="0" anchor="ctr" wrap="square" lIns="73152" rIns="73152" tIns="36576" bIns="36576"/>
-          <a:lstStyle/>
-          <a:p>
-            <a:pPr algn="ctr"/>
-            <a:r>
-              <a:rPr sz="1500" b="1" i="0">
-                <a:solidFill>
-                  <a:srgbClr val="FFFFFF"/>
-                </a:solidFill>
-                <a:latin typeface="Arial"/>
-              </a:rPr>
-              <a:t>High</a:t>
-            </a:r>
-          </a:p>
-        </p:txBody>
-      </p:sp>
-      <p:sp>
-        <p:nvSpPr>
-          <p:cNvPr id="9" name="TextBox 8"/>
-          <p:cNvSpPr txBox="1"/>
-          <p:nvPr/>
-        </p:nvSpPr>
-        <p:spPr>
-          <a:xfrm>
-            <a:off x="7269480" y="1874519"/>
-            <a:ext cx="4373575" cy="868680"/>
+            <a:off x="5349240" y="1828799"/>
+            <a:ext cx="6293815" cy="365760"/>
           </a:xfrm>
           <a:prstGeom prst="rect">
             <a:avLst/>
@@ -15038,184 +14093,34 @@
           <a:noFill/>
         </p:spPr>
         <p:txBody>
-          <a:bodyPr wrap="square" anchor="ctr" lIns="36576" rIns="36576" tIns="18288" bIns="18288">
+          <a:bodyPr wrap="square" anchor="t" lIns="36576" rIns="36576" tIns="18288" bIns="18288">
             <a:spAutoFit/>
           </a:bodyPr>
           <a:lstStyle/>
           <a:p>
-            <a:pPr algn="l"/>
-            <a:r>
-              <a:rPr sz="1900" b="0" i="0">
+            <a:pPr algn="ctr"/>
+            <a:r>
+              <a:rPr sz="1800" b="1" i="0">
                 <a:solidFill>
                   <a:srgbClr val="111518"/>
                 </a:solidFill>
                 <a:latin typeface="Arial"/>
               </a:rPr>
-              <a:t>Power. The dams are spoken for, and 800 MW of requests wait in line.</a:t>
-            </a:r>
-          </a:p>
-        </p:txBody>
-      </p:sp>
-      <p:sp>
-        <p:nvSpPr>
-          <p:cNvPr id="10" name="Risk Medium"/>
+              <a:t>How the campus phases in</a:t>
+            </a:r>
+          </a:p>
+        </p:txBody>
+      </p:sp>
+      <p:sp>
+        <p:nvSpPr>
+          <p:cNvPr id="9" name="Timeline"/>
           <p:cNvSpPr/>
           <p:nvPr/>
         </p:nvSpPr>
         <p:spPr>
           <a:xfrm>
-            <a:off x="5989320" y="3127247"/>
-            <a:ext cx="1097280" cy="457200"/>
-          </a:xfrm>
-          <a:prstGeom prst="roundRect">
-            <a:avLst>
-              <a:gd name="adj" fmla="val 12000"/>
-            </a:avLst>
-          </a:prstGeom>
-          <a:solidFill>
-            <a:srgbClr val="B86200"/>
-          </a:solidFill>
-          <a:ln>
-            <a:noFill/>
-          </a:ln>
-        </p:spPr>
-        <p:txBody>
-          <a:bodyPr rtlCol="0" anchor="ctr" wrap="square" lIns="73152" rIns="73152" tIns="36576" bIns="36576"/>
-          <a:lstStyle/>
-          <a:p>
-            <a:pPr algn="ctr"/>
-            <a:r>
-              <a:rPr sz="1500" b="1" i="0">
-                <a:solidFill>
-                  <a:srgbClr val="FFFFFF"/>
-                </a:solidFill>
-                <a:latin typeface="Arial"/>
-              </a:rPr>
-              <a:t>Medium</a:t>
-            </a:r>
-          </a:p>
-        </p:txBody>
-      </p:sp>
-      <p:sp>
-        <p:nvSpPr>
-          <p:cNvPr id="11" name="TextBox 10"/>
-          <p:cNvSpPr txBox="1"/>
-          <p:nvPr/>
-        </p:nvSpPr>
-        <p:spPr>
-          <a:xfrm>
-            <a:off x="7269480" y="2944367"/>
-            <a:ext cx="4373575" cy="868680"/>
-          </a:xfrm>
-          <a:prstGeom prst="rect">
-            <a:avLst/>
-          </a:prstGeom>
-          <a:noFill/>
-        </p:spPr>
-        <p:txBody>
-          <a:bodyPr wrap="square" anchor="ctr" lIns="36576" rIns="36576" tIns="18288" bIns="18288">
-            <a:spAutoFit/>
-          </a:bodyPr>
-          <a:lstStyle/>
-          <a:p>
-            <a:pPr algn="l"/>
-            <a:r>
-              <a:rPr sz="1900" b="0" i="0">
-                <a:solidFill>
-                  <a:srgbClr val="111518"/>
-                </a:solidFill>
-                <a:latin typeface="Arial"/>
-              </a:rPr>
-              <a:t>Heat. Days above 95°F rise from 14 to 36 by 2050.</a:t>
-            </a:r>
-          </a:p>
-        </p:txBody>
-      </p:sp>
-      <p:sp>
-        <p:nvSpPr>
-          <p:cNvPr id="12" name="Risk Low"/>
-          <p:cNvSpPr/>
-          <p:nvPr/>
-        </p:nvSpPr>
-        <p:spPr>
-          <a:xfrm>
-            <a:off x="5989320" y="4197095"/>
-            <a:ext cx="1097280" cy="457200"/>
-          </a:xfrm>
-          <a:prstGeom prst="roundRect">
-            <a:avLst>
-              <a:gd name="adj" fmla="val 12000"/>
-            </a:avLst>
-          </a:prstGeom>
-          <a:solidFill>
-            <a:srgbClr val="23804F"/>
-          </a:solidFill>
-          <a:ln>
-            <a:noFill/>
-          </a:ln>
-        </p:spPr>
-        <p:txBody>
-          <a:bodyPr rtlCol="0" anchor="ctr" wrap="square" lIns="73152" rIns="73152" tIns="36576" bIns="36576"/>
-          <a:lstStyle/>
-          <a:p>
-            <a:pPr algn="ctr"/>
-            <a:r>
-              <a:rPr sz="1500" b="1" i="0">
-                <a:solidFill>
-                  <a:srgbClr val="FFFFFF"/>
-                </a:solidFill>
-                <a:latin typeface="Arial"/>
-              </a:rPr>
-              <a:t>Low</a:t>
-            </a:r>
-          </a:p>
-        </p:txBody>
-      </p:sp>
-      <p:sp>
-        <p:nvSpPr>
-          <p:cNvPr id="13" name="TextBox 12"/>
-          <p:cNvSpPr txBox="1"/>
-          <p:nvPr/>
-        </p:nvSpPr>
-        <p:spPr>
-          <a:xfrm>
-            <a:off x="7269480" y="4014215"/>
-            <a:ext cx="4373575" cy="868680"/>
-          </a:xfrm>
-          <a:prstGeom prst="rect">
-            <a:avLst/>
-          </a:prstGeom>
-          <a:noFill/>
-        </p:spPr>
-        <p:txBody>
-          <a:bodyPr wrap="square" anchor="ctr" lIns="36576" rIns="36576" tIns="18288" bIns="18288">
-            <a:spAutoFit/>
-          </a:bodyPr>
-          <a:lstStyle/>
-          <a:p>
-            <a:pPr algn="l"/>
-            <a:r>
-              <a:rPr sz="1900" b="0" i="0">
-                <a:solidFill>
-                  <a:srgbClr val="111518"/>
-                </a:solidFill>
-                <a:latin typeface="Arial"/>
-              </a:rPr>
-              <a:t>Land. No protected land within 5 km, and tribal consultation starts early.</a:t>
-            </a:r>
-          </a:p>
-        </p:txBody>
-      </p:sp>
-      <p:sp>
-        <p:nvSpPr>
-          <p:cNvPr id="14" name="Band"/>
-          <p:cNvSpPr/>
-          <p:nvPr/>
-        </p:nvSpPr>
-        <p:spPr>
-          <a:xfrm>
-            <a:off x="548640" y="5212079"/>
-            <a:ext cx="11094415" cy="822960"/>
+            <a:off x="5532120" y="2724149"/>
+            <a:ext cx="5928055" cy="38100"/>
           </a:xfrm>
           <a:prstGeom prst="rect">
             <a:avLst/>
@@ -15228,253 +14133,23 @@
           </a:ln>
         </p:spPr>
         <p:txBody>
-          <a:bodyPr rtlCol="0" anchor="ctr" wrap="square" lIns="274320" rIns="274320" tIns="36576" bIns="36576"/>
+          <a:bodyPr rtlCol="0" anchor="ctr"/>
           <a:lstStyle/>
           <a:p>
             <a:pPr algn="ctr"/>
-            <a:r>
-              <a:rPr sz="2000" b="1" i="0">
-                <a:solidFill>
-                  <a:srgbClr val="FFFFFF"/>
-                </a:solidFill>
-                <a:latin typeface="Arial"/>
-              </a:rPr>
-              <a:t>The example holds only if full power arrives by about late 2029, near today's price.</a:t>
-            </a:r>
-          </a:p>
-        </p:txBody>
-      </p:sp>
-    </p:spTree>
-  </p:cSld>
-  <p:clrMapOvr>
-    <a:masterClrMapping/>
-  </p:clrMapOvr>
-  <p:transition spd="med">
-    <p:fade/>
-  </p:transition>
-</p:sld>
-</file>
-
-<file path=ppt/slides/slide8.xml><?xml version="1.0" encoding="utf-8"?>
-<p:sld xmlns:a="http://schemas.openxmlformats.org/drawingml/2006/main" xmlns:p="http://schemas.openxmlformats.org/presentationml/2006/main" xmlns:r="http://schemas.openxmlformats.org/officeDocument/2006/relationships">
-  <p:cSld>
-    <p:bg>
-      <p:bgPr>
-        <a:solidFill>
-          <a:srgbClr val="FFFFFF"/>
-        </a:solidFill>
-        <a:effectLst/>
-      </p:bgPr>
-    </p:bg>
-    <p:spTree>
-      <p:nvGrpSpPr>
-        <p:cNvPr id="1" name=""/>
-        <p:cNvGrpSpPr/>
-        <p:nvPr/>
-      </p:nvGrpSpPr>
-      <p:grpSpPr/>
-      <p:sp>
-        <p:nvSpPr>
-          <p:cNvPr id="2" name="Accent"/>
+          </a:p>
+        </p:txBody>
+      </p:sp>
+      <p:sp>
+        <p:nvSpPr>
+          <p:cNvPr id="10" name="Milestone 2027"/>
           <p:cNvSpPr/>
           <p:nvPr/>
         </p:nvSpPr>
         <p:spPr>
           <a:xfrm>
-            <a:off x="548640" y="384048"/>
-            <a:ext cx="457200" cy="64008"/>
-          </a:xfrm>
-          <a:prstGeom prst="rect">
-            <a:avLst/>
-          </a:prstGeom>
-          <a:solidFill>
-            <a:srgbClr val="0B3C6F"/>
-          </a:solidFill>
-          <a:ln>
-            <a:noFill/>
-          </a:ln>
-        </p:spPr>
-        <p:txBody>
-          <a:bodyPr rtlCol="0" anchor="ctr"/>
-          <a:lstStyle/>
-          <a:p>
-            <a:pPr algn="ctr"/>
-          </a:p>
-        </p:txBody>
-      </p:sp>
-      <p:sp>
-        <p:nvSpPr>
-          <p:cNvPr id="3" name="Headline"/>
-          <p:cNvSpPr txBox="1"/>
-          <p:nvPr/>
-        </p:nvSpPr>
-        <p:spPr>
-          <a:xfrm>
-            <a:off x="548640" y="548640"/>
-            <a:ext cx="11094415" cy="1143000"/>
-          </a:xfrm>
-          <a:prstGeom prst="rect">
-            <a:avLst/>
-          </a:prstGeom>
-          <a:noFill/>
-        </p:spPr>
-        <p:txBody>
-          <a:bodyPr wrap="square" anchor="t" lIns="36576" rIns="36576" tIns="18288" bIns="18288">
-            <a:spAutoFit/>
-          </a:bodyPr>
-          <a:lstStyle/>
-          <a:p>
-            <a:pPr algn="l"/>
-            <a:r>
-              <a:rPr sz="3000" b="1" i="0">
-                <a:solidFill>
-                  <a:srgbClr val="111518"/>
-                </a:solidFill>
-                <a:latin typeface="Arial"/>
-              </a:rPr>
-              <a:t>The campus would grow with new transmission and new clean power</a:t>
-            </a:r>
-          </a:p>
-        </p:txBody>
-      </p:sp>
-      <p:sp>
-        <p:nvSpPr>
-          <p:cNvPr id="4" name="Rule"/>
-          <p:cNvSpPr/>
-          <p:nvPr/>
-        </p:nvSpPr>
-        <p:spPr>
-          <a:xfrm>
-            <a:off x="548640" y="6272784"/>
-            <a:ext cx="11094415" cy="9525"/>
-          </a:xfrm>
-          <a:prstGeom prst="rect">
-            <a:avLst/>
-          </a:prstGeom>
-          <a:solidFill>
-            <a:srgbClr val="D3D8D6"/>
-          </a:solidFill>
-          <a:ln>
-            <a:noFill/>
-          </a:ln>
-        </p:spPr>
-        <p:txBody>
-          <a:bodyPr rtlCol="0" anchor="ctr"/>
-          <a:lstStyle/>
-          <a:p>
-            <a:pPr algn="ctr"/>
-          </a:p>
-        </p:txBody>
-      </p:sp>
-      <p:sp>
-        <p:nvSpPr>
-          <p:cNvPr id="5" name="Source line"/>
-          <p:cNvSpPr txBox="1"/>
-          <p:nvPr/>
-        </p:nvSpPr>
-        <p:spPr>
-          <a:xfrm>
-            <a:off x="548640" y="6327648"/>
-            <a:ext cx="10362895" cy="457200"/>
-          </a:xfrm>
-          <a:prstGeom prst="rect">
-            <a:avLst/>
-          </a:prstGeom>
-          <a:noFill/>
-        </p:spPr>
-        <p:txBody>
-          <a:bodyPr wrap="square" anchor="t" lIns="36576" rIns="36576" tIns="18288" bIns="18288">
-            <a:spAutoFit/>
-          </a:bodyPr>
-          <a:lstStyle/>
-          <a:p>
-            <a:pPr algn="l"/>
-            <a:r>
-              <a:rPr sz="1100" b="0" i="0">
-                <a:solidFill>
-                  <a:srgbClr val="5F6A74"/>
-                </a:solidFill>
-                <a:latin typeface="Arial"/>
-              </a:rPr>
-              <a:t>Plan from research/implementation.md (Columbia Basin Herald, Rye Development, RCW 19.405, ASHRAE liquid cooling classes, Ramboll on Odense). Quote from Grant PUD's data center FAQ, August 2026.</a:t>
-            </a:r>
-          </a:p>
-        </p:txBody>
-      </p:sp>
-      <p:sp>
-        <p:nvSpPr>
-          <p:cNvPr id="6" name="Slide number"/>
-          <p:cNvSpPr txBox="1"/>
-          <p:nvPr/>
-        </p:nvSpPr>
-        <p:spPr>
-          <a:xfrm>
-            <a:off x="11002975" y="6327648"/>
-            <a:ext cx="640080" cy="274320"/>
-          </a:xfrm>
-          <a:prstGeom prst="rect">
-            <a:avLst/>
-          </a:prstGeom>
-          <a:noFill/>
-        </p:spPr>
-        <p:txBody>
-          <a:bodyPr wrap="square" anchor="t" lIns="36576" rIns="36576" tIns="18288" bIns="18288">
-            <a:spAutoFit/>
-          </a:bodyPr>
-          <a:lstStyle/>
-          <a:p>
-            <a:pPr algn="r"/>
-            <a:r>
-              <a:rPr sz="1100" b="0" i="0">
-                <a:solidFill>
-                  <a:srgbClr val="5F6A74"/>
-                </a:solidFill>
-                <a:latin typeface="Arial"/>
-              </a:rPr>
-              <a:t>8</a:t>
-            </a:r>
-          </a:p>
-        </p:txBody>
-      </p:sp>
-      <p:sp>
-        <p:nvSpPr>
-          <p:cNvPr id="7" name="Timeline"/>
-          <p:cNvSpPr/>
-          <p:nvPr/>
-        </p:nvSpPr>
-        <p:spPr>
-          <a:xfrm>
-            <a:off x="822960" y="2404109"/>
-            <a:ext cx="10545775" cy="38100"/>
-          </a:xfrm>
-          <a:prstGeom prst="rect">
-            <a:avLst/>
-          </a:prstGeom>
-          <a:solidFill>
-            <a:srgbClr val="0B3C6F"/>
-          </a:solidFill>
-          <a:ln>
-            <a:noFill/>
-          </a:ln>
-        </p:spPr>
-        <p:txBody>
-          <a:bodyPr rtlCol="0" anchor="ctr"/>
-          <a:lstStyle/>
-          <a:p>
-            <a:pPr algn="ctr"/>
-          </a:p>
-        </p:txBody>
-      </p:sp>
-      <p:sp>
-        <p:nvSpPr>
-          <p:cNvPr id="8" name="Milestone 2027"/>
-          <p:cNvSpPr/>
-          <p:nvPr/>
-        </p:nvSpPr>
-        <p:spPr>
-          <a:xfrm>
-            <a:off x="1530065" y="2295143"/>
-            <a:ext cx="256032" cy="256032"/>
+            <a:off x="6017094" y="2624327"/>
+            <a:ext cx="237744" cy="237744"/>
           </a:xfrm>
           <a:prstGeom prst="ellipse">
             <a:avLst/>
@@ -15496,14 +14171,14 @@
       </p:sp>
       <p:sp>
         <p:nvSpPr>
-          <p:cNvPr id="9" name="Year 2027"/>
+          <p:cNvPr id="11" name="Year 2027"/>
           <p:cNvSpPr txBox="1"/>
           <p:nvPr/>
         </p:nvSpPr>
         <p:spPr>
           <a:xfrm>
-            <a:off x="548640" y="1737359"/>
-            <a:ext cx="2218883" cy="457200"/>
+            <a:off x="5349240" y="2194559"/>
+            <a:ext cx="1573453" cy="384048"/>
           </a:xfrm>
           <a:prstGeom prst="rect">
             <a:avLst/>
@@ -15518,7 +14193,7 @@
           <a:p>
             <a:pPr algn="ctr"/>
             <a:r>
-              <a:rPr sz="2400" b="1" i="0">
+              <a:rPr sz="2200" b="1" i="0">
                 <a:solidFill>
                   <a:srgbClr val="0B3C6F"/>
                 </a:solidFill>
@@ -15531,14 +14206,14 @@
       </p:sp>
       <p:sp>
         <p:nvSpPr>
-          <p:cNvPr id="10" name="Milestone text 2027"/>
+          <p:cNvPr id="12" name="Milestone text 2027"/>
           <p:cNvSpPr txBox="1"/>
           <p:nvPr/>
         </p:nvSpPr>
         <p:spPr>
           <a:xfrm>
-            <a:off x="621792" y="2624327"/>
-            <a:ext cx="2072579" cy="777240"/>
+            <a:off x="5394960" y="2926079"/>
+            <a:ext cx="1482013" cy="1097280"/>
           </a:xfrm>
           <a:prstGeom prst="rect">
             <a:avLst/>
@@ -15553,27 +14228,27 @@
           <a:p>
             <a:pPr algn="ctr"/>
             <a:r>
-              <a:rPr sz="1600" b="0" i="0">
+              <a:rPr sz="1500" b="0" i="0">
                 <a:solidFill>
                   <a:srgbClr val="111518"/>
                 </a:solidFill>
                 <a:latin typeface="Arial"/>
               </a:rPr>
-              <a:t>Quincy transmission upgrade, first phase online</a:t>
-            </a:r>
-          </a:p>
-        </p:txBody>
-      </p:sp>
-      <p:sp>
-        <p:nvSpPr>
-          <p:cNvPr id="11" name="Milestone 2029"/>
+              <a:t>Quincy upgrade, first phase online</a:t>
+            </a:r>
+          </a:p>
+        </p:txBody>
+      </p:sp>
+      <p:sp>
+        <p:nvSpPr>
+          <p:cNvPr id="13" name="Milestone 2029"/>
           <p:cNvSpPr/>
           <p:nvPr/>
         </p:nvSpPr>
         <p:spPr>
           <a:xfrm>
-            <a:off x="3748948" y="2295143"/>
-            <a:ext cx="256032" cy="256032"/>
+            <a:off x="7590547" y="2624327"/>
+            <a:ext cx="237744" cy="237744"/>
           </a:xfrm>
           <a:prstGeom prst="ellipse">
             <a:avLst/>
@@ -15595,14 +14270,14 @@
       </p:sp>
       <p:sp>
         <p:nvSpPr>
-          <p:cNvPr id="12" name="Year 2029"/>
+          <p:cNvPr id="14" name="Year 2029"/>
           <p:cNvSpPr txBox="1"/>
           <p:nvPr/>
         </p:nvSpPr>
         <p:spPr>
           <a:xfrm>
-            <a:off x="2767523" y="1737359"/>
-            <a:ext cx="2218883" cy="457200"/>
+            <a:off x="6922693" y="2194559"/>
+            <a:ext cx="1573453" cy="384048"/>
           </a:xfrm>
           <a:prstGeom prst="rect">
             <a:avLst/>
@@ -15617,7 +14292,7 @@
           <a:p>
             <a:pPr algn="ctr"/>
             <a:r>
-              <a:rPr sz="2400" b="1" i="0">
+              <a:rPr sz="2200" b="1" i="0">
                 <a:solidFill>
                   <a:srgbClr val="0B3C6F"/>
                 </a:solidFill>
@@ -15630,14 +14305,14 @@
       </p:sp>
       <p:sp>
         <p:nvSpPr>
-          <p:cNvPr id="13" name="Milestone text 2029"/>
+          <p:cNvPr id="15" name="Milestone text 2029"/>
           <p:cNvSpPr txBox="1"/>
           <p:nvPr/>
         </p:nvSpPr>
         <p:spPr>
           <a:xfrm>
-            <a:off x="2840675" y="2624327"/>
-            <a:ext cx="2072579" cy="777240"/>
+            <a:off x="6968413" y="2926079"/>
+            <a:ext cx="1482013" cy="1097280"/>
           </a:xfrm>
           <a:prstGeom prst="rect">
             <a:avLst/>
@@ -15652,27 +14327,27 @@
           <a:p>
             <a:pPr algn="ctr"/>
             <a:r>
-              <a:rPr sz="1600" b="0" i="0">
+              <a:rPr sz="1500" b="0" i="0">
                 <a:solidFill>
                   <a:srgbClr val="111518"/>
                 </a:solidFill>
                 <a:latin typeface="Arial"/>
               </a:rPr>
-              <a:t>Wanapum to Quincy line, grow toward 300 MW</a:t>
-            </a:r>
-          </a:p>
-        </p:txBody>
-      </p:sp>
-      <p:sp>
-        <p:nvSpPr>
-          <p:cNvPr id="14" name="Milestone 2030"/>
+              <a:t>New line, grow toward 300 MW</a:t>
+            </a:r>
+          </a:p>
+        </p:txBody>
+      </p:sp>
+      <p:sp>
+        <p:nvSpPr>
+          <p:cNvPr id="16" name="Milestone 2030s"/>
           <p:cNvSpPr/>
           <p:nvPr/>
         </p:nvSpPr>
         <p:spPr>
           <a:xfrm>
-            <a:off x="5967831" y="2295143"/>
-            <a:ext cx="256032" cy="256032"/>
+            <a:off x="9164000" y="2624327"/>
+            <a:ext cx="237744" cy="237744"/>
           </a:xfrm>
           <a:prstGeom prst="ellipse">
             <a:avLst/>
@@ -15694,14 +14369,14 @@
       </p:sp>
       <p:sp>
         <p:nvSpPr>
-          <p:cNvPr id="15" name="Year 2030"/>
+          <p:cNvPr id="17" name="Year 2030s"/>
           <p:cNvSpPr txBox="1"/>
           <p:nvPr/>
         </p:nvSpPr>
         <p:spPr>
           <a:xfrm>
-            <a:off x="4986406" y="1737359"/>
-            <a:ext cx="2218883" cy="457200"/>
+            <a:off x="8496146" y="2194559"/>
+            <a:ext cx="1573453" cy="384048"/>
           </a:xfrm>
           <a:prstGeom prst="rect">
             <a:avLst/>
@@ -15716,27 +14391,27 @@
           <a:p>
             <a:pPr algn="ctr"/>
             <a:r>
-              <a:rPr sz="2400" b="1" i="0">
+              <a:rPr sz="2200" b="1" i="0">
                 <a:solidFill>
                   <a:srgbClr val="0B3C6F"/>
                 </a:solidFill>
                 <a:latin typeface="Arial"/>
               </a:rPr>
-              <a:t>2030</a:t>
-            </a:r>
-          </a:p>
-        </p:txBody>
-      </p:sp>
-      <p:sp>
-        <p:nvSpPr>
-          <p:cNvPr id="16" name="Milestone text 2030"/>
+              <a:t>2030s</a:t>
+            </a:r>
+          </a:p>
+        </p:txBody>
+      </p:sp>
+      <p:sp>
+        <p:nvSpPr>
+          <p:cNvPr id="18" name="Milestone text 2030s"/>
           <p:cNvSpPr txBox="1"/>
           <p:nvPr/>
         </p:nvSpPr>
         <p:spPr>
           <a:xfrm>
-            <a:off x="5059558" y="2624327"/>
-            <a:ext cx="2072579" cy="777240"/>
+            <a:off x="8541866" y="2926079"/>
+            <a:ext cx="1482013" cy="1097280"/>
           </a:xfrm>
           <a:prstGeom prst="rect">
             <a:avLst/>
@@ -15751,27 +14426,27 @@
           <a:p>
             <a:pPr algn="ctr"/>
             <a:r>
-              <a:rPr sz="1600" b="0" i="0">
+              <a:rPr sz="1500" b="0" i="0">
                 <a:solidFill>
                   <a:srgbClr val="111518"/>
                 </a:solidFill>
                 <a:latin typeface="Arial"/>
               </a:rPr>
-              <a:t>State law requires carbon-neutral utility sales</a:t>
-            </a:r>
-          </a:p>
-        </p:txBody>
-      </p:sp>
-      <p:sp>
-        <p:nvSpPr>
-          <p:cNvPr id="17" name="Milestone 2030s"/>
+              <a:t>Firm clean power such as pumped storage</a:t>
+            </a:r>
+          </a:p>
+        </p:txBody>
+      </p:sp>
+      <p:sp>
+        <p:nvSpPr>
+          <p:cNvPr id="19" name="Milestone 2045"/>
           <p:cNvSpPr/>
           <p:nvPr/>
         </p:nvSpPr>
         <p:spPr>
           <a:xfrm>
-            <a:off x="8186714" y="2295143"/>
-            <a:ext cx="256032" cy="256032"/>
+            <a:off x="10737453" y="2624327"/>
+            <a:ext cx="237744" cy="237744"/>
           </a:xfrm>
           <a:prstGeom prst="ellipse">
             <a:avLst/>
@@ -15793,14 +14468,14 @@
       </p:sp>
       <p:sp>
         <p:nvSpPr>
-          <p:cNvPr id="18" name="Year 2030s"/>
+          <p:cNvPr id="20" name="Year 2045"/>
           <p:cNvSpPr txBox="1"/>
           <p:nvPr/>
         </p:nvSpPr>
         <p:spPr>
           <a:xfrm>
-            <a:off x="7205289" y="1737359"/>
-            <a:ext cx="2218883" cy="457200"/>
+            <a:off x="10069599" y="2194559"/>
+            <a:ext cx="1573453" cy="384048"/>
           </a:xfrm>
           <a:prstGeom prst="rect">
             <a:avLst/>
@@ -15815,27 +14490,27 @@
           <a:p>
             <a:pPr algn="ctr"/>
             <a:r>
-              <a:rPr sz="2400" b="1" i="0">
+              <a:rPr sz="2200" b="1" i="0">
                 <a:solidFill>
                   <a:srgbClr val="0B3C6F"/>
                 </a:solidFill>
                 <a:latin typeface="Arial"/>
               </a:rPr>
-              <a:t>2030s</a:t>
-            </a:r>
-          </a:p>
-        </p:txBody>
-      </p:sp>
-      <p:sp>
-        <p:nvSpPr>
-          <p:cNvPr id="19" name="Milestone text 2030s"/>
+              <a:t>2045</a:t>
+            </a:r>
+          </a:p>
+        </p:txBody>
+      </p:sp>
+      <p:sp>
+        <p:nvSpPr>
+          <p:cNvPr id="21" name="Milestone text 2045"/>
           <p:cNvSpPr txBox="1"/>
           <p:nvPr/>
         </p:nvSpPr>
         <p:spPr>
           <a:xfrm>
-            <a:off x="7278441" y="2624327"/>
-            <a:ext cx="2072579" cy="777240"/>
+            <a:off x="10115319" y="2926079"/>
+            <a:ext cx="1482013" cy="1097280"/>
           </a:xfrm>
           <a:prstGeom prst="rect">
             <a:avLst/>
@@ -15850,126 +14525,27 @@
           <a:p>
             <a:pPr algn="ctr"/>
             <a:r>
-              <a:rPr sz="1600" b="0" i="0">
+              <a:rPr sz="1500" b="0" i="0">
                 <a:solidFill>
                   <a:srgbClr val="111518"/>
                 </a:solidFill>
                 <a:latin typeface="Arial"/>
               </a:rPr>
-              <a:t>Firm clean power such as pumped storage</a:t>
-            </a:r>
-          </a:p>
-        </p:txBody>
-      </p:sp>
-      <p:sp>
-        <p:nvSpPr>
-          <p:cNvPr id="20" name="Milestone 2045"/>
+              <a:t>State law requires 100% clean power</a:t>
+            </a:r>
+          </a:p>
+        </p:txBody>
+      </p:sp>
+      <p:sp>
+        <p:nvSpPr>
+          <p:cNvPr id="22" name="Card Power, high risk"/>
           <p:cNvSpPr/>
           <p:nvPr/>
         </p:nvSpPr>
         <p:spPr>
           <a:xfrm>
-            <a:off x="10405597" y="2295143"/>
-            <a:ext cx="256032" cy="256032"/>
-          </a:xfrm>
-          <a:prstGeom prst="ellipse">
-            <a:avLst/>
-          </a:prstGeom>
-          <a:solidFill>
-            <a:srgbClr val="4F82BD"/>
-          </a:solidFill>
-          <a:ln>
-            <a:noFill/>
-          </a:ln>
-        </p:spPr>
-        <p:txBody>
-          <a:bodyPr rtlCol="0" anchor="ctr"/>
-          <a:lstStyle/>
-          <a:p>
-            <a:pPr algn="ctr"/>
-          </a:p>
-        </p:txBody>
-      </p:sp>
-      <p:sp>
-        <p:nvSpPr>
-          <p:cNvPr id="21" name="Year 2045"/>
-          <p:cNvSpPr txBox="1"/>
-          <p:nvPr/>
-        </p:nvSpPr>
-        <p:spPr>
-          <a:xfrm>
-            <a:off x="9424172" y="1737359"/>
-            <a:ext cx="2218883" cy="457200"/>
-          </a:xfrm>
-          <a:prstGeom prst="rect">
-            <a:avLst/>
-          </a:prstGeom>
-          <a:noFill/>
-        </p:spPr>
-        <p:txBody>
-          <a:bodyPr wrap="square" anchor="t" lIns="36576" rIns="36576" tIns="18288" bIns="18288">
-            <a:spAutoFit/>
-          </a:bodyPr>
-          <a:lstStyle/>
-          <a:p>
-            <a:pPr algn="ctr"/>
-            <a:r>
-              <a:rPr sz="2400" b="1" i="0">
-                <a:solidFill>
-                  <a:srgbClr val="0B3C6F"/>
-                </a:solidFill>
-                <a:latin typeface="Arial"/>
-              </a:rPr>
-              <a:t>2045</a:t>
-            </a:r>
-          </a:p>
-        </p:txBody>
-      </p:sp>
-      <p:sp>
-        <p:nvSpPr>
-          <p:cNvPr id="22" name="Milestone text 2045"/>
-          <p:cNvSpPr txBox="1"/>
-          <p:nvPr/>
-        </p:nvSpPr>
-        <p:spPr>
-          <a:xfrm>
-            <a:off x="9497324" y="2624327"/>
-            <a:ext cx="2072579" cy="777240"/>
-          </a:xfrm>
-          <a:prstGeom prst="rect">
-            <a:avLst/>
-          </a:prstGeom>
-          <a:noFill/>
-        </p:spPr>
-        <p:txBody>
-          <a:bodyPr wrap="square" anchor="t" lIns="36576" rIns="36576" tIns="18288" bIns="18288">
-            <a:spAutoFit/>
-          </a:bodyPr>
-          <a:lstStyle/>
-          <a:p>
-            <a:pPr algn="ctr"/>
-            <a:r>
-              <a:rPr sz="1600" b="0" i="0">
-                <a:solidFill>
-                  <a:srgbClr val="111518"/>
-                </a:solidFill>
-                <a:latin typeface="Arial"/>
-              </a:rPr>
-              <a:t>State law requires 100% clean retail power</a:t>
-            </a:r>
-          </a:p>
-        </p:txBody>
-      </p:sp>
-      <p:sp>
-        <p:nvSpPr>
-          <p:cNvPr id="23" name="Card Power"/>
-          <p:cNvSpPr/>
-          <p:nvPr/>
-        </p:nvSpPr>
-        <p:spPr>
-          <a:xfrm>
-            <a:off x="548640" y="3566159"/>
-            <a:ext cx="3515258" cy="1325880"/>
+            <a:off x="548640" y="4617719"/>
+            <a:ext cx="3545738" cy="1463040"/>
           </a:xfrm>
           <a:prstGeom prst="rect">
             <a:avLst/>
@@ -15982,50 +14558,50 @@
           </a:ln>
         </p:spPr>
         <p:txBody>
-          <a:bodyPr rtlCol="0" anchor="ctr" wrap="square" lIns="201168" rIns="201168" tIns="36576" bIns="36576"/>
+          <a:bodyPr rtlCol="0" anchor="ctr" wrap="square" lIns="182880" rIns="182880" tIns="36576" bIns="36576"/>
           <a:lstStyle/>
           <a:p>
             <a:pPr algn="l"/>
             <a:r>
               <a:rPr sz="1600" b="1" i="0">
                 <a:solidFill>
-                  <a:srgbClr val="0B3C6F"/>
+                  <a:srgbClr val="D9532B"/>
                 </a:solidFill>
                 <a:latin typeface="Arial"/>
               </a:rPr>
-              <a:t>Power</a:t>
+              <a:t>Power, high risk</a:t>
             </a:r>
           </a:p>
           <a:p>
             <a:pPr algn="l"/>
             <a:r>
-              <a:rPr sz="1900" b="0" i="0">
+              <a:rPr sz="1800" b="0" i="0">
                 <a:solidFill>
                   <a:srgbClr val="111518"/>
                 </a:solidFill>
                 <a:latin typeface="Arial"/>
               </a:rPr>
-              <a:t>About 1 GW of new solar to match yearly use</a:t>
-            </a:r>
-          </a:p>
-        </p:txBody>
-      </p:sp>
-      <p:sp>
-        <p:nvSpPr>
-          <p:cNvPr id="24" name="Card rule"/>
+              <a:t>The dams are spoken for, and 800 MW of requests wait in line.</a:t>
+            </a:r>
+          </a:p>
+        </p:txBody>
+      </p:sp>
+      <p:sp>
+        <p:nvSpPr>
+          <p:cNvPr id="23" name="Card rule"/>
           <p:cNvSpPr/>
           <p:nvPr/>
         </p:nvSpPr>
         <p:spPr>
           <a:xfrm>
-            <a:off x="548640" y="3566159"/>
-            <a:ext cx="3515258" cy="64008"/>
+            <a:off x="548640" y="4617719"/>
+            <a:ext cx="3545738" cy="64008"/>
           </a:xfrm>
           <a:prstGeom prst="rect">
             <a:avLst/>
           </a:prstGeom>
           <a:solidFill>
-            <a:srgbClr val="0B3C6F"/>
+            <a:srgbClr val="D9532B"/>
           </a:solidFill>
           <a:ln>
             <a:noFill/>
@@ -16041,14 +14617,14 @@
       </p:sp>
       <p:sp>
         <p:nvSpPr>
-          <p:cNvPr id="25" name="Card Cooling"/>
+          <p:cNvPr id="24" name="Card Heat, medium risk"/>
           <p:cNvSpPr/>
           <p:nvPr/>
         </p:nvSpPr>
         <p:spPr>
           <a:xfrm>
-            <a:off x="4338218" y="3566159"/>
-            <a:ext cx="3515258" cy="1325880"/>
+            <a:off x="4322978" y="4617719"/>
+            <a:ext cx="3545738" cy="1463040"/>
           </a:xfrm>
           <a:prstGeom prst="rect">
             <a:avLst/>
@@ -16061,50 +14637,50 @@
           </a:ln>
         </p:spPr>
         <p:txBody>
-          <a:bodyPr rtlCol="0" anchor="ctr" wrap="square" lIns="201168" rIns="201168" tIns="36576" bIns="36576"/>
+          <a:bodyPr rtlCol="0" anchor="ctr" wrap="square" lIns="182880" rIns="182880" tIns="36576" bIns="36576"/>
           <a:lstStyle/>
           <a:p>
             <a:pPr algn="l"/>
             <a:r>
               <a:rPr sz="1600" b="1" i="0">
                 <a:solidFill>
-                  <a:srgbClr val="0B3C6F"/>
+                  <a:srgbClr val="B86200"/>
                 </a:solidFill>
                 <a:latin typeface="Arial"/>
               </a:rPr>
-              <a:t>Cooling</a:t>
+              <a:t>Heat, medium risk</a:t>
             </a:r>
           </a:p>
           <a:p>
             <a:pPr algn="l"/>
             <a:r>
-              <a:rPr sz="1900" b="0" i="0">
+              <a:rPr sz="1800" b="0" i="0">
                 <a:solidFill>
                   <a:srgbClr val="111518"/>
                 </a:solidFill>
                 <a:latin typeface="Arial"/>
               </a:rPr>
-              <a:t>Liquid cooling with dry coolers, about 28 million gallons a year</a:t>
-            </a:r>
-          </a:p>
-        </p:txBody>
-      </p:sp>
-      <p:sp>
-        <p:nvSpPr>
-          <p:cNvPr id="26" name="Card rule"/>
+              <a:t>Days above 95°F rise from 14 to 36 by 2050. Dry coolers are sized for that.</a:t>
+            </a:r>
+          </a:p>
+        </p:txBody>
+      </p:sp>
+      <p:sp>
+        <p:nvSpPr>
+          <p:cNvPr id="25" name="Card rule"/>
           <p:cNvSpPr/>
           <p:nvPr/>
         </p:nvSpPr>
         <p:spPr>
           <a:xfrm>
-            <a:off x="4338218" y="3566159"/>
-            <a:ext cx="3515258" cy="64008"/>
+            <a:off x="4322978" y="4617719"/>
+            <a:ext cx="3545738" cy="64008"/>
           </a:xfrm>
           <a:prstGeom prst="rect">
             <a:avLst/>
           </a:prstGeom>
           <a:solidFill>
-            <a:srgbClr val="0B3C6F"/>
+            <a:srgbClr val="B86200"/>
           </a:solidFill>
           <a:ln>
             <a:noFill/>
@@ -16120,14 +14696,14 @@
       </p:sp>
       <p:sp>
         <p:nvSpPr>
-          <p:cNvPr id="27" name="Card Heat"/>
+          <p:cNvPr id="26" name="Card Land, low risk"/>
           <p:cNvSpPr/>
           <p:nvPr/>
         </p:nvSpPr>
         <p:spPr>
           <a:xfrm>
-            <a:off x="8127796" y="3566159"/>
-            <a:ext cx="3515258" cy="1325880"/>
+            <a:off x="8097316" y="4617719"/>
+            <a:ext cx="3545738" cy="1463040"/>
           </a:xfrm>
           <a:prstGeom prst="rect">
             <a:avLst/>
@@ -16140,50 +14716,50 @@
           </a:ln>
         </p:spPr>
         <p:txBody>
-          <a:bodyPr rtlCol="0" anchor="ctr" wrap="square" lIns="201168" rIns="201168" tIns="36576" bIns="36576"/>
+          <a:bodyPr rtlCol="0" anchor="ctr" wrap="square" lIns="182880" rIns="182880" tIns="36576" bIns="36576"/>
           <a:lstStyle/>
           <a:p>
             <a:pPr algn="l"/>
             <a:r>
               <a:rPr sz="1600" b="1" i="0">
                 <a:solidFill>
-                  <a:srgbClr val="0B3C6F"/>
+                  <a:srgbClr val="23804F"/>
                 </a:solidFill>
                 <a:latin typeface="Arial"/>
               </a:rPr>
-              <a:t>Heat</a:t>
+              <a:t>Land, low risk</a:t>
             </a:r>
           </a:p>
           <a:p>
             <a:pPr algn="l"/>
             <a:r>
-              <a:rPr sz="1900" b="0" i="0">
+              <a:rPr sz="1800" b="0" i="0">
                 <a:solidFill>
                   <a:srgbClr val="111518"/>
                 </a:solidFill>
                 <a:latin typeface="Arial"/>
               </a:rPr>
-              <a:t>Warm return water heats a neighboring food processor</a:t>
-            </a:r>
-          </a:p>
-        </p:txBody>
-      </p:sp>
-      <p:sp>
-        <p:nvSpPr>
-          <p:cNvPr id="28" name="Card rule"/>
+              <a:t>A hand check found no protected land within 5 km of Quincy.</a:t>
+            </a:r>
+          </a:p>
+        </p:txBody>
+      </p:sp>
+      <p:sp>
+        <p:nvSpPr>
+          <p:cNvPr id="27" name="Card rule"/>
           <p:cNvSpPr/>
           <p:nvPr/>
         </p:nvSpPr>
         <p:spPr>
           <a:xfrm>
-            <a:off x="8127796" y="3566159"/>
-            <a:ext cx="3515258" cy="64008"/>
+            <a:off x="8097316" y="4617719"/>
+            <a:ext cx="3545738" cy="64008"/>
           </a:xfrm>
           <a:prstGeom prst="rect">
             <a:avLst/>
           </a:prstGeom>
           <a:solidFill>
-            <a:srgbClr val="0B3C6F"/>
+            <a:srgbClr val="23804F"/>
           </a:solidFill>
           <a:ln>
             <a:noFill/>
@@ -16194,115 +14770,6 @@
           <a:lstStyle/>
           <a:p>
             <a:pPr algn="ctr"/>
-          </a:p>
-        </p:txBody>
-      </p:sp>
-      <p:sp>
-        <p:nvSpPr>
-          <p:cNvPr id="29" name="Quote"/>
-          <p:cNvSpPr/>
-          <p:nvPr/>
-        </p:nvSpPr>
-        <p:spPr>
-          <a:xfrm>
-            <a:off x="548640" y="5029199"/>
-            <a:ext cx="11094415" cy="1051560"/>
-          </a:xfrm>
-          <a:prstGeom prst="rect">
-            <a:avLst/>
-          </a:prstGeom>
-          <a:solidFill>
-            <a:srgbClr val="F3F5F4"/>
-          </a:solidFill>
-          <a:ln>
-            <a:noFill/>
-          </a:ln>
-        </p:spPr>
-        <p:txBody>
-          <a:bodyPr rtlCol="0" anchor="ctr"/>
-          <a:lstStyle/>
-          <a:p>
-            <a:pPr algn="ctr"/>
-          </a:p>
-        </p:txBody>
-      </p:sp>
-      <p:sp>
-        <p:nvSpPr>
-          <p:cNvPr id="30" name="Quote bar"/>
-          <p:cNvSpPr/>
-          <p:nvPr/>
-        </p:nvSpPr>
-        <p:spPr>
-          <a:xfrm>
-            <a:off x="548640" y="5029199"/>
-            <a:ext cx="73152" cy="1051560"/>
-          </a:xfrm>
-          <a:prstGeom prst="rect">
-            <a:avLst/>
-          </a:prstGeom>
-          <a:solidFill>
-            <a:srgbClr val="0B3C6F"/>
-          </a:solidFill>
-          <a:ln>
-            <a:noFill/>
-          </a:ln>
-        </p:spPr>
-        <p:txBody>
-          <a:bodyPr rtlCol="0" anchor="ctr"/>
-          <a:lstStyle/>
-          <a:p>
-            <a:pPr algn="ctr"/>
-          </a:p>
-        </p:txBody>
-      </p:sp>
-      <p:sp>
-        <p:nvSpPr>
-          <p:cNvPr id="31" name="Quote text"/>
-          <p:cNvSpPr txBox="1"/>
-          <p:nvPr/>
-        </p:nvSpPr>
-        <p:spPr>
-          <a:xfrm>
-            <a:off x="822960" y="5120639"/>
-            <a:ext cx="10637215" cy="868680"/>
-          </a:xfrm>
-          <a:prstGeom prst="rect">
-            <a:avLst/>
-          </a:prstGeom>
-          <a:noFill/>
-        </p:spPr>
-        <p:txBody>
-          <a:bodyPr wrap="square" anchor="ctr" lIns="36576" rIns="36576" tIns="18288" bIns="18288">
-            <a:spAutoFit/>
-          </a:bodyPr>
-          <a:lstStyle/>
-          <a:p>
-            <a:pPr algn="l"/>
-            <a:r>
-              <a:rPr sz="1700" b="0" i="0">
-                <a:solidFill>
-                  <a:srgbClr val="111518"/>
-                </a:solidFill>
-                <a:latin typeface="Arial"/>
-              </a:rPr>
-              <a:t>“Large power users, including data centers, are responsible for paying the costs of additional generation, transmission, and distribution infrastructure needed specifically to serve their loads.”</a:t>
-            </a:r>
-          </a:p>
-          <a:p>
-            <a:pPr algn="l">
-              <a:spcBef>
-                <a:spcPts val="600"/>
-              </a:spcBef>
-            </a:pPr>
-            <a:r>
-              <a:rPr sz="1400" b="1" i="0">
-                <a:solidFill>
-                  <a:srgbClr val="46505A"/>
-                </a:solidFill>
-                <a:latin typeface="Arial"/>
-              </a:rPr>
-              <a:t>Grant County PUD, Aug. 2026</a:t>
-            </a:r>
           </a:p>
         </p:txBody>
       </p:sp>
@@ -16351,7 +14818,7 @@
                                           </p:stCondLst>
                                         </p:cTn>
                                         <p:tgtEl>
-                                          <p:spTgt spid="8"/>
+                                          <p:spTgt spid="10"/>
                                         </p:tgtEl>
                                         <p:attrNameLst>
                                           <p:attrName>style.visibility</p:attrName>
@@ -16365,7 +14832,7 @@
                                       <p:cBhvr>
                                         <p:cTn id="7" dur="450"/>
                                         <p:tgtEl>
-                                          <p:spTgt spid="8"/>
+                                          <p:spTgt spid="10"/>
                                         </p:tgtEl>
                                       </p:cBhvr>
                                     </p:animEffect>
@@ -16386,7 +14853,7 @@
                                           </p:stCondLst>
                                         </p:cTn>
                                         <p:tgtEl>
-                                          <p:spTgt spid="9"/>
+                                          <p:spTgt spid="11"/>
                                         </p:tgtEl>
                                         <p:attrNameLst>
                                           <p:attrName>style.visibility</p:attrName>
@@ -16400,7 +14867,7 @@
                                       <p:cBhvr>
                                         <p:cTn id="10" dur="450"/>
                                         <p:tgtEl>
-                                          <p:spTgt spid="9"/>
+                                          <p:spTgt spid="11"/>
                                         </p:tgtEl>
                                       </p:cBhvr>
                                     </p:animEffect>
@@ -16421,7 +14888,7 @@
                                           </p:stCondLst>
                                         </p:cTn>
                                         <p:tgtEl>
-                                          <p:spTgt spid="10"/>
+                                          <p:spTgt spid="12"/>
                                         </p:tgtEl>
                                         <p:attrNameLst>
                                           <p:attrName>style.visibility</p:attrName>
@@ -16435,7 +14902,7 @@
                                       <p:cBhvr>
                                         <p:cTn id="13" dur="450"/>
                                         <p:tgtEl>
-                                          <p:spTgt spid="10"/>
+                                          <p:spTgt spid="12"/>
                                         </p:tgtEl>
                                       </p:cBhvr>
                                     </p:animEffect>
@@ -16465,7 +14932,7 @@
                                           </p:stCondLst>
                                         </p:cTn>
                                         <p:tgtEl>
-                                          <p:spTgt spid="11"/>
+                                          <p:spTgt spid="13"/>
                                         </p:tgtEl>
                                         <p:attrNameLst>
                                           <p:attrName>style.visibility</p:attrName>
@@ -16479,7 +14946,7 @@
                                       <p:cBhvr>
                                         <p:cTn id="17" dur="450"/>
                                         <p:tgtEl>
-                                          <p:spTgt spid="11"/>
+                                          <p:spTgt spid="13"/>
                                         </p:tgtEl>
                                       </p:cBhvr>
                                     </p:animEffect>
@@ -16500,7 +14967,7 @@
                                           </p:stCondLst>
                                         </p:cTn>
                                         <p:tgtEl>
-                                          <p:spTgt spid="12"/>
+                                          <p:spTgt spid="14"/>
                                         </p:tgtEl>
                                         <p:attrNameLst>
                                           <p:attrName>style.visibility</p:attrName>
@@ -16514,7 +14981,7 @@
                                       <p:cBhvr>
                                         <p:cTn id="20" dur="450"/>
                                         <p:tgtEl>
-                                          <p:spTgt spid="12"/>
+                                          <p:spTgt spid="14"/>
                                         </p:tgtEl>
                                       </p:cBhvr>
                                     </p:animEffect>
@@ -16535,7 +15002,7 @@
                                           </p:stCondLst>
                                         </p:cTn>
                                         <p:tgtEl>
-                                          <p:spTgt spid="13"/>
+                                          <p:spTgt spid="15"/>
                                         </p:tgtEl>
                                         <p:attrNameLst>
                                           <p:attrName>style.visibility</p:attrName>
@@ -16549,7 +15016,7 @@
                                       <p:cBhvr>
                                         <p:cTn id="23" dur="450"/>
                                         <p:tgtEl>
-                                          <p:spTgt spid="13"/>
+                                          <p:spTgt spid="15"/>
                                         </p:tgtEl>
                                       </p:cBhvr>
                                     </p:animEffect>
@@ -16579,7 +15046,7 @@
                                           </p:stCondLst>
                                         </p:cTn>
                                         <p:tgtEl>
-                                          <p:spTgt spid="14"/>
+                                          <p:spTgt spid="16"/>
                                         </p:tgtEl>
                                         <p:attrNameLst>
                                           <p:attrName>style.visibility</p:attrName>
@@ -16593,7 +15060,7 @@
                                       <p:cBhvr>
                                         <p:cTn id="27" dur="450"/>
                                         <p:tgtEl>
-                                          <p:spTgt spid="14"/>
+                                          <p:spTgt spid="16"/>
                                         </p:tgtEl>
                                       </p:cBhvr>
                                     </p:animEffect>
@@ -16614,7 +15081,7 @@
                                           </p:stCondLst>
                                         </p:cTn>
                                         <p:tgtEl>
-                                          <p:spTgt spid="15"/>
+                                          <p:spTgt spid="17"/>
                                         </p:tgtEl>
                                         <p:attrNameLst>
                                           <p:attrName>style.visibility</p:attrName>
@@ -16628,7 +15095,7 @@
                                       <p:cBhvr>
                                         <p:cTn id="30" dur="450"/>
                                         <p:tgtEl>
-                                          <p:spTgt spid="15"/>
+                                          <p:spTgt spid="17"/>
                                         </p:tgtEl>
                                       </p:cBhvr>
                                     </p:animEffect>
@@ -16649,7 +15116,7 @@
                                           </p:stCondLst>
                                         </p:cTn>
                                         <p:tgtEl>
-                                          <p:spTgt spid="16"/>
+                                          <p:spTgt spid="18"/>
                                         </p:tgtEl>
                                         <p:attrNameLst>
                                           <p:attrName>style.visibility</p:attrName>
@@ -16663,7 +15130,7 @@
                                       <p:cBhvr>
                                         <p:cTn id="33" dur="450"/>
                                         <p:tgtEl>
-                                          <p:spTgt spid="16"/>
+                                          <p:spTgt spid="18"/>
                                         </p:tgtEl>
                                       </p:cBhvr>
                                     </p:animEffect>
@@ -16693,7 +15160,7 @@
                                           </p:stCondLst>
                                         </p:cTn>
                                         <p:tgtEl>
-                                          <p:spTgt spid="17"/>
+                                          <p:spTgt spid="19"/>
                                         </p:tgtEl>
                                         <p:attrNameLst>
                                           <p:attrName>style.visibility</p:attrName>
@@ -16707,7 +15174,7 @@
                                       <p:cBhvr>
                                         <p:cTn id="37" dur="450"/>
                                         <p:tgtEl>
-                                          <p:spTgt spid="17"/>
+                                          <p:spTgt spid="19"/>
                                         </p:tgtEl>
                                       </p:cBhvr>
                                     </p:animEffect>
@@ -16728,7 +15195,7 @@
                                           </p:stCondLst>
                                         </p:cTn>
                                         <p:tgtEl>
-                                          <p:spTgt spid="18"/>
+                                          <p:spTgt spid="20"/>
                                         </p:tgtEl>
                                         <p:attrNameLst>
                                           <p:attrName>style.visibility</p:attrName>
@@ -16742,7 +15209,7 @@
                                       <p:cBhvr>
                                         <p:cTn id="40" dur="450"/>
                                         <p:tgtEl>
-                                          <p:spTgt spid="18"/>
+                                          <p:spTgt spid="20"/>
                                         </p:tgtEl>
                                       </p:cBhvr>
                                     </p:animEffect>
@@ -16763,7 +15230,7 @@
                                           </p:stCondLst>
                                         </p:cTn>
                                         <p:tgtEl>
-                                          <p:spTgt spid="19"/>
+                                          <p:spTgt spid="21"/>
                                         </p:tgtEl>
                                         <p:attrNameLst>
                                           <p:attrName>style.visibility</p:attrName>
@@ -16777,121 +15244,7 @@
                                       <p:cBhvr>
                                         <p:cTn id="43" dur="450"/>
                                         <p:tgtEl>
-                                          <p:spTgt spid="19"/>
-                                        </p:tgtEl>
-                                      </p:cBhvr>
-                                    </p:animEffect>
-                                  </p:childTnLst>
-                                </p:cTn>
-                              </p:par>
-                            </p:childTnLst>
-                          </p:cTn>
-                        </p:par>
-                        <p:par>
-                          <p:cTn id="44" fill="hold">
-                            <p:stCondLst>
-                              <p:cond delay="2100"/>
-                            </p:stCondLst>
-                            <p:childTnLst>
-                              <p:par>
-                                <p:cTn id="45" presetID="10" presetClass="entr" presetSubtype="0" fill="hold" grpId="0" nodeType="afterEffect">
-                                  <p:stCondLst>
-                                    <p:cond delay="0"/>
-                                  </p:stCondLst>
-                                  <p:childTnLst>
-                                    <p:set>
-                                      <p:cBhvr>
-                                        <p:cTn id="46" dur="1" fill="hold">
-                                          <p:stCondLst>
-                                            <p:cond delay="0"/>
-                                          </p:stCondLst>
-                                        </p:cTn>
-                                        <p:tgtEl>
-                                          <p:spTgt spid="20"/>
-                                        </p:tgtEl>
-                                        <p:attrNameLst>
-                                          <p:attrName>style.visibility</p:attrName>
-                                        </p:attrNameLst>
-                                      </p:cBhvr>
-                                      <p:to>
-                                        <p:strVal val="visible"/>
-                                      </p:to>
-                                    </p:set>
-                                    <p:animEffect transition="in" filter="fade">
-                                      <p:cBhvr>
-                                        <p:cTn id="47" dur="450"/>
-                                        <p:tgtEl>
-                                          <p:spTgt spid="20"/>
-                                        </p:tgtEl>
-                                      </p:cBhvr>
-                                    </p:animEffect>
-                                  </p:childTnLst>
-                                </p:cTn>
-                              </p:par>
-                              <p:par>
-                                <p:cTn id="48" presetID="10" presetClass="entr" presetSubtype="0" fill="hold" grpId="0" nodeType="withEffect">
-                                  <p:stCondLst>
-                                    <p:cond delay="0"/>
-                                  </p:stCondLst>
-                                  <p:childTnLst>
-                                    <p:set>
-                                      <p:cBhvr>
-                                        <p:cTn id="49" dur="1" fill="hold">
-                                          <p:stCondLst>
-                                            <p:cond delay="0"/>
-                                          </p:stCondLst>
-                                        </p:cTn>
-                                        <p:tgtEl>
                                           <p:spTgt spid="21"/>
-                                        </p:tgtEl>
-                                        <p:attrNameLst>
-                                          <p:attrName>style.visibility</p:attrName>
-                                        </p:attrNameLst>
-                                      </p:cBhvr>
-                                      <p:to>
-                                        <p:strVal val="visible"/>
-                                      </p:to>
-                                    </p:set>
-                                    <p:animEffect transition="in" filter="fade">
-                                      <p:cBhvr>
-                                        <p:cTn id="50" dur="450"/>
-                                        <p:tgtEl>
-                                          <p:spTgt spid="21"/>
-                                        </p:tgtEl>
-                                      </p:cBhvr>
-                                    </p:animEffect>
-                                  </p:childTnLst>
-                                </p:cTn>
-                              </p:par>
-                              <p:par>
-                                <p:cTn id="51" presetID="10" presetClass="entr" presetSubtype="0" fill="hold" grpId="0" nodeType="withEffect">
-                                  <p:stCondLst>
-                                    <p:cond delay="0"/>
-                                  </p:stCondLst>
-                                  <p:childTnLst>
-                                    <p:set>
-                                      <p:cBhvr>
-                                        <p:cTn id="52" dur="1" fill="hold">
-                                          <p:stCondLst>
-                                            <p:cond delay="0"/>
-                                          </p:stCondLst>
-                                        </p:cTn>
-                                        <p:tgtEl>
-                                          <p:spTgt spid="22"/>
-                                        </p:tgtEl>
-                                        <p:attrNameLst>
-                                          <p:attrName>style.visibility</p:attrName>
-                                        </p:attrNameLst>
-                                      </p:cBhvr>
-                                      <p:to>
-                                        <p:strVal val="visible"/>
-                                      </p:to>
-                                    </p:set>
-                                    <p:animEffect transition="in" filter="fade">
-                                      <p:cBhvr>
-                                        <p:cTn id="53" dur="450"/>
-                                        <p:tgtEl>
-                                          <p:spTgt spid="22"/>
                                         </p:tgtEl>
                                       </p:cBhvr>
                                     </p:animEffect>
@@ -16926,8 +15279,6 @@
       </p:par>
     </p:tnLst>
     <p:bldLst>
-      <p:bldP spid="8" grpId="0" animBg="1"/>
-      <p:bldP spid="9" grpId="0" animBg="1"/>
       <p:bldP spid="10" grpId="0" animBg="1"/>
       <p:bldP spid="11" grpId="0" animBg="1"/>
       <p:bldP spid="12" grpId="0" animBg="1"/>
@@ -16940,13 +15291,12 @@
       <p:bldP spid="19" grpId="0" animBg="1"/>
       <p:bldP spid="20" grpId="0" animBg="1"/>
       <p:bldP spid="21" grpId="0" animBg="1"/>
-      <p:bldP spid="22" grpId="0" animBg="1"/>
     </p:bldLst>
   </p:timing>
 </p:sld>
 </file>
 
-<file path=ppt/slides/slide9.xml><?xml version="1.0" encoding="utf-8"?>
+<file path=ppt/slides/slide8.xml><?xml version="1.0" encoding="utf-8"?>
 <p:sld xmlns:a="http://schemas.openxmlformats.org/drawingml/2006/main" xmlns:p="http://schemas.openxmlformats.org/presentationml/2006/main" xmlns:r="http://schemas.openxmlformats.org/officeDocument/2006/relationships">
   <p:cSld>
     <p:bg>
@@ -17122,7 +15472,7 @@
                 </a:solidFill>
                 <a:latin typeface="Arial"/>
               </a:rPr>
-              <a:t>9</a:t>
+              <a:t>8</a:t>
             </a:r>
           </a:p>
         </p:txBody>
@@ -17306,6 +15656,387 @@
                 <a:latin typeface="Arial"/>
               </a:rPr>
               <a:t>You set the conditions. The tool ranks every county and explains each result.</a:t>
+            </a:r>
+          </a:p>
+        </p:txBody>
+      </p:sp>
+    </p:spTree>
+  </p:cSld>
+  <p:clrMapOvr>
+    <a:masterClrMapping/>
+  </p:clrMapOvr>
+  <p:transition spd="med">
+    <p:fade/>
+  </p:transition>
+</p:sld>
+</file>
+
+<file path=ppt/slides/slide9.xml><?xml version="1.0" encoding="utf-8"?>
+<p:sld xmlns:a="http://schemas.openxmlformats.org/drawingml/2006/main" xmlns:p="http://schemas.openxmlformats.org/presentationml/2006/main" xmlns:r="http://schemas.openxmlformats.org/officeDocument/2006/relationships">
+  <p:cSld>
+    <p:bg>
+      <p:bgPr>
+        <a:solidFill>
+          <a:srgbClr val="FFFFFF"/>
+        </a:solidFill>
+        <a:effectLst/>
+      </p:bgPr>
+    </p:bg>
+    <p:spTree>
+      <p:nvGrpSpPr>
+        <p:cNvPr id="1" name=""/>
+        <p:cNvGrpSpPr/>
+        <p:nvPr/>
+      </p:nvGrpSpPr>
+      <p:grpSpPr/>
+      <p:sp>
+        <p:nvSpPr>
+          <p:cNvPr id="2" name="Accent"/>
+          <p:cNvSpPr/>
+          <p:nvPr/>
+        </p:nvSpPr>
+        <p:spPr>
+          <a:xfrm>
+            <a:off x="548640" y="384048"/>
+            <a:ext cx="457200" cy="64008"/>
+          </a:xfrm>
+          <a:prstGeom prst="rect">
+            <a:avLst/>
+          </a:prstGeom>
+          <a:solidFill>
+            <a:srgbClr val="0B3C6F"/>
+          </a:solidFill>
+          <a:ln>
+            <a:noFill/>
+          </a:ln>
+        </p:spPr>
+        <p:txBody>
+          <a:bodyPr rtlCol="0" anchor="ctr"/>
+          <a:lstStyle/>
+          <a:p>
+            <a:pPr algn="ctr"/>
+          </a:p>
+        </p:txBody>
+      </p:sp>
+      <p:sp>
+        <p:nvSpPr>
+          <p:cNvPr id="3" name="Headline"/>
+          <p:cNvSpPr txBox="1"/>
+          <p:nvPr/>
+        </p:nvSpPr>
+        <p:spPr>
+          <a:xfrm>
+            <a:off x="548640" y="548640"/>
+            <a:ext cx="11094415" cy="1143000"/>
+          </a:xfrm>
+          <a:prstGeom prst="rect">
+            <a:avLst/>
+          </a:prstGeom>
+          <a:noFill/>
+        </p:spPr>
+        <p:txBody>
+          <a:bodyPr wrap="square" anchor="t" lIns="36576" rIns="36576" tIns="18288" bIns="18288">
+            <a:spAutoFit/>
+          </a:bodyPr>
+          <a:lstStyle/>
+          <a:p>
+            <a:pPr algn="l"/>
+            <a:r>
+              <a:rPr sz="3000" b="1" i="0">
+                <a:solidFill>
+                  <a:srgbClr val="111518"/>
+                </a:solidFill>
+                <a:latin typeface="Arial"/>
+              </a:rPr>
+              <a:t>How our pick changed as we fixed the inputs</a:t>
+            </a:r>
+          </a:p>
+        </p:txBody>
+      </p:sp>
+      <p:sp>
+        <p:nvSpPr>
+          <p:cNvPr id="4" name="Rule"/>
+          <p:cNvSpPr/>
+          <p:nvPr/>
+        </p:nvSpPr>
+        <p:spPr>
+          <a:xfrm>
+            <a:off x="548640" y="6272784"/>
+            <a:ext cx="11094415" cy="9525"/>
+          </a:xfrm>
+          <a:prstGeom prst="rect">
+            <a:avLst/>
+          </a:prstGeom>
+          <a:solidFill>
+            <a:srgbClr val="D3D8D6"/>
+          </a:solidFill>
+          <a:ln>
+            <a:noFill/>
+          </a:ln>
+        </p:spPr>
+        <p:txBody>
+          <a:bodyPr rtlCol="0" anchor="ctr"/>
+          <a:lstStyle/>
+          <a:p>
+            <a:pPr algn="ctr"/>
+          </a:p>
+        </p:txBody>
+      </p:sp>
+      <p:sp>
+        <p:nvSpPr>
+          <p:cNvPr id="5" name="Source line"/>
+          <p:cNvSpPr txBox="1"/>
+          <p:nvPr/>
+        </p:nvSpPr>
+        <p:spPr>
+          <a:xfrm>
+            <a:off x="548640" y="6327648"/>
+            <a:ext cx="10362895" cy="457200"/>
+          </a:xfrm>
+          <a:prstGeom prst="rect">
+            <a:avLst/>
+          </a:prstGeom>
+          <a:noFill/>
+        </p:spPr>
+        <p:txBody>
+          <a:bodyPr wrap="square" anchor="t" lIns="36576" rIns="36576" tIns="18288" bIns="18288">
+            <a:spAutoFit/>
+          </a:bodyPr>
+          <a:lstStyle/>
+          <a:p>
+            <a:pPr algn="l"/>
+            <a:r>
+              <a:rPr sz="1100" b="0" i="0">
+                <a:solidFill>
+                  <a:srgbClr val="5F6A74"/>
+                </a:solidFill>
+                <a:latin typeface="Arial"/>
+              </a:rPr>
+              <a:t>Ranks from docs/figures/facts.json (pick_story). Price rerun in docs/deck_build_log.md step 4. Permitting model results in research/permitting_model.md.</a:t>
+            </a:r>
+          </a:p>
+        </p:txBody>
+      </p:sp>
+      <p:sp>
+        <p:nvSpPr>
+          <p:cNvPr id="6" name="Slide number"/>
+          <p:cNvSpPr txBox="1"/>
+          <p:nvPr/>
+        </p:nvSpPr>
+        <p:spPr>
+          <a:xfrm>
+            <a:off x="11002975" y="6327648"/>
+            <a:ext cx="640080" cy="274320"/>
+          </a:xfrm>
+          <a:prstGeom prst="rect">
+            <a:avLst/>
+          </a:prstGeom>
+          <a:noFill/>
+        </p:spPr>
+        <p:txBody>
+          <a:bodyPr wrap="square" anchor="t" lIns="36576" rIns="36576" tIns="18288" bIns="18288">
+            <a:spAutoFit/>
+          </a:bodyPr>
+          <a:lstStyle/>
+          <a:p>
+            <a:pPr algn="r"/>
+            <a:r>
+              <a:rPr sz="1100" b="0" i="0">
+                <a:solidFill>
+                  <a:srgbClr val="5F6A74"/>
+                </a:solidFill>
+                <a:latin typeface="Arial"/>
+              </a:rPr>
+              <a:t>A1</a:t>
+            </a:r>
+          </a:p>
+        </p:txBody>
+      </p:sp>
+      <p:graphicFrame>
+        <p:nvGraphicFramePr>
+          <p:cNvPr id="7" name="Chart 6"/>
+          <p:cNvGraphicFramePr>
+            <a:graphicFrameLocks noGrp="1"/>
+          </p:cNvGraphicFramePr>
+          <p:nvPr/>
+        </p:nvGraphicFramePr>
+        <p:xfrm>
+          <a:off x="548640" y="2194559"/>
+          <a:ext cx="6309360" cy="3931920"/>
+        </p:xfrm>
+        <a:graphic>
+          <a:graphicData uri="http://schemas.openxmlformats.org/drawingml/2006/chart">
+            <c:chart xmlns:c="http://schemas.openxmlformats.org/drawingml/2006/chart" r:id="rId3"/>
+          </a:graphicData>
+        </a:graphic>
+      </p:graphicFrame>
+      <p:sp>
+        <p:nvSpPr>
+          <p:cNvPr id="8" name="TextBox 7"/>
+          <p:cNvSpPr txBox="1"/>
+          <p:nvPr/>
+        </p:nvSpPr>
+        <p:spPr>
+          <a:xfrm>
+            <a:off x="548640" y="1783079"/>
+            <a:ext cx="6309360" cy="365760"/>
+          </a:xfrm>
+          <a:prstGeom prst="rect">
+            <a:avLst/>
+          </a:prstGeom>
+          <a:noFill/>
+        </p:spPr>
+        <p:txBody>
+          <a:bodyPr wrap="square" anchor="t" lIns="36576" rIns="36576" tIns="18288" bIns="18288">
+            <a:spAutoFit/>
+          </a:bodyPr>
+          <a:lstStyle/>
+          <a:p>
+            <a:pPr algn="ctr"/>
+            <a:r>
+              <a:rPr sz="1800" b="1" i="0">
+                <a:solidFill>
+                  <a:srgbClr val="111518"/>
+                </a:solidFill>
+                <a:latin typeface="Arial"/>
+              </a:rPr>
+              <a:t>Rank at each step, log scale</a:t>
+            </a:r>
+          </a:p>
+        </p:txBody>
+      </p:sp>
+      <p:sp>
+        <p:nvSpPr>
+          <p:cNvPr id="9" name="Bullets"/>
+          <p:cNvSpPr txBox="1"/>
+          <p:nvPr/>
+        </p:nvSpPr>
+        <p:spPr>
+          <a:xfrm>
+            <a:off x="7132320" y="1965959"/>
+            <a:ext cx="4510735" cy="2926080"/>
+          </a:xfrm>
+          <a:prstGeom prst="rect">
+            <a:avLst/>
+          </a:prstGeom>
+          <a:noFill/>
+        </p:spPr>
+        <p:txBody>
+          <a:bodyPr wrap="square" lIns="36576" rIns="36576">
+            <a:spAutoFit/>
+          </a:bodyPr>
+          <a:lstStyle/>
+          <a:p>
+            <a:pPr marL="292608" indent="-292608">
+              <a:lnSpc>
+                <a:spcPct val="105000"/>
+              </a:lnSpc>
+              <a:spcAft>
+                <a:spcPts val="1200"/>
+              </a:spcAft>
+              <a:buClr>
+                <a:srgbClr val="0B3C6F"/>
+              </a:buClr>
+              <a:buSzPct val="100000"/>
+              <a:buFont typeface="Arial"/>
+              <a:buChar char="■"/>
+            </a:pPr>
+            <a:r>
+              <a:rPr sz="1900" b="0" i="0">
+                <a:solidFill>
+                  <a:srgbClr val="111518"/>
+                </a:solidFill>
+                <a:latin typeface="Arial"/>
+              </a:rPr>
+              <a:t>Massachusetts closed a tax break, and Berkshire fell to 27th.</a:t>
+            </a:r>
+          </a:p>
+          <a:p>
+            <a:pPr marL="292608" indent="-292608">
+              <a:lnSpc>
+                <a:spcPct val="105000"/>
+              </a:lnSpc>
+              <a:spcAft>
+                <a:spcPts val="1200"/>
+              </a:spcAft>
+              <a:buClr>
+                <a:srgbClr val="0B3C6F"/>
+              </a:buClr>
+              <a:buSzPct val="100000"/>
+              <a:buFont typeface="Arial"/>
+              <a:buChar char="■"/>
+            </a:pPr>
+            <a:r>
+              <a:rPr sz="1900" b="0" i="0">
+                <a:solidFill>
+                  <a:srgbClr val="111518"/>
+                </a:solidFill>
+                <a:latin typeface="Arial"/>
+              </a:rPr>
+              <a:t>Adding the cost of power moved Grant to first.</a:t>
+            </a:r>
+          </a:p>
+          <a:p>
+            <a:pPr marL="292608" indent="-292608">
+              <a:lnSpc>
+                <a:spcPct val="105000"/>
+              </a:lnSpc>
+              <a:spcAft>
+                <a:spcPts val="1200"/>
+              </a:spcAft>
+              <a:buClr>
+                <a:srgbClr val="0B3C6F"/>
+              </a:buClr>
+              <a:buSzPct val="100000"/>
+              <a:buFont typeface="Arial"/>
+              <a:buChar char="■"/>
+            </a:pPr>
+            <a:r>
+              <a:rPr sz="1900" b="0" i="0">
+                <a:solidFill>
+                  <a:srgbClr val="111518"/>
+                </a:solidFill>
+                <a:latin typeface="Arial"/>
+              </a:rPr>
+              <a:t>Repricing only Washington at BPA's rate drops Grant to 77th.</a:t>
+            </a:r>
+          </a:p>
+        </p:txBody>
+      </p:sp>
+      <p:sp>
+        <p:nvSpPr>
+          <p:cNvPr id="10" name="Dropped"/>
+          <p:cNvSpPr/>
+          <p:nvPr/>
+        </p:nvSpPr>
+        <p:spPr>
+          <a:xfrm>
+            <a:off x="7132320" y="4937759"/>
+            <a:ext cx="4510735" cy="1188720"/>
+          </a:xfrm>
+          <a:prstGeom prst="rect">
+            <a:avLst/>
+          </a:prstGeom>
+          <a:solidFill>
+            <a:srgbClr val="F3F5F4"/>
+          </a:solidFill>
+          <a:ln>
+            <a:noFill/>
+          </a:ln>
+        </p:spPr>
+        <p:txBody>
+          <a:bodyPr rtlCol="0" anchor="ctr" wrap="square" lIns="182880" rIns="182880" tIns="36576" bIns="36576"/>
+          <a:lstStyle/>
+          <a:p>
+            <a:pPr algn="l"/>
+            <a:r>
+              <a:rPr sz="1700" b="0" i="0">
+                <a:solidFill>
+                  <a:srgbClr val="111518"/>
+                </a:solidFill>
+                <a:latin typeface="Arial"/>
+              </a:rPr>
+              <a:t>We also tested a machine-learning model of permitting and dropped it. Out of sample it did no better than chance.</a:t>
             </a:r>
           </a:p>
         </p:txBody>

</xml_diff>